<commit_message>
fix(laporan): pil TPA tampilkan luas terbakar, bantuan air kosong jadi '– liter'
</commit_message>
<xml_diff>
--- a/data/laporan-bnpb/harian-2026-10-28/Laporan Kejadian Bencana Harian 281026.pptx
+++ b/data/laporan-bnpb/harian-2026-10-28/Laporan Kejadian Bencana Harian 281026.pptx
@@ -1944,7 +1944,7 @@
       </p:sp>
       <p:sp>
         <p:nvSpPr>
-          <p:cNvPr id="568" name="T"/>
+          <p:cNvPr id="569" name="T"/>
           <p:cNvSpPr txBox="1"/>
           <p:nvPr/>
         </p:nvSpPr>
@@ -9281,8 +9281,8 @@
         </p:nvSpPr>
         <p:spPr>
           <a:xfrm>
-            <a:off x="10545775" y="4935114"/>
-            <a:ext cx="932688" cy="97300"/>
+            <a:off x="10680000" y="4935114"/>
+            <a:ext cx="500000" cy="97300"/>
           </a:xfrm>
           <a:prstGeom prst="rect">
             <a:avLst/>
@@ -9293,11 +9293,11 @@
           <a:bodyPr wrap="none" lIns="0" tIns="0" rIns="0" bIns="0" anchor="ctr"/>
           <a:lstStyle/>
           <a:p>
-            <a:pPr algn="ctr">
-              <a:buNone/>
-            </a:pPr>
-            <a:r>
-              <a:rPr lang="id-ID" sz="700" b="1" dirty="0">
+            <a:pPr algn="r">
+              <a:buNone/>
+            </a:pPr>
+            <a:r>
+              <a:rPr lang="id-ID" sz="720" b="1" dirty="0">
                 <a:solidFill>
                   <a:srgbClr val="A23B2A"/>
                 </a:solidFill>
@@ -9305,15 +9305,53 @@
                 <a:ea typeface="Roboto"/>
                 <a:cs typeface="Roboto"/>
               </a:rPr>
-              <a:t>penanganan</a:t>
-            </a:r>
-            <a:endParaRPr lang="id-ID" sz="620"/>
+              <a:t>± 15,5</a:t>
+            </a:r>
+            <a:endParaRPr lang="id-ID" sz="720"/>
+          </a:p>
+        </p:txBody>
+      </p:sp>
+      <p:sp>
+        <p:nvSpPr>
+          <p:cNvPr id="536" name="T"/>
+          <p:cNvSpPr txBox="1"/>
+          <p:nvPr/>
+        </p:nvSpPr>
+        <p:spPr>
+          <a:xfrm>
+            <a:off x="11201600" y="4935114"/>
+            <a:ext cx="300000" cy="97300"/>
+          </a:xfrm>
+          <a:prstGeom prst="rect">
+            <a:avLst/>
+          </a:prstGeom>
+          <a:noFill/>
+        </p:spPr>
+        <p:txBody>
+          <a:bodyPr wrap="none" lIns="0" tIns="0" rIns="0" bIns="0" anchor="ctr"/>
+          <a:lstStyle/>
+          <a:p>
+            <a:pPr algn="l">
+              <a:buNone/>
+            </a:pPr>
+            <a:r>
+              <a:rPr lang="id-ID" sz="720" b="1" dirty="0">
+                <a:solidFill>
+                  <a:srgbClr val="A23B2A"/>
+                </a:solidFill>
+                <a:latin typeface="Roboto"/>
+                <a:ea typeface="Roboto"/>
+                <a:cs typeface="Roboto"/>
+              </a:rPr>
+              <a:t>ha</a:t>
+            </a:r>
+            <a:endParaRPr lang="id-ID" sz="720"/>
           </a:p>
         </p:txBody>
       </p:sp>
       <p:cxnSp>
         <p:nvCxnSpPr>
-          <p:cNvPr id="536" name="L"/>
+          <p:cNvPr id="537" name="L"/>
           <p:cNvCxnSpPr/>
           <p:nvPr/>
         </p:nvCxnSpPr>
@@ -9334,7 +9372,7 @@
       </p:cxnSp>
       <p:sp>
         <p:nvSpPr>
-          <p:cNvPr id="537" name="K"/>
+          <p:cNvPr id="538" name="K"/>
           <p:cNvSpPr/>
           <p:nvPr/>
         </p:nvSpPr>
@@ -9356,7 +9394,7 @@
       </p:sp>
       <p:pic>
         <p:nvPicPr>
-          <p:cNvPr id="538" name="G"/>
+          <p:cNvPr id="539" name="G"/>
           <p:cNvPicPr>
             <a:picLocks noChangeAspect="1"/>
           </p:cNvPicPr>
@@ -9380,7 +9418,7 @@
       </p:pic>
       <p:sp>
         <p:nvSpPr>
-          <p:cNvPr id="539" name="T"/>
+          <p:cNvPr id="540" name="T"/>
           <p:cNvSpPr txBox="1"/>
           <p:nvPr/>
         </p:nvSpPr>
@@ -9418,7 +9456,7 @@
       </p:sp>
       <p:sp>
         <p:nvSpPr>
-          <p:cNvPr id="540" name="K"/>
+          <p:cNvPr id="541" name="K"/>
           <p:cNvSpPr/>
           <p:nvPr/>
         </p:nvSpPr>
@@ -9442,7 +9480,7 @@
       </p:sp>
       <p:pic>
         <p:nvPicPr>
-          <p:cNvPr id="541" name="G"/>
+          <p:cNvPr id="542" name="G"/>
           <p:cNvPicPr>
             <a:picLocks noChangeAspect="1"/>
           </p:cNvPicPr>
@@ -9466,7 +9504,7 @@
       </p:pic>
       <p:sp>
         <p:nvSpPr>
-          <p:cNvPr id="542" name="T"/>
+          <p:cNvPr id="543" name="T"/>
           <p:cNvSpPr txBox="1"/>
           <p:nvPr/>
         </p:nvSpPr>
@@ -9504,7 +9542,7 @@
       </p:sp>
       <p:sp>
         <p:nvSpPr>
-          <p:cNvPr id="543" name="T"/>
+          <p:cNvPr id="544" name="T"/>
           <p:cNvSpPr txBox="1"/>
           <p:nvPr/>
         </p:nvSpPr>
@@ -9542,7 +9580,7 @@
       </p:sp>
       <p:cxnSp>
         <p:nvCxnSpPr>
-          <p:cNvPr id="544" name="L"/>
+          <p:cNvPr id="545" name="L"/>
           <p:cNvCxnSpPr/>
           <p:nvPr/>
         </p:nvCxnSpPr>
@@ -9563,7 +9601,7 @@
       </p:cxnSp>
       <p:sp>
         <p:nvSpPr>
-          <p:cNvPr id="545" name="K"/>
+          <p:cNvPr id="546" name="K"/>
           <p:cNvSpPr/>
           <p:nvPr/>
         </p:nvSpPr>
@@ -9585,7 +9623,7 @@
       </p:sp>
       <p:pic>
         <p:nvPicPr>
-          <p:cNvPr id="546" name="G"/>
+          <p:cNvPr id="547" name="G"/>
           <p:cNvPicPr>
             <a:picLocks noChangeAspect="1"/>
           </p:cNvPicPr>
@@ -9609,7 +9647,7 @@
       </p:pic>
       <p:sp>
         <p:nvSpPr>
-          <p:cNvPr id="547" name="T"/>
+          <p:cNvPr id="548" name="T"/>
           <p:cNvSpPr txBox="1"/>
           <p:nvPr/>
         </p:nvSpPr>
@@ -9658,7 +9696,7 @@
       </p:sp>
       <p:sp>
         <p:nvSpPr>
-          <p:cNvPr id="548" name="K"/>
+          <p:cNvPr id="549" name="K"/>
           <p:cNvSpPr/>
           <p:nvPr/>
         </p:nvSpPr>
@@ -9682,7 +9720,7 @@
       </p:sp>
       <p:pic>
         <p:nvPicPr>
-          <p:cNvPr id="549" name="G"/>
+          <p:cNvPr id="550" name="G"/>
           <p:cNvPicPr>
             <a:picLocks noChangeAspect="1"/>
           </p:cNvPicPr>
@@ -9706,7 +9744,7 @@
       </p:pic>
       <p:sp>
         <p:nvSpPr>
-          <p:cNvPr id="550" name="T"/>
+          <p:cNvPr id="551" name="T"/>
           <p:cNvSpPr txBox="1"/>
           <p:nvPr/>
         </p:nvSpPr>
@@ -9744,7 +9782,7 @@
       </p:sp>
       <p:sp>
         <p:nvSpPr>
-          <p:cNvPr id="551" name="T"/>
+          <p:cNvPr id="552" name="T"/>
           <p:cNvSpPr txBox="1"/>
           <p:nvPr/>
         </p:nvSpPr>
@@ -9782,7 +9820,7 @@
       </p:sp>
       <p:sp>
         <p:nvSpPr>
-          <p:cNvPr id="552" name="K"/>
+          <p:cNvPr id="553" name="K"/>
           <p:cNvSpPr/>
           <p:nvPr/>
         </p:nvSpPr>
@@ -9806,7 +9844,7 @@
       </p:sp>
       <p:sp>
         <p:nvSpPr>
-          <p:cNvPr id="553" name="T"/>
+          <p:cNvPr id="554" name="T"/>
           <p:cNvSpPr txBox="1"/>
           <p:nvPr/>
         </p:nvSpPr>
@@ -9844,7 +9882,7 @@
       </p:sp>
       <p:sp>
         <p:nvSpPr>
-          <p:cNvPr id="554" name="K"/>
+          <p:cNvPr id="555" name="K"/>
           <p:cNvSpPr/>
           <p:nvPr/>
         </p:nvSpPr>
@@ -9866,7 +9904,7 @@
       </p:sp>
       <p:pic>
         <p:nvPicPr>
-          <p:cNvPr id="555" name="G"/>
+          <p:cNvPr id="556" name="G"/>
           <p:cNvPicPr>
             <a:picLocks noChangeAspect="1"/>
           </p:cNvPicPr>
@@ -9890,7 +9928,7 @@
       </p:pic>
       <p:sp>
         <p:nvSpPr>
-          <p:cNvPr id="556" name="T"/>
+          <p:cNvPr id="557" name="T"/>
           <p:cNvSpPr txBox="1"/>
           <p:nvPr/>
         </p:nvSpPr>
@@ -9928,7 +9966,7 @@
       </p:sp>
       <p:sp>
         <p:nvSpPr>
-          <p:cNvPr id="557" name="T"/>
+          <p:cNvPr id="558" name="T"/>
           <p:cNvSpPr txBox="1"/>
           <p:nvPr/>
         </p:nvSpPr>
@@ -9983,7 +10021,7 @@
       </p:sp>
       <p:cxnSp>
         <p:nvCxnSpPr>
-          <p:cNvPr id="558" name="L"/>
+          <p:cNvPr id="559" name="L"/>
           <p:cNvCxnSpPr/>
           <p:nvPr/>
         </p:nvCxnSpPr>
@@ -10004,7 +10042,7 @@
       </p:cxnSp>
       <p:sp>
         <p:nvSpPr>
-          <p:cNvPr id="559" name="K"/>
+          <p:cNvPr id="560" name="K"/>
           <p:cNvSpPr/>
           <p:nvPr/>
         </p:nvSpPr>
@@ -10026,7 +10064,7 @@
       </p:sp>
       <p:pic>
         <p:nvPicPr>
-          <p:cNvPr id="560" name="G"/>
+          <p:cNvPr id="561" name="G"/>
           <p:cNvPicPr>
             <a:picLocks noChangeAspect="1"/>
           </p:cNvPicPr>
@@ -10050,7 +10088,7 @@
       </p:pic>
       <p:sp>
         <p:nvSpPr>
-          <p:cNvPr id="561" name="T"/>
+          <p:cNvPr id="562" name="T"/>
           <p:cNvSpPr txBox="1"/>
           <p:nvPr/>
         </p:nvSpPr>
@@ -10088,7 +10126,7 @@
       </p:sp>
       <p:sp>
         <p:nvSpPr>
-          <p:cNvPr id="562" name="T"/>
+          <p:cNvPr id="563" name="T"/>
           <p:cNvSpPr txBox="1"/>
           <p:nvPr/>
         </p:nvSpPr>
@@ -10143,7 +10181,7 @@
       </p:sp>
       <p:cxnSp>
         <p:nvCxnSpPr>
-          <p:cNvPr id="563" name="L"/>
+          <p:cNvPr id="564" name="L"/>
           <p:cNvCxnSpPr/>
           <p:nvPr/>
         </p:nvCxnSpPr>
@@ -10164,7 +10202,7 @@
       </p:cxnSp>
       <p:sp>
         <p:nvSpPr>
-          <p:cNvPr id="564" name="K"/>
+          <p:cNvPr id="565" name="K"/>
           <p:cNvSpPr/>
           <p:nvPr/>
         </p:nvSpPr>
@@ -10186,7 +10224,7 @@
       </p:sp>
       <p:pic>
         <p:nvPicPr>
-          <p:cNvPr id="565" name="G"/>
+          <p:cNvPr id="566" name="G"/>
           <p:cNvPicPr>
             <a:picLocks noChangeAspect="1"/>
           </p:cNvPicPr>
@@ -10210,7 +10248,7 @@
       </p:pic>
       <p:sp>
         <p:nvSpPr>
-          <p:cNvPr id="566" name="T"/>
+          <p:cNvPr id="567" name="T"/>
           <p:cNvSpPr txBox="1"/>
           <p:nvPr/>
         </p:nvSpPr>
@@ -10248,7 +10286,7 @@
       </p:sp>
       <p:sp>
         <p:nvSpPr>
-          <p:cNvPr id="567" name="T"/>
+          <p:cNvPr id="568" name="T"/>
           <p:cNvSpPr txBox="1"/>
           <p:nvPr/>
         </p:nvSpPr>
@@ -10476,7 +10514,7 @@
       </p:sp>
       <p:sp>
         <p:nvSpPr>
-          <p:cNvPr id="790" name="T"/>
+          <p:cNvPr id="791" name="T"/>
           <p:cNvSpPr txBox="1"/>
           <p:nvPr/>
         </p:nvSpPr>
@@ -19295,8 +19333,8 @@
         </p:nvSpPr>
         <p:spPr>
           <a:xfrm>
-            <a:off x="10110000" y="3499866"/>
-            <a:ext cx="650000" cy="164592"/>
+            <a:off x="10120000" y="3499866"/>
+            <a:ext cx="430000" cy="164592"/>
           </a:xfrm>
           <a:prstGeom prst="rect">
             <a:avLst/>
@@ -19307,19 +19345,57 @@
           <a:bodyPr wrap="none" lIns="0" tIns="0" rIns="0" bIns="0" anchor="ctr"/>
           <a:lstStyle/>
           <a:p>
+            <a:pPr algn="r">
+              <a:buNone/>
+            </a:pPr>
+            <a:r>
+              <a:rPr lang="id-ID" sz="720" b="1" dirty="0">
+                <a:solidFill>
+                  <a:srgbClr val="6B7280"/>
+                </a:solidFill>
+                <a:latin typeface="Roboto"/>
+                <a:ea typeface="Roboto"/>
+                <a:cs typeface="Roboto"/>
+              </a:rPr>
+              <a:t>–</a:t>
+            </a:r>
+            <a:endParaRPr lang="id-ID" sz="720"/>
+          </a:p>
+        </p:txBody>
+      </p:sp>
+      <p:sp>
+        <p:nvSpPr>
+          <p:cNvPr id="775" name="T"/>
+          <p:cNvSpPr txBox="1"/>
+          <p:nvPr/>
+        </p:nvSpPr>
+        <p:spPr>
+          <a:xfrm>
+            <a:off x="10571600" y="3499866"/>
+            <a:ext cx="200000" cy="164592"/>
+          </a:xfrm>
+          <a:prstGeom prst="rect">
+            <a:avLst/>
+          </a:prstGeom>
+          <a:noFill/>
+        </p:spPr>
+        <p:txBody>
+          <a:bodyPr wrap="none" lIns="0" tIns="0" rIns="0" bIns="0" anchor="ctr"/>
+          <a:lstStyle/>
+          <a:p>
             <a:pPr algn="l">
               <a:buNone/>
             </a:pPr>
             <a:r>
               <a:rPr lang="id-ID" sz="720" b="1" dirty="0">
                 <a:solidFill>
-                  <a:srgbClr val="1A1A1A"/>
-                </a:solidFill>
-                <a:latin typeface="Roboto"/>
-                <a:ea typeface="Roboto"/>
-                <a:cs typeface="Roboto"/>
-              </a:rPr>
-              <a:t>belum dilaporkan</a:t>
+                  <a:srgbClr val="6B7280"/>
+                </a:solidFill>
+                <a:latin typeface="Roboto"/>
+                <a:ea typeface="Roboto"/>
+                <a:cs typeface="Roboto"/>
+              </a:rPr>
+              <a:t>liter</a:t>
             </a:r>
             <a:endParaRPr lang="id-ID" sz="720"/>
           </a:p>
@@ -19327,7 +19403,7 @@
       </p:sp>
       <p:sp>
         <p:nvSpPr>
-          <p:cNvPr id="775" name="K"/>
+          <p:cNvPr id="776" name="K"/>
           <p:cNvSpPr/>
           <p:nvPr/>
         </p:nvSpPr>
@@ -19353,7 +19429,7 @@
       </p:sp>
       <p:sp>
         <p:nvSpPr>
-          <p:cNvPr id="776" name="K"/>
+          <p:cNvPr id="777" name="K"/>
           <p:cNvSpPr/>
           <p:nvPr/>
         </p:nvSpPr>
@@ -19377,7 +19453,7 @@
       </p:sp>
       <p:sp>
         <p:nvSpPr>
-          <p:cNvPr id="777" name="K"/>
+          <p:cNvPr id="778" name="K"/>
           <p:cNvSpPr/>
           <p:nvPr/>
         </p:nvSpPr>
@@ -19399,7 +19475,7 @@
       </p:sp>
       <p:sp>
         <p:nvSpPr>
-          <p:cNvPr id="778" name="K"/>
+          <p:cNvPr id="779" name="K"/>
           <p:cNvSpPr/>
           <p:nvPr/>
         </p:nvSpPr>
@@ -19421,7 +19497,7 @@
       </p:sp>
       <p:pic>
         <p:nvPicPr>
-          <p:cNvPr id="779" name="G"/>
+          <p:cNvPr id="780" name="G"/>
           <p:cNvPicPr>
             <a:picLocks noChangeAspect="1"/>
           </p:cNvPicPr>
@@ -19445,7 +19521,7 @@
       </p:pic>
       <p:sp>
         <p:nvSpPr>
-          <p:cNvPr id="780" name="T"/>
+          <p:cNvPr id="781" name="T"/>
           <p:cNvSpPr txBox="1"/>
           <p:nvPr/>
         </p:nvSpPr>
@@ -19483,7 +19559,7 @@
       </p:sp>
       <p:sp>
         <p:nvSpPr>
-          <p:cNvPr id="781" name="T"/>
+          <p:cNvPr id="782" name="T"/>
           <p:cNvSpPr txBox="1"/>
           <p:nvPr/>
         </p:nvSpPr>
@@ -21787,7 +21863,7 @@
       </p:sp>
       <p:sp>
         <p:nvSpPr>
-          <p:cNvPr id="782" name="K"/>
+          <p:cNvPr id="783" name="K"/>
           <p:cNvSpPr/>
           <p:nvPr/>
         </p:nvSpPr>
@@ -21811,7 +21887,7 @@
       </p:sp>
       <p:sp>
         <p:nvSpPr>
-          <p:cNvPr id="783" name="T"/>
+          <p:cNvPr id="784" name="T"/>
           <p:cNvSpPr txBox="1"/>
           <p:nvPr/>
         </p:nvSpPr>
@@ -21849,7 +21925,7 @@
       </p:sp>
       <p:sp>
         <p:nvSpPr>
-          <p:cNvPr id="784" name="K"/>
+          <p:cNvPr id="785" name="K"/>
           <p:cNvSpPr/>
           <p:nvPr/>
         </p:nvSpPr>
@@ -21871,7 +21947,7 @@
       </p:sp>
       <p:pic>
         <p:nvPicPr>
-          <p:cNvPr id="785" name="G"/>
+          <p:cNvPr id="786" name="G"/>
           <p:cNvPicPr>
             <a:picLocks noChangeAspect="1"/>
           </p:cNvPicPr>
@@ -21895,7 +21971,7 @@
       </p:pic>
       <p:sp>
         <p:nvSpPr>
-          <p:cNvPr id="786" name="T"/>
+          <p:cNvPr id="787" name="T"/>
           <p:cNvSpPr txBox="1"/>
           <p:nvPr/>
         </p:nvSpPr>
@@ -21933,7 +22009,7 @@
       </p:sp>
       <p:sp>
         <p:nvSpPr>
-          <p:cNvPr id="787" name="K"/>
+          <p:cNvPr id="788" name="K"/>
           <p:cNvSpPr/>
           <p:nvPr/>
         </p:nvSpPr>
@@ -21955,7 +22031,7 @@
       </p:sp>
       <p:pic>
         <p:nvPicPr>
-          <p:cNvPr id="788" name="G"/>
+          <p:cNvPr id="789" name="G"/>
           <p:cNvPicPr>
             <a:picLocks noChangeAspect="1"/>
           </p:cNvPicPr>
@@ -21979,7 +22055,7 @@
       </p:pic>
       <p:sp>
         <p:nvSpPr>
-          <p:cNvPr id="789" name="T"/>
+          <p:cNvPr id="790" name="T"/>
           <p:cNvSpPr txBox="1"/>
           <p:nvPr/>
         </p:nvSpPr>

</xml_diff>

<commit_message>
fix(laporan): bantuan air tanpa data ditulis 'belum ada data'
</commit_message>
<xml_diff>
--- a/data/laporan-bnpb/harian-2026-10-28/Laporan Kejadian Bencana Harian 281026.pptx
+++ b/data/laporan-bnpb/harian-2026-10-28/Laporan Kejadian Bencana Harian 281026.pptx
@@ -1944,7 +1944,7 @@
       </p:sp>
       <p:sp>
         <p:nvSpPr>
-          <p:cNvPr id="569" name="T"/>
+          <p:cNvPr id="570" name="T"/>
           <p:cNvSpPr txBox="1"/>
           <p:nvPr/>
         </p:nvSpPr>
@@ -9281,8 +9281,8 @@
         </p:nvSpPr>
         <p:spPr>
           <a:xfrm>
-            <a:off x="10680000" y="4935114"/>
-            <a:ext cx="500000" cy="97300"/>
+            <a:off x="10650000" y="4935114"/>
+            <a:ext cx="260000" cy="97300"/>
           </a:xfrm>
           <a:prstGeom prst="rect">
             <a:avLst/>
@@ -9293,6 +9293,44 @@
           <a:bodyPr wrap="none" lIns="0" tIns="0" rIns="0" bIns="0" anchor="ctr"/>
           <a:lstStyle/>
           <a:p>
+            <a:pPr algn="l">
+              <a:buNone/>
+            </a:pPr>
+            <a:r>
+              <a:rPr lang="id-ID" sz="720" b="1" dirty="0">
+                <a:solidFill>
+                  <a:srgbClr val="A23B2A"/>
+                </a:solidFill>
+                <a:latin typeface="Roboto"/>
+                <a:ea typeface="Roboto"/>
+                <a:cs typeface="Roboto"/>
+              </a:rPr>
+              <a:t>luas</a:t>
+            </a:r>
+            <a:endParaRPr lang="id-ID" sz="720"/>
+          </a:p>
+        </p:txBody>
+      </p:sp>
+      <p:sp>
+        <p:nvSpPr>
+          <p:cNvPr id="536" name="T"/>
+          <p:cNvSpPr txBox="1"/>
+          <p:nvPr/>
+        </p:nvSpPr>
+        <p:spPr>
+          <a:xfrm>
+            <a:off x="10800000" y="4935114"/>
+            <a:ext cx="380000" cy="97300"/>
+          </a:xfrm>
+          <a:prstGeom prst="rect">
+            <a:avLst/>
+          </a:prstGeom>
+          <a:noFill/>
+        </p:spPr>
+        <p:txBody>
+          <a:bodyPr wrap="none" lIns="0" tIns="0" rIns="0" bIns="0" anchor="ctr"/>
+          <a:lstStyle/>
+          <a:p>
             <a:pPr algn="r">
               <a:buNone/>
             </a:pPr>
@@ -9313,14 +9351,14 @@
       </p:sp>
       <p:sp>
         <p:nvSpPr>
-          <p:cNvPr id="536" name="T"/>
+          <p:cNvPr id="537" name="T"/>
           <p:cNvSpPr txBox="1"/>
           <p:nvPr/>
         </p:nvSpPr>
         <p:spPr>
           <a:xfrm>
             <a:off x="11201600" y="4935114"/>
-            <a:ext cx="300000" cy="97300"/>
+            <a:ext cx="200000" cy="97300"/>
           </a:xfrm>
           <a:prstGeom prst="rect">
             <a:avLst/>
@@ -9351,7 +9389,7 @@
       </p:sp>
       <p:cxnSp>
         <p:nvCxnSpPr>
-          <p:cNvPr id="537" name="L"/>
+          <p:cNvPr id="538" name="L"/>
           <p:cNvCxnSpPr/>
           <p:nvPr/>
         </p:nvCxnSpPr>
@@ -9372,7 +9410,7 @@
       </p:cxnSp>
       <p:sp>
         <p:nvSpPr>
-          <p:cNvPr id="538" name="K"/>
+          <p:cNvPr id="539" name="K"/>
           <p:cNvSpPr/>
           <p:nvPr/>
         </p:nvSpPr>
@@ -9394,7 +9432,7 @@
       </p:sp>
       <p:pic>
         <p:nvPicPr>
-          <p:cNvPr id="539" name="G"/>
+          <p:cNvPr id="540" name="G"/>
           <p:cNvPicPr>
             <a:picLocks noChangeAspect="1"/>
           </p:cNvPicPr>
@@ -9418,7 +9456,7 @@
       </p:pic>
       <p:sp>
         <p:nvSpPr>
-          <p:cNvPr id="540" name="T"/>
+          <p:cNvPr id="541" name="T"/>
           <p:cNvSpPr txBox="1"/>
           <p:nvPr/>
         </p:nvSpPr>
@@ -9456,7 +9494,7 @@
       </p:sp>
       <p:sp>
         <p:nvSpPr>
-          <p:cNvPr id="541" name="K"/>
+          <p:cNvPr id="542" name="K"/>
           <p:cNvSpPr/>
           <p:nvPr/>
         </p:nvSpPr>
@@ -9480,7 +9518,7 @@
       </p:sp>
       <p:pic>
         <p:nvPicPr>
-          <p:cNvPr id="542" name="G"/>
+          <p:cNvPr id="543" name="G"/>
           <p:cNvPicPr>
             <a:picLocks noChangeAspect="1"/>
           </p:cNvPicPr>
@@ -9504,7 +9542,7 @@
       </p:pic>
       <p:sp>
         <p:nvSpPr>
-          <p:cNvPr id="543" name="T"/>
+          <p:cNvPr id="544" name="T"/>
           <p:cNvSpPr txBox="1"/>
           <p:nvPr/>
         </p:nvSpPr>
@@ -9542,7 +9580,7 @@
       </p:sp>
       <p:sp>
         <p:nvSpPr>
-          <p:cNvPr id="544" name="T"/>
+          <p:cNvPr id="545" name="T"/>
           <p:cNvSpPr txBox="1"/>
           <p:nvPr/>
         </p:nvSpPr>
@@ -9580,7 +9618,7 @@
       </p:sp>
       <p:cxnSp>
         <p:nvCxnSpPr>
-          <p:cNvPr id="545" name="L"/>
+          <p:cNvPr id="546" name="L"/>
           <p:cNvCxnSpPr/>
           <p:nvPr/>
         </p:nvCxnSpPr>
@@ -9601,7 +9639,7 @@
       </p:cxnSp>
       <p:sp>
         <p:nvSpPr>
-          <p:cNvPr id="546" name="K"/>
+          <p:cNvPr id="547" name="K"/>
           <p:cNvSpPr/>
           <p:nvPr/>
         </p:nvSpPr>
@@ -9623,7 +9661,7 @@
       </p:sp>
       <p:pic>
         <p:nvPicPr>
-          <p:cNvPr id="547" name="G"/>
+          <p:cNvPr id="548" name="G"/>
           <p:cNvPicPr>
             <a:picLocks noChangeAspect="1"/>
           </p:cNvPicPr>
@@ -9647,7 +9685,7 @@
       </p:pic>
       <p:sp>
         <p:nvSpPr>
-          <p:cNvPr id="548" name="T"/>
+          <p:cNvPr id="549" name="T"/>
           <p:cNvSpPr txBox="1"/>
           <p:nvPr/>
         </p:nvSpPr>
@@ -9696,7 +9734,7 @@
       </p:sp>
       <p:sp>
         <p:nvSpPr>
-          <p:cNvPr id="549" name="K"/>
+          <p:cNvPr id="550" name="K"/>
           <p:cNvSpPr/>
           <p:nvPr/>
         </p:nvSpPr>
@@ -9720,7 +9758,7 @@
       </p:sp>
       <p:pic>
         <p:nvPicPr>
-          <p:cNvPr id="550" name="G"/>
+          <p:cNvPr id="551" name="G"/>
           <p:cNvPicPr>
             <a:picLocks noChangeAspect="1"/>
           </p:cNvPicPr>
@@ -9744,7 +9782,7 @@
       </p:pic>
       <p:sp>
         <p:nvSpPr>
-          <p:cNvPr id="551" name="T"/>
+          <p:cNvPr id="552" name="T"/>
           <p:cNvSpPr txBox="1"/>
           <p:nvPr/>
         </p:nvSpPr>
@@ -9782,7 +9820,7 @@
       </p:sp>
       <p:sp>
         <p:nvSpPr>
-          <p:cNvPr id="552" name="T"/>
+          <p:cNvPr id="553" name="T"/>
           <p:cNvSpPr txBox="1"/>
           <p:nvPr/>
         </p:nvSpPr>
@@ -9820,7 +9858,7 @@
       </p:sp>
       <p:sp>
         <p:nvSpPr>
-          <p:cNvPr id="553" name="K"/>
+          <p:cNvPr id="554" name="K"/>
           <p:cNvSpPr/>
           <p:nvPr/>
         </p:nvSpPr>
@@ -9844,7 +9882,7 @@
       </p:sp>
       <p:sp>
         <p:nvSpPr>
-          <p:cNvPr id="554" name="T"/>
+          <p:cNvPr id="555" name="T"/>
           <p:cNvSpPr txBox="1"/>
           <p:nvPr/>
         </p:nvSpPr>
@@ -9882,7 +9920,7 @@
       </p:sp>
       <p:sp>
         <p:nvSpPr>
-          <p:cNvPr id="555" name="K"/>
+          <p:cNvPr id="556" name="K"/>
           <p:cNvSpPr/>
           <p:nvPr/>
         </p:nvSpPr>
@@ -9904,7 +9942,7 @@
       </p:sp>
       <p:pic>
         <p:nvPicPr>
-          <p:cNvPr id="556" name="G"/>
+          <p:cNvPr id="557" name="G"/>
           <p:cNvPicPr>
             <a:picLocks noChangeAspect="1"/>
           </p:cNvPicPr>
@@ -9928,7 +9966,7 @@
       </p:pic>
       <p:sp>
         <p:nvSpPr>
-          <p:cNvPr id="557" name="T"/>
+          <p:cNvPr id="558" name="T"/>
           <p:cNvSpPr txBox="1"/>
           <p:nvPr/>
         </p:nvSpPr>
@@ -9966,7 +10004,7 @@
       </p:sp>
       <p:sp>
         <p:nvSpPr>
-          <p:cNvPr id="558" name="T"/>
+          <p:cNvPr id="559" name="T"/>
           <p:cNvSpPr txBox="1"/>
           <p:nvPr/>
         </p:nvSpPr>
@@ -10021,7 +10059,7 @@
       </p:sp>
       <p:cxnSp>
         <p:nvCxnSpPr>
-          <p:cNvPr id="559" name="L"/>
+          <p:cNvPr id="560" name="L"/>
           <p:cNvCxnSpPr/>
           <p:nvPr/>
         </p:nvCxnSpPr>
@@ -10042,7 +10080,7 @@
       </p:cxnSp>
       <p:sp>
         <p:nvSpPr>
-          <p:cNvPr id="560" name="K"/>
+          <p:cNvPr id="561" name="K"/>
           <p:cNvSpPr/>
           <p:nvPr/>
         </p:nvSpPr>
@@ -10064,7 +10102,7 @@
       </p:sp>
       <p:pic>
         <p:nvPicPr>
-          <p:cNvPr id="561" name="G"/>
+          <p:cNvPr id="562" name="G"/>
           <p:cNvPicPr>
             <a:picLocks noChangeAspect="1"/>
           </p:cNvPicPr>
@@ -10088,7 +10126,7 @@
       </p:pic>
       <p:sp>
         <p:nvSpPr>
-          <p:cNvPr id="562" name="T"/>
+          <p:cNvPr id="563" name="T"/>
           <p:cNvSpPr txBox="1"/>
           <p:nvPr/>
         </p:nvSpPr>
@@ -10126,7 +10164,7 @@
       </p:sp>
       <p:sp>
         <p:nvSpPr>
-          <p:cNvPr id="563" name="T"/>
+          <p:cNvPr id="564" name="T"/>
           <p:cNvSpPr txBox="1"/>
           <p:nvPr/>
         </p:nvSpPr>
@@ -10181,7 +10219,7 @@
       </p:sp>
       <p:cxnSp>
         <p:nvCxnSpPr>
-          <p:cNvPr id="564" name="L"/>
+          <p:cNvPr id="565" name="L"/>
           <p:cNvCxnSpPr/>
           <p:nvPr/>
         </p:nvCxnSpPr>
@@ -10202,7 +10240,7 @@
       </p:cxnSp>
       <p:sp>
         <p:nvSpPr>
-          <p:cNvPr id="565" name="K"/>
+          <p:cNvPr id="566" name="K"/>
           <p:cNvSpPr/>
           <p:nvPr/>
         </p:nvSpPr>
@@ -10224,7 +10262,7 @@
       </p:sp>
       <p:pic>
         <p:nvPicPr>
-          <p:cNvPr id="566" name="G"/>
+          <p:cNvPr id="567" name="G"/>
           <p:cNvPicPr>
             <a:picLocks noChangeAspect="1"/>
           </p:cNvPicPr>
@@ -10248,7 +10286,7 @@
       </p:pic>
       <p:sp>
         <p:nvSpPr>
-          <p:cNvPr id="567" name="T"/>
+          <p:cNvPr id="568" name="T"/>
           <p:cNvSpPr txBox="1"/>
           <p:nvPr/>
         </p:nvSpPr>
@@ -10286,7 +10324,7 @@
       </p:sp>
       <p:sp>
         <p:nvSpPr>
-          <p:cNvPr id="568" name="T"/>
+          <p:cNvPr id="569" name="T"/>
           <p:cNvSpPr txBox="1"/>
           <p:nvPr/>
         </p:nvSpPr>
@@ -10514,7 +10552,7 @@
       </p:sp>
       <p:sp>
         <p:nvSpPr>
-          <p:cNvPr id="791" name="T"/>
+          <p:cNvPr id="790" name="T"/>
           <p:cNvSpPr txBox="1"/>
           <p:nvPr/>
         </p:nvSpPr>
@@ -19333,8 +19371,8 @@
         </p:nvSpPr>
         <p:spPr>
           <a:xfrm>
-            <a:off x="10120000" y="3499866"/>
-            <a:ext cx="430000" cy="164592"/>
+            <a:off x="10100000" y="3499866"/>
+            <a:ext cx="690000" cy="164592"/>
           </a:xfrm>
           <a:prstGeom prst="rect">
             <a:avLst/>
@@ -19345,65 +19383,27 @@
           <a:bodyPr wrap="none" lIns="0" tIns="0" rIns="0" bIns="0" anchor="ctr"/>
           <a:lstStyle/>
           <a:p>
-            <a:pPr algn="r">
-              <a:buNone/>
-            </a:pPr>
-            <a:r>
-              <a:rPr lang="id-ID" sz="720" b="1" dirty="0">
-                <a:solidFill>
-                  <a:srgbClr val="6B7280"/>
-                </a:solidFill>
-                <a:latin typeface="Roboto"/>
-                <a:ea typeface="Roboto"/>
-                <a:cs typeface="Roboto"/>
-              </a:rPr>
-              <a:t>–</a:t>
-            </a:r>
-            <a:endParaRPr lang="id-ID" sz="720"/>
-          </a:p>
-        </p:txBody>
-      </p:sp>
-      <p:sp>
-        <p:nvSpPr>
-          <p:cNvPr id="775" name="T"/>
-          <p:cNvSpPr txBox="1"/>
-          <p:nvPr/>
-        </p:nvSpPr>
-        <p:spPr>
-          <a:xfrm>
-            <a:off x="10571600" y="3499866"/>
-            <a:ext cx="200000" cy="164592"/>
-          </a:xfrm>
-          <a:prstGeom prst="rect">
-            <a:avLst/>
-          </a:prstGeom>
-          <a:noFill/>
-        </p:spPr>
-        <p:txBody>
-          <a:bodyPr wrap="none" lIns="0" tIns="0" rIns="0" bIns="0" anchor="ctr"/>
-          <a:lstStyle/>
-          <a:p>
-            <a:pPr algn="l">
-              <a:buNone/>
-            </a:pPr>
-            <a:r>
-              <a:rPr lang="id-ID" sz="720" b="1" dirty="0">
-                <a:solidFill>
-                  <a:srgbClr val="6B7280"/>
-                </a:solidFill>
-                <a:latin typeface="Roboto"/>
-                <a:ea typeface="Roboto"/>
-                <a:cs typeface="Roboto"/>
-              </a:rPr>
-              <a:t>liter</a:t>
-            </a:r>
-            <a:endParaRPr lang="id-ID" sz="720"/>
-          </a:p>
-        </p:txBody>
-      </p:sp>
-      <p:sp>
-        <p:nvSpPr>
-          <p:cNvPr id="776" name="K"/>
+            <a:pPr algn="ctr">
+              <a:buNone/>
+            </a:pPr>
+            <a:r>
+              <a:rPr lang="id-ID" sz="700" dirty="0">
+                <a:solidFill>
+                  <a:srgbClr val="2E3440"/>
+                </a:solidFill>
+                <a:latin typeface="Roboto"/>
+                <a:ea typeface="Roboto"/>
+                <a:cs typeface="Roboto"/>
+              </a:rPr>
+              <a:t>belum ada data</a:t>
+            </a:r>
+            <a:endParaRPr lang="id-ID" sz="650"/>
+          </a:p>
+        </p:txBody>
+      </p:sp>
+      <p:sp>
+        <p:nvSpPr>
+          <p:cNvPr id="775" name="K"/>
           <p:cNvSpPr/>
           <p:nvPr/>
         </p:nvSpPr>
@@ -19429,7 +19429,7 @@
       </p:sp>
       <p:sp>
         <p:nvSpPr>
-          <p:cNvPr id="777" name="K"/>
+          <p:cNvPr id="776" name="K"/>
           <p:cNvSpPr/>
           <p:nvPr/>
         </p:nvSpPr>
@@ -19453,7 +19453,7 @@
       </p:sp>
       <p:sp>
         <p:nvSpPr>
-          <p:cNvPr id="778" name="K"/>
+          <p:cNvPr id="777" name="K"/>
           <p:cNvSpPr/>
           <p:nvPr/>
         </p:nvSpPr>
@@ -19475,7 +19475,7 @@
       </p:sp>
       <p:sp>
         <p:nvSpPr>
-          <p:cNvPr id="779" name="K"/>
+          <p:cNvPr id="778" name="K"/>
           <p:cNvSpPr/>
           <p:nvPr/>
         </p:nvSpPr>
@@ -19497,7 +19497,7 @@
       </p:sp>
       <p:pic>
         <p:nvPicPr>
-          <p:cNvPr id="780" name="G"/>
+          <p:cNvPr id="779" name="G"/>
           <p:cNvPicPr>
             <a:picLocks noChangeAspect="1"/>
           </p:cNvPicPr>
@@ -19521,7 +19521,7 @@
       </p:pic>
       <p:sp>
         <p:nvSpPr>
-          <p:cNvPr id="781" name="T"/>
+          <p:cNvPr id="780" name="T"/>
           <p:cNvSpPr txBox="1"/>
           <p:nvPr/>
         </p:nvSpPr>
@@ -19559,7 +19559,7 @@
       </p:sp>
       <p:sp>
         <p:nvSpPr>
-          <p:cNvPr id="782" name="T"/>
+          <p:cNvPr id="781" name="T"/>
           <p:cNvSpPr txBox="1"/>
           <p:nvPr/>
         </p:nvSpPr>
@@ -21863,7 +21863,7 @@
       </p:sp>
       <p:sp>
         <p:nvSpPr>
-          <p:cNvPr id="783" name="K"/>
+          <p:cNvPr id="782" name="K"/>
           <p:cNvSpPr/>
           <p:nvPr/>
         </p:nvSpPr>
@@ -21887,7 +21887,7 @@
       </p:sp>
       <p:sp>
         <p:nvSpPr>
-          <p:cNvPr id="784" name="T"/>
+          <p:cNvPr id="783" name="T"/>
           <p:cNvSpPr txBox="1"/>
           <p:nvPr/>
         </p:nvSpPr>
@@ -21925,7 +21925,7 @@
       </p:sp>
       <p:sp>
         <p:nvSpPr>
-          <p:cNvPr id="785" name="K"/>
+          <p:cNvPr id="784" name="K"/>
           <p:cNvSpPr/>
           <p:nvPr/>
         </p:nvSpPr>
@@ -21947,7 +21947,7 @@
       </p:sp>
       <p:pic>
         <p:nvPicPr>
-          <p:cNvPr id="786" name="G"/>
+          <p:cNvPr id="785" name="G"/>
           <p:cNvPicPr>
             <a:picLocks noChangeAspect="1"/>
           </p:cNvPicPr>
@@ -21971,7 +21971,7 @@
       </p:pic>
       <p:sp>
         <p:nvSpPr>
-          <p:cNvPr id="787" name="T"/>
+          <p:cNvPr id="786" name="T"/>
           <p:cNvSpPr txBox="1"/>
           <p:nvPr/>
         </p:nvSpPr>
@@ -22009,7 +22009,7 @@
       </p:sp>
       <p:sp>
         <p:nvSpPr>
-          <p:cNvPr id="788" name="K"/>
+          <p:cNvPr id="787" name="K"/>
           <p:cNvSpPr/>
           <p:nvPr/>
         </p:nvSpPr>
@@ -22031,7 +22031,7 @@
       </p:sp>
       <p:pic>
         <p:nvPicPr>
-          <p:cNvPr id="789" name="G"/>
+          <p:cNvPr id="788" name="G"/>
           <p:cNvPicPr>
             <a:picLocks noChangeAspect="1"/>
           </p:cNvPicPr>
@@ -22055,7 +22055,7 @@
       </p:pic>
       <p:sp>
         <p:nvSpPr>
-          <p:cNvPr id="790" name="T"/>
+          <p:cNvPr id="789" name="T"/>
           <p:cNvSpPr txBox="1"/>
           <p:nvPr/>
         </p:nvSpPr>

</xml_diff>

<commit_message>
fix(laporan): harian 281026 perlu perhatian juga sisa >= 100 ha, laporan termasuk tambahan website
</commit_message>
<xml_diff>
--- a/data/laporan-bnpb/harian-2026-10-28/Laporan Kejadian Bencana Harian 281026.pptx
+++ b/data/laporan-bnpb/harian-2026-10-28/Laporan Kejadian Bencana Harian 281026.pptx
@@ -1944,7 +1944,7 @@
       </p:sp>
       <p:sp>
         <p:nvSpPr>
-          <p:cNvPr id="570" name="T"/>
+          <p:cNvPr id="573" name="T"/>
           <p:cNvSpPr txBox="1"/>
           <p:nvPr/>
         </p:nvSpPr>
@@ -2414,7 +2414,7 @@
                 <a:ea typeface="Roboto"/>
                 <a:cs typeface="Roboto"/>
               </a:rPr>
-              <a:t>26</a:t>
+              <a:t>33</a:t>
             </a:r>
             <a:endParaRPr lang="id-ID" sz="1700"/>
           </a:p>
@@ -3154,7 +3154,7 @@
                 <a:ea typeface="Roboto"/>
                 <a:cs typeface="Roboto"/>
               </a:rPr>
-              <a:t>6</a:t>
+              <a:t>7</a:t>
             </a:r>
             <a:endParaRPr lang="id-ID" sz="1700"/>
           </a:p>
@@ -3286,7 +3286,69 @@
       </p:sp>
       <p:sp>
         <p:nvSpPr>
-          <p:cNvPr id="342" name="T"/>
+          <p:cNvPr id="342" name="K"/>
+          <p:cNvSpPr/>
+          <p:nvPr/>
+        </p:nvSpPr>
+        <p:spPr>
+          <a:xfrm>
+            <a:off x="4113686" y="3132169"/>
+            <a:ext cx="137160" cy="137160"/>
+          </a:xfrm>
+          <a:prstGeom prst="ellipse">
+            <a:avLst/>
+          </a:prstGeom>
+          <a:solidFill>
+            <a:srgbClr val="C8102E"/>
+          </a:solidFill>
+          <a:ln w="12700">
+            <a:solidFill>
+              <a:srgbClr val="FFFFFF"/>
+            </a:solidFill>
+          </a:ln>
+        </p:spPr>
+      </p:sp>
+      <p:sp>
+        <p:nvSpPr>
+          <p:cNvPr id="343" name="T"/>
+          <p:cNvSpPr txBox="1"/>
+          <p:nvPr/>
+        </p:nvSpPr>
+        <p:spPr>
+          <a:xfrm>
+            <a:off x="4113686" y="3132169"/>
+            <a:ext cx="137160" cy="137160"/>
+          </a:xfrm>
+          <a:prstGeom prst="rect">
+            <a:avLst/>
+          </a:prstGeom>
+          <a:noFill/>
+        </p:spPr>
+        <p:txBody>
+          <a:bodyPr wrap="square" lIns="0" tIns="0" rIns="0" bIns="0" anchor="ctr"/>
+          <a:lstStyle/>
+          <a:p>
+            <a:pPr algn="ctr">
+              <a:buNone/>
+            </a:pPr>
+            <a:r>
+              <a:rPr lang="id-ID" sz="700" b="1" dirty="0">
+                <a:solidFill>
+                  <a:srgbClr val="FFFFFF"/>
+                </a:solidFill>
+                <a:latin typeface="Roboto"/>
+                <a:ea typeface="Roboto"/>
+                <a:cs typeface="Roboto"/>
+              </a:rPr>
+              <a:t>!</a:t>
+            </a:r>
+            <a:endParaRPr lang="id-ID" sz="700"/>
+          </a:p>
+        </p:txBody>
+      </p:sp>
+      <p:sp>
+        <p:nvSpPr>
+          <p:cNvPr id="344" name="T"/>
           <p:cNvSpPr txBox="1"/>
           <p:nvPr/>
         </p:nvSpPr>
@@ -3324,7 +3386,7 @@
       </p:sp>
       <p:sp>
         <p:nvSpPr>
-          <p:cNvPr id="343" name="K"/>
+          <p:cNvPr id="345" name="K"/>
           <p:cNvSpPr/>
           <p:nvPr/>
         </p:nvSpPr>
@@ -3348,7 +3410,7 @@
       </p:sp>
       <p:sp>
         <p:nvSpPr>
-          <p:cNvPr id="344" name="T"/>
+          <p:cNvPr id="346" name="T"/>
           <p:cNvSpPr txBox="1"/>
           <p:nvPr/>
         </p:nvSpPr>
@@ -3386,7 +3448,7 @@
       </p:sp>
       <p:sp>
         <p:nvSpPr>
-          <p:cNvPr id="345" name="K"/>
+          <p:cNvPr id="347" name="K"/>
           <p:cNvSpPr/>
           <p:nvPr/>
         </p:nvSpPr>
@@ -3410,7 +3472,7 @@
       </p:sp>
       <p:sp>
         <p:nvSpPr>
-          <p:cNvPr id="346" name="T"/>
+          <p:cNvPr id="348" name="T"/>
           <p:cNvSpPr txBox="1"/>
           <p:nvPr/>
         </p:nvSpPr>
@@ -3448,7 +3510,7 @@
       </p:sp>
       <p:sp>
         <p:nvSpPr>
-          <p:cNvPr id="347" name="T"/>
+          <p:cNvPr id="349" name="T"/>
           <p:cNvSpPr txBox="1"/>
           <p:nvPr/>
         </p:nvSpPr>
@@ -3486,7 +3548,7 @@
       </p:sp>
       <p:sp>
         <p:nvSpPr>
-          <p:cNvPr id="348" name="K"/>
+          <p:cNvPr id="350" name="K"/>
           <p:cNvSpPr/>
           <p:nvPr/>
         </p:nvSpPr>
@@ -3510,7 +3572,7 @@
       </p:sp>
       <p:sp>
         <p:nvSpPr>
-          <p:cNvPr id="349" name="T"/>
+          <p:cNvPr id="351" name="T"/>
           <p:cNvSpPr txBox="1"/>
           <p:nvPr/>
         </p:nvSpPr>
@@ -3548,7 +3610,7 @@
       </p:sp>
       <p:sp>
         <p:nvSpPr>
-          <p:cNvPr id="350" name="K"/>
+          <p:cNvPr id="352" name="K"/>
           <p:cNvSpPr/>
           <p:nvPr/>
         </p:nvSpPr>
@@ -3572,7 +3634,7 @@
       </p:sp>
       <p:sp>
         <p:nvSpPr>
-          <p:cNvPr id="351" name="T"/>
+          <p:cNvPr id="353" name="T"/>
           <p:cNvSpPr txBox="1"/>
           <p:nvPr/>
         </p:nvSpPr>
@@ -3610,7 +3672,7 @@
       </p:sp>
       <p:sp>
         <p:nvSpPr>
-          <p:cNvPr id="352" name="T"/>
+          <p:cNvPr id="354" name="T"/>
           <p:cNvSpPr txBox="1"/>
           <p:nvPr/>
         </p:nvSpPr>
@@ -3648,7 +3710,7 @@
       </p:sp>
       <p:sp>
         <p:nvSpPr>
-          <p:cNvPr id="353" name="K"/>
+          <p:cNvPr id="355" name="K"/>
           <p:cNvSpPr/>
           <p:nvPr/>
         </p:nvSpPr>
@@ -3672,7 +3734,7 @@
       </p:sp>
       <p:sp>
         <p:nvSpPr>
-          <p:cNvPr id="354" name="T"/>
+          <p:cNvPr id="356" name="T"/>
           <p:cNvSpPr txBox="1"/>
           <p:nvPr/>
         </p:nvSpPr>
@@ -3710,7 +3772,7 @@
       </p:sp>
       <p:sp>
         <p:nvSpPr>
-          <p:cNvPr id="355" name="K"/>
+          <p:cNvPr id="357" name="K"/>
           <p:cNvSpPr/>
           <p:nvPr/>
         </p:nvSpPr>
@@ -3734,7 +3796,7 @@
       </p:sp>
       <p:sp>
         <p:nvSpPr>
-          <p:cNvPr id="356" name="T"/>
+          <p:cNvPr id="358" name="T"/>
           <p:cNvSpPr txBox="1"/>
           <p:nvPr/>
         </p:nvSpPr>
@@ -3772,7 +3834,7 @@
       </p:sp>
       <p:sp>
         <p:nvSpPr>
-          <p:cNvPr id="357" name="T"/>
+          <p:cNvPr id="359" name="T"/>
           <p:cNvSpPr txBox="1"/>
           <p:nvPr/>
         </p:nvSpPr>
@@ -3810,7 +3872,7 @@
       </p:sp>
       <p:sp>
         <p:nvSpPr>
-          <p:cNvPr id="358" name="K"/>
+          <p:cNvPr id="360" name="K"/>
           <p:cNvSpPr/>
           <p:nvPr/>
         </p:nvSpPr>
@@ -3834,7 +3896,7 @@
       </p:sp>
       <p:sp>
         <p:nvSpPr>
-          <p:cNvPr id="359" name="T"/>
+          <p:cNvPr id="361" name="T"/>
           <p:cNvSpPr txBox="1"/>
           <p:nvPr/>
         </p:nvSpPr>
@@ -3872,7 +3934,7 @@
       </p:sp>
       <p:sp>
         <p:nvSpPr>
-          <p:cNvPr id="360" name="T"/>
+          <p:cNvPr id="362" name="T"/>
           <p:cNvSpPr txBox="1"/>
           <p:nvPr/>
         </p:nvSpPr>
@@ -3910,7 +3972,7 @@
       </p:sp>
       <p:sp>
         <p:nvSpPr>
-          <p:cNvPr id="361" name="K"/>
+          <p:cNvPr id="363" name="K"/>
           <p:cNvSpPr/>
           <p:nvPr/>
         </p:nvSpPr>
@@ -3934,7 +3996,7 @@
       </p:sp>
       <p:sp>
         <p:nvSpPr>
-          <p:cNvPr id="362" name="T"/>
+          <p:cNvPr id="364" name="T"/>
           <p:cNvSpPr txBox="1"/>
           <p:nvPr/>
         </p:nvSpPr>
@@ -3972,7 +4034,7 @@
       </p:sp>
       <p:sp>
         <p:nvSpPr>
-          <p:cNvPr id="363" name="K"/>
+          <p:cNvPr id="365" name="K"/>
           <p:cNvSpPr/>
           <p:nvPr/>
         </p:nvSpPr>
@@ -3996,7 +4058,7 @@
       </p:sp>
       <p:sp>
         <p:nvSpPr>
-          <p:cNvPr id="364" name="T"/>
+          <p:cNvPr id="366" name="T"/>
           <p:cNvSpPr txBox="1"/>
           <p:nvPr/>
         </p:nvSpPr>
@@ -4034,7 +4096,7 @@
       </p:sp>
       <p:sp>
         <p:nvSpPr>
-          <p:cNvPr id="365" name="T"/>
+          <p:cNvPr id="367" name="T"/>
           <p:cNvSpPr txBox="1"/>
           <p:nvPr/>
         </p:nvSpPr>
@@ -4072,7 +4134,7 @@
       </p:sp>
       <p:sp>
         <p:nvSpPr>
-          <p:cNvPr id="366" name="K"/>
+          <p:cNvPr id="368" name="K"/>
           <p:cNvSpPr/>
           <p:nvPr/>
         </p:nvSpPr>
@@ -4096,7 +4158,7 @@
       </p:sp>
       <p:sp>
         <p:nvSpPr>
-          <p:cNvPr id="367" name="T"/>
+          <p:cNvPr id="369" name="T"/>
           <p:cNvSpPr txBox="1"/>
           <p:nvPr/>
         </p:nvSpPr>
@@ -4134,7 +4196,7 @@
       </p:sp>
       <p:sp>
         <p:nvSpPr>
-          <p:cNvPr id="368" name="K"/>
+          <p:cNvPr id="370" name="K"/>
           <p:cNvSpPr/>
           <p:nvPr/>
         </p:nvSpPr>
@@ -4158,7 +4220,7 @@
       </p:sp>
       <p:sp>
         <p:nvSpPr>
-          <p:cNvPr id="369" name="T"/>
+          <p:cNvPr id="371" name="T"/>
           <p:cNvSpPr txBox="1"/>
           <p:nvPr/>
         </p:nvSpPr>
@@ -4196,7 +4258,7 @@
       </p:sp>
       <p:sp>
         <p:nvSpPr>
-          <p:cNvPr id="370" name="T"/>
+          <p:cNvPr id="372" name="T"/>
           <p:cNvSpPr txBox="1"/>
           <p:nvPr/>
         </p:nvSpPr>
@@ -4234,7 +4296,7 @@
       </p:sp>
       <p:sp>
         <p:nvSpPr>
-          <p:cNvPr id="371" name="K"/>
+          <p:cNvPr id="373" name="K"/>
           <p:cNvSpPr/>
           <p:nvPr/>
         </p:nvSpPr>
@@ -4258,7 +4320,7 @@
       </p:sp>
       <p:sp>
         <p:nvSpPr>
-          <p:cNvPr id="372" name="T"/>
+          <p:cNvPr id="374" name="T"/>
           <p:cNvSpPr txBox="1"/>
           <p:nvPr/>
         </p:nvSpPr>
@@ -4296,7 +4358,7 @@
       </p:sp>
       <p:sp>
         <p:nvSpPr>
-          <p:cNvPr id="373" name="T"/>
+          <p:cNvPr id="375" name="T"/>
           <p:cNvSpPr txBox="1"/>
           <p:nvPr/>
         </p:nvSpPr>
@@ -4334,7 +4396,7 @@
       </p:sp>
       <p:sp>
         <p:nvSpPr>
-          <p:cNvPr id="374" name="K"/>
+          <p:cNvPr id="376" name="K"/>
           <p:cNvSpPr/>
           <p:nvPr/>
         </p:nvSpPr>
@@ -4358,7 +4420,7 @@
       </p:sp>
       <p:sp>
         <p:nvSpPr>
-          <p:cNvPr id="375" name="T"/>
+          <p:cNvPr id="377" name="T"/>
           <p:cNvSpPr txBox="1"/>
           <p:nvPr/>
         </p:nvSpPr>
@@ -4396,7 +4458,7 @@
       </p:sp>
       <p:sp>
         <p:nvSpPr>
-          <p:cNvPr id="376" name="T"/>
+          <p:cNvPr id="378" name="T"/>
           <p:cNvSpPr txBox="1"/>
           <p:nvPr/>
         </p:nvSpPr>
@@ -4434,7 +4496,7 @@
       </p:sp>
       <p:sp>
         <p:nvSpPr>
-          <p:cNvPr id="377" name="K"/>
+          <p:cNvPr id="379" name="K"/>
           <p:cNvSpPr/>
           <p:nvPr/>
         </p:nvSpPr>
@@ -4458,7 +4520,7 @@
       </p:sp>
       <p:sp>
         <p:nvSpPr>
-          <p:cNvPr id="378" name="T"/>
+          <p:cNvPr id="380" name="T"/>
           <p:cNvSpPr txBox="1"/>
           <p:nvPr/>
         </p:nvSpPr>
@@ -4496,7 +4558,7 @@
       </p:sp>
       <p:sp>
         <p:nvSpPr>
-          <p:cNvPr id="379" name="T"/>
+          <p:cNvPr id="381" name="T"/>
           <p:cNvSpPr txBox="1"/>
           <p:nvPr/>
         </p:nvSpPr>
@@ -4534,7 +4596,7 @@
       </p:sp>
       <p:sp>
         <p:nvSpPr>
-          <p:cNvPr id="380" name="K"/>
+          <p:cNvPr id="382" name="K"/>
           <p:cNvSpPr/>
           <p:nvPr/>
         </p:nvSpPr>
@@ -4558,7 +4620,7 @@
       </p:sp>
       <p:sp>
         <p:nvSpPr>
-          <p:cNvPr id="381" name="T"/>
+          <p:cNvPr id="383" name="T"/>
           <p:cNvSpPr txBox="1"/>
           <p:nvPr/>
         </p:nvSpPr>
@@ -4596,7 +4658,7 @@
       </p:sp>
       <p:sp>
         <p:nvSpPr>
-          <p:cNvPr id="382" name="T"/>
+          <p:cNvPr id="384" name="T"/>
           <p:cNvSpPr txBox="1"/>
           <p:nvPr/>
         </p:nvSpPr>
@@ -4634,7 +4696,7 @@
       </p:sp>
       <p:sp>
         <p:nvSpPr>
-          <p:cNvPr id="383" name="K"/>
+          <p:cNvPr id="385" name="K"/>
           <p:cNvSpPr/>
           <p:nvPr/>
         </p:nvSpPr>
@@ -4658,7 +4720,7 @@
       </p:sp>
       <p:sp>
         <p:nvSpPr>
-          <p:cNvPr id="384" name="T"/>
+          <p:cNvPr id="386" name="T"/>
           <p:cNvSpPr txBox="1"/>
           <p:nvPr/>
         </p:nvSpPr>
@@ -4696,7 +4758,7 @@
       </p:sp>
       <p:sp>
         <p:nvSpPr>
-          <p:cNvPr id="385" name="T"/>
+          <p:cNvPr id="387" name="T"/>
           <p:cNvSpPr txBox="1"/>
           <p:nvPr/>
         </p:nvSpPr>
@@ -4734,7 +4796,7 @@
       </p:sp>
       <p:sp>
         <p:nvSpPr>
-          <p:cNvPr id="386" name="K"/>
+          <p:cNvPr id="388" name="K"/>
           <p:cNvSpPr/>
           <p:nvPr/>
         </p:nvSpPr>
@@ -4758,7 +4820,7 @@
       </p:sp>
       <p:sp>
         <p:nvSpPr>
-          <p:cNvPr id="387" name="T"/>
+          <p:cNvPr id="389" name="T"/>
           <p:cNvSpPr txBox="1"/>
           <p:nvPr/>
         </p:nvSpPr>
@@ -4796,7 +4858,7 @@
       </p:sp>
       <p:sp>
         <p:nvSpPr>
-          <p:cNvPr id="388" name="K"/>
+          <p:cNvPr id="390" name="K"/>
           <p:cNvSpPr/>
           <p:nvPr/>
         </p:nvSpPr>
@@ -4820,7 +4882,7 @@
       </p:sp>
       <p:sp>
         <p:nvSpPr>
-          <p:cNvPr id="389" name="T"/>
+          <p:cNvPr id="391" name="T"/>
           <p:cNvSpPr txBox="1"/>
           <p:nvPr/>
         </p:nvSpPr>
@@ -4858,7 +4920,7 @@
       </p:sp>
       <p:sp>
         <p:nvSpPr>
-          <p:cNvPr id="390" name="T"/>
+          <p:cNvPr id="392" name="T"/>
           <p:cNvSpPr txBox="1"/>
           <p:nvPr/>
         </p:nvSpPr>
@@ -4896,7 +4958,7 @@
       </p:sp>
       <p:sp>
         <p:nvSpPr>
-          <p:cNvPr id="391" name="K"/>
+          <p:cNvPr id="393" name="K"/>
           <p:cNvSpPr/>
           <p:nvPr/>
         </p:nvSpPr>
@@ -4920,7 +4982,7 @@
       </p:sp>
       <p:sp>
         <p:nvSpPr>
-          <p:cNvPr id="392" name="T"/>
+          <p:cNvPr id="394" name="T"/>
           <p:cNvSpPr txBox="1"/>
           <p:nvPr/>
         </p:nvSpPr>
@@ -4958,7 +5020,7 @@
       </p:sp>
       <p:sp>
         <p:nvSpPr>
-          <p:cNvPr id="393" name="K"/>
+          <p:cNvPr id="395" name="K"/>
           <p:cNvSpPr/>
           <p:nvPr/>
         </p:nvSpPr>
@@ -4982,7 +5044,7 @@
       </p:sp>
       <p:sp>
         <p:nvSpPr>
-          <p:cNvPr id="394" name="T"/>
+          <p:cNvPr id="396" name="T"/>
           <p:cNvSpPr txBox="1"/>
           <p:nvPr/>
         </p:nvSpPr>
@@ -5020,7 +5082,7 @@
       </p:sp>
       <p:sp>
         <p:nvSpPr>
-          <p:cNvPr id="395" name="T"/>
+          <p:cNvPr id="397" name="T"/>
           <p:cNvSpPr txBox="1"/>
           <p:nvPr/>
         </p:nvSpPr>
@@ -5058,7 +5120,7 @@
       </p:sp>
       <p:sp>
         <p:nvSpPr>
-          <p:cNvPr id="396" name="K"/>
+          <p:cNvPr id="398" name="K"/>
           <p:cNvSpPr/>
           <p:nvPr/>
         </p:nvSpPr>
@@ -5082,7 +5144,7 @@
       </p:sp>
       <p:sp>
         <p:nvSpPr>
-          <p:cNvPr id="397" name="T"/>
+          <p:cNvPr id="399" name="T"/>
           <p:cNvSpPr txBox="1"/>
           <p:nvPr/>
         </p:nvSpPr>
@@ -5120,7 +5182,7 @@
       </p:sp>
       <p:sp>
         <p:nvSpPr>
-          <p:cNvPr id="398" name="T"/>
+          <p:cNvPr id="400" name="T"/>
           <p:cNvSpPr txBox="1"/>
           <p:nvPr/>
         </p:nvSpPr>
@@ -5158,7 +5220,7 @@
       </p:sp>
       <p:sp>
         <p:nvSpPr>
-          <p:cNvPr id="399" name="K"/>
+          <p:cNvPr id="401" name="K"/>
           <p:cNvSpPr/>
           <p:nvPr/>
         </p:nvSpPr>
@@ -5182,7 +5244,7 @@
       </p:sp>
       <p:sp>
         <p:nvSpPr>
-          <p:cNvPr id="400" name="T"/>
+          <p:cNvPr id="402" name="T"/>
           <p:cNvSpPr txBox="1"/>
           <p:nvPr/>
         </p:nvSpPr>
@@ -5220,7 +5282,7 @@
       </p:sp>
       <p:sp>
         <p:nvSpPr>
-          <p:cNvPr id="401" name="K"/>
+          <p:cNvPr id="403" name="K"/>
           <p:cNvSpPr/>
           <p:nvPr/>
         </p:nvSpPr>
@@ -5244,7 +5306,7 @@
       </p:sp>
       <p:sp>
         <p:nvSpPr>
-          <p:cNvPr id="402" name="T"/>
+          <p:cNvPr id="404" name="T"/>
           <p:cNvSpPr txBox="1"/>
           <p:nvPr/>
         </p:nvSpPr>
@@ -5282,7 +5344,7 @@
       </p:sp>
       <p:sp>
         <p:nvSpPr>
-          <p:cNvPr id="403" name="T"/>
+          <p:cNvPr id="405" name="T"/>
           <p:cNvSpPr txBox="1"/>
           <p:nvPr/>
         </p:nvSpPr>
@@ -5320,7 +5382,7 @@
       </p:sp>
       <p:sp>
         <p:nvSpPr>
-          <p:cNvPr id="404" name="K"/>
+          <p:cNvPr id="406" name="K"/>
           <p:cNvSpPr/>
           <p:nvPr/>
         </p:nvSpPr>
@@ -5344,7 +5406,7 @@
       </p:sp>
       <p:sp>
         <p:nvSpPr>
-          <p:cNvPr id="405" name="T"/>
+          <p:cNvPr id="407" name="T"/>
           <p:cNvSpPr txBox="1"/>
           <p:nvPr/>
         </p:nvSpPr>
@@ -5382,7 +5444,7 @@
       </p:sp>
       <p:sp>
         <p:nvSpPr>
-          <p:cNvPr id="406" name="T"/>
+          <p:cNvPr id="408" name="T"/>
           <p:cNvSpPr txBox="1"/>
           <p:nvPr/>
         </p:nvSpPr>
@@ -5420,7 +5482,7 @@
       </p:sp>
       <p:sp>
         <p:nvSpPr>
-          <p:cNvPr id="407" name="K"/>
+          <p:cNvPr id="409" name="K"/>
           <p:cNvSpPr/>
           <p:nvPr/>
         </p:nvSpPr>
@@ -5444,7 +5506,7 @@
       </p:sp>
       <p:sp>
         <p:nvSpPr>
-          <p:cNvPr id="408" name="T"/>
+          <p:cNvPr id="410" name="T"/>
           <p:cNvSpPr txBox="1"/>
           <p:nvPr/>
         </p:nvSpPr>
@@ -5482,7 +5544,7 @@
       </p:sp>
       <p:sp>
         <p:nvSpPr>
-          <p:cNvPr id="409" name="T"/>
+          <p:cNvPr id="411" name="T"/>
           <p:cNvSpPr txBox="1"/>
           <p:nvPr/>
         </p:nvSpPr>
@@ -5520,7 +5582,7 @@
       </p:sp>
       <p:sp>
         <p:nvSpPr>
-          <p:cNvPr id="410" name="K"/>
+          <p:cNvPr id="412" name="K"/>
           <p:cNvSpPr/>
           <p:nvPr/>
         </p:nvSpPr>
@@ -5542,7 +5604,7 @@
       </p:sp>
       <p:sp>
         <p:nvSpPr>
-          <p:cNvPr id="411" name="T"/>
+          <p:cNvPr id="413" name="T"/>
           <p:cNvSpPr txBox="1"/>
           <p:nvPr/>
         </p:nvSpPr>
@@ -5580,7 +5642,7 @@
       </p:sp>
       <p:sp>
         <p:nvSpPr>
-          <p:cNvPr id="412" name="K"/>
+          <p:cNvPr id="414" name="K"/>
           <p:cNvSpPr/>
           <p:nvPr/>
         </p:nvSpPr>
@@ -5602,7 +5664,7 @@
       </p:sp>
       <p:sp>
         <p:nvSpPr>
-          <p:cNvPr id="413" name="T"/>
+          <p:cNvPr id="415" name="T"/>
           <p:cNvSpPr txBox="1"/>
           <p:nvPr/>
         </p:nvSpPr>
@@ -5640,7 +5702,7 @@
       </p:sp>
       <p:sp>
         <p:nvSpPr>
-          <p:cNvPr id="414" name="K"/>
+          <p:cNvPr id="416" name="K"/>
           <p:cNvSpPr/>
           <p:nvPr/>
         </p:nvSpPr>
@@ -5662,7 +5724,7 @@
       </p:sp>
       <p:sp>
         <p:nvSpPr>
-          <p:cNvPr id="415" name="T"/>
+          <p:cNvPr id="417" name="T"/>
           <p:cNvSpPr txBox="1"/>
           <p:nvPr/>
         </p:nvSpPr>
@@ -5700,7 +5762,7 @@
       </p:sp>
       <p:sp>
         <p:nvSpPr>
-          <p:cNvPr id="416" name="K"/>
+          <p:cNvPr id="418" name="K"/>
           <p:cNvSpPr/>
           <p:nvPr/>
         </p:nvSpPr>
@@ -5722,7 +5784,7 @@
       </p:sp>
       <p:sp>
         <p:nvSpPr>
-          <p:cNvPr id="417" name="T"/>
+          <p:cNvPr id="419" name="T"/>
           <p:cNvSpPr txBox="1"/>
           <p:nvPr/>
         </p:nvSpPr>
@@ -5760,7 +5822,7 @@
       </p:sp>
       <p:sp>
         <p:nvSpPr>
-          <p:cNvPr id="418" name="K"/>
+          <p:cNvPr id="420" name="K"/>
           <p:cNvSpPr/>
           <p:nvPr/>
         </p:nvSpPr>
@@ -5782,7 +5844,7 @@
       </p:sp>
       <p:sp>
         <p:nvSpPr>
-          <p:cNvPr id="419" name="T"/>
+          <p:cNvPr id="421" name="T"/>
           <p:cNvSpPr txBox="1"/>
           <p:nvPr/>
         </p:nvSpPr>
@@ -5820,7 +5882,7 @@
       </p:sp>
       <p:sp>
         <p:nvSpPr>
-          <p:cNvPr id="420" name="K"/>
+          <p:cNvPr id="422" name="K"/>
           <p:cNvSpPr/>
           <p:nvPr/>
         </p:nvSpPr>
@@ -5842,7 +5904,7 @@
       </p:sp>
       <p:sp>
         <p:nvSpPr>
-          <p:cNvPr id="421" name="T"/>
+          <p:cNvPr id="423" name="T"/>
           <p:cNvSpPr txBox="1"/>
           <p:nvPr/>
         </p:nvSpPr>
@@ -5880,7 +5942,7 @@
       </p:sp>
       <p:sp>
         <p:nvSpPr>
-          <p:cNvPr id="422" name="K"/>
+          <p:cNvPr id="424" name="K"/>
           <p:cNvSpPr/>
           <p:nvPr/>
         </p:nvSpPr>
@@ -5902,7 +5964,7 @@
       </p:sp>
       <p:sp>
         <p:nvSpPr>
-          <p:cNvPr id="423" name="T"/>
+          <p:cNvPr id="425" name="T"/>
           <p:cNvSpPr txBox="1"/>
           <p:nvPr/>
         </p:nvSpPr>
@@ -5940,7 +6002,7 @@
       </p:sp>
       <p:sp>
         <p:nvSpPr>
-          <p:cNvPr id="424" name="T"/>
+          <p:cNvPr id="426" name="T"/>
           <p:cNvSpPr txBox="1"/>
           <p:nvPr/>
         </p:nvSpPr>
@@ -5978,7 +6040,7 @@
       </p:sp>
       <p:sp>
         <p:nvSpPr>
-          <p:cNvPr id="425" name="K"/>
+          <p:cNvPr id="427" name="K"/>
           <p:cNvSpPr/>
           <p:nvPr/>
         </p:nvSpPr>
@@ -6004,7 +6066,7 @@
       </p:sp>
       <p:sp>
         <p:nvSpPr>
-          <p:cNvPr id="426" name="T"/>
+          <p:cNvPr id="428" name="T"/>
           <p:cNvSpPr txBox="1"/>
           <p:nvPr/>
         </p:nvSpPr>
@@ -6042,7 +6104,7 @@
       </p:sp>
       <p:sp>
         <p:nvSpPr>
-          <p:cNvPr id="427" name="K"/>
+          <p:cNvPr id="429" name="K"/>
           <p:cNvSpPr/>
           <p:nvPr/>
         </p:nvSpPr>
@@ -6064,7 +6126,7 @@
       </p:sp>
       <p:sp>
         <p:nvSpPr>
-          <p:cNvPr id="428" name="T"/>
+          <p:cNvPr id="430" name="T"/>
           <p:cNvSpPr txBox="1"/>
           <p:nvPr/>
         </p:nvSpPr>
@@ -6102,7 +6164,7 @@
       </p:sp>
       <p:sp>
         <p:nvSpPr>
-          <p:cNvPr id="429" name="K"/>
+          <p:cNvPr id="431" name="K"/>
           <p:cNvSpPr/>
           <p:nvPr/>
         </p:nvSpPr>
@@ -6124,7 +6186,7 @@
       </p:sp>
       <p:sp>
         <p:nvSpPr>
-          <p:cNvPr id="430" name="T"/>
+          <p:cNvPr id="432" name="T"/>
           <p:cNvSpPr txBox="1"/>
           <p:nvPr/>
         </p:nvSpPr>
@@ -6162,7 +6224,7 @@
       </p:sp>
       <p:sp>
         <p:nvSpPr>
-          <p:cNvPr id="431" name="K"/>
+          <p:cNvPr id="433" name="K"/>
           <p:cNvSpPr/>
           <p:nvPr/>
         </p:nvSpPr>
@@ -6186,7 +6248,7 @@
       </p:sp>
       <p:sp>
         <p:nvSpPr>
-          <p:cNvPr id="432" name="K"/>
+          <p:cNvPr id="434" name="K"/>
           <p:cNvSpPr/>
           <p:nvPr/>
         </p:nvSpPr>
@@ -6208,7 +6270,7 @@
       </p:sp>
       <p:pic>
         <p:nvPicPr>
-          <p:cNvPr id="433" name="G"/>
+          <p:cNvPr id="435" name="G"/>
           <p:cNvPicPr>
             <a:picLocks noChangeAspect="1"/>
           </p:cNvPicPr>
@@ -6232,7 +6294,7 @@
       </p:pic>
       <p:sp>
         <p:nvSpPr>
-          <p:cNvPr id="434" name="T"/>
+          <p:cNvPr id="436" name="T"/>
           <p:cNvSpPr txBox="1"/>
           <p:nvPr/>
         </p:nvSpPr>
@@ -6281,7 +6343,7 @@
       </p:sp>
       <p:sp>
         <p:nvSpPr>
-          <p:cNvPr id="435" name="T"/>
+          <p:cNvPr id="437" name="T"/>
           <p:cNvSpPr txBox="1"/>
           <p:nvPr/>
         </p:nvSpPr>
@@ -6319,7 +6381,7 @@
       </p:sp>
       <p:sp>
         <p:nvSpPr>
-          <p:cNvPr id="436" name="K"/>
+          <p:cNvPr id="438" name="K"/>
           <p:cNvSpPr/>
           <p:nvPr/>
         </p:nvSpPr>
@@ -6343,7 +6405,7 @@
       </p:sp>
       <p:sp>
         <p:nvSpPr>
-          <p:cNvPr id="437" name="K"/>
+          <p:cNvPr id="439" name="K"/>
           <p:cNvSpPr/>
           <p:nvPr/>
         </p:nvSpPr>
@@ -6365,7 +6427,7 @@
       </p:sp>
       <p:pic>
         <p:nvPicPr>
-          <p:cNvPr id="438" name="G"/>
+          <p:cNvPr id="440" name="G"/>
           <p:cNvPicPr>
             <a:picLocks noChangeAspect="1"/>
           </p:cNvPicPr>
@@ -6389,7 +6451,7 @@
       </p:pic>
       <p:sp>
         <p:nvSpPr>
-          <p:cNvPr id="439" name="T"/>
+          <p:cNvPr id="441" name="T"/>
           <p:cNvSpPr txBox="1"/>
           <p:nvPr/>
         </p:nvSpPr>
@@ -6438,7 +6500,7 @@
       </p:sp>
       <p:sp>
         <p:nvSpPr>
-          <p:cNvPr id="440" name="T"/>
+          <p:cNvPr id="442" name="T"/>
           <p:cNvSpPr txBox="1"/>
           <p:nvPr/>
         </p:nvSpPr>
@@ -6476,7 +6538,7 @@
       </p:sp>
       <p:cxnSp>
         <p:nvCxnSpPr>
-          <p:cNvPr id="441" name="L"/>
+          <p:cNvPr id="443" name="L"/>
           <p:cNvCxnSpPr/>
           <p:nvPr/>
         </p:nvCxnSpPr>
@@ -6497,7 +6559,7 @@
       </p:cxnSp>
       <p:sp>
         <p:nvSpPr>
-          <p:cNvPr id="442" name="T"/>
+          <p:cNvPr id="444" name="T"/>
           <p:cNvSpPr txBox="1"/>
           <p:nvPr/>
         </p:nvSpPr>
@@ -6535,7 +6597,7 @@
       </p:sp>
       <p:sp>
         <p:nvSpPr>
-          <p:cNvPr id="443" name="K"/>
+          <p:cNvPr id="445" name="K"/>
           <p:cNvSpPr/>
           <p:nvPr/>
         </p:nvSpPr>
@@ -6557,7 +6619,7 @@
       </p:sp>
       <p:pic>
         <p:nvPicPr>
-          <p:cNvPr id="444" name="G"/>
+          <p:cNvPr id="446" name="G"/>
           <p:cNvPicPr>
             <a:picLocks noChangeAspect="1"/>
           </p:cNvPicPr>
@@ -6581,280 +6643,13 @@
       </p:pic>
       <p:sp>
         <p:nvSpPr>
-          <p:cNvPr id="445" name="T"/>
-          <p:cNvSpPr txBox="1"/>
-          <p:nvPr/>
-        </p:nvSpPr>
-        <p:spPr>
-          <a:xfrm>
-            <a:off x="8869680" y="3806834"/>
-            <a:ext cx="1758391" cy="164592"/>
-          </a:xfrm>
-          <a:prstGeom prst="rect">
-            <a:avLst/>
-          </a:prstGeom>
-          <a:noFill/>
-        </p:spPr>
-        <p:txBody>
-          <a:bodyPr wrap="none" lIns="0" tIns="0" rIns="0" bIns="0" anchor="ctr"/>
-          <a:lstStyle/>
-          <a:p>
-            <a:pPr algn="l">
-              <a:buNone/>
-            </a:pPr>
-            <a:r>
-              <a:rPr lang="id-ID" sz="760" b="1" dirty="0">
-                <a:solidFill>
-                  <a:srgbClr val="1A1A1A"/>
-                </a:solidFill>
-                <a:latin typeface="Roboto"/>
-                <a:ea typeface="Roboto"/>
-                <a:cs typeface="Roboto"/>
-              </a:rPr>
-              <a:t>Kalimantan Timur</a:t>
-            </a:r>
-            <a:endParaRPr lang="id-ID" sz="760"/>
-          </a:p>
-        </p:txBody>
-      </p:sp>
-      <p:sp>
-        <p:nvSpPr>
-          <p:cNvPr id="446" name="K"/>
+          <p:cNvPr id="447" name="K"/>
           <p:cNvSpPr/>
           <p:nvPr/>
         </p:nvSpPr>
         <p:spPr>
           <a:xfrm>
-            <a:off x="10470000" y="3840480"/>
-            <a:ext cx="1070000" cy="97300"/>
-          </a:xfrm>
-          <a:prstGeom prst="roundRect">
-            <a:avLst>
-              <a:gd name="adj" fmla="val 50000"/>
-            </a:avLst>
-          </a:prstGeom>
-          <a:solidFill>
-            <a:srgbClr val="FBE7D6"/>
-          </a:solidFill>
-          <a:ln>
-            <a:noFill/>
-          </a:ln>
-        </p:spPr>
-      </p:sp>
-      <p:pic>
-        <p:nvPicPr>
-          <p:cNvPr id="447" name="G"/>
-          <p:cNvPicPr>
-            <a:picLocks noChangeAspect="1"/>
-          </p:cNvPicPr>
-          <p:nvPr/>
-        </p:nvPicPr>
-        <p:blipFill>
-          <a:blip r:embed="rIdM13"/>
-          <a:stretch>
-            <a:fillRect/>
-          </a:stretch>
-        </p:blipFill>
-        <p:spPr>
-          <a:xfrm>
-            <a:off x="10520000" y="3856048"/>
-            <a:ext cx="66164" cy="66164"/>
-          </a:xfrm>
-          <a:prstGeom prst="rect">
-            <a:avLst/>
-          </a:prstGeom>
-        </p:spPr>
-      </p:pic>
-      <p:sp>
-        <p:nvSpPr>
-          <p:cNvPr id="448" name="T"/>
-          <p:cNvSpPr txBox="1"/>
-          <p:nvPr/>
-        </p:nvSpPr>
-        <p:spPr>
-          <a:xfrm>
-            <a:off x="10650000" y="3840480"/>
-            <a:ext cx="260000" cy="97300"/>
-          </a:xfrm>
-          <a:prstGeom prst="rect">
-            <a:avLst/>
-          </a:prstGeom>
-          <a:noFill/>
-        </p:spPr>
-        <p:txBody>
-          <a:bodyPr wrap="none" lIns="0" tIns="0" rIns="0" bIns="0" anchor="ctr"/>
-          <a:lstStyle/>
-          <a:p>
-            <a:pPr algn="l">
-              <a:buNone/>
-            </a:pPr>
-            <a:r>
-              <a:rPr lang="id-ID" sz="720" b="1" dirty="0">
-                <a:solidFill>
-                  <a:srgbClr val="D9600B"/>
-                </a:solidFill>
-                <a:latin typeface="Roboto"/>
-                <a:ea typeface="Roboto"/>
-                <a:cs typeface="Roboto"/>
-              </a:rPr>
-              <a:t>sisa</a:t>
-            </a:r>
-            <a:endParaRPr lang="id-ID" sz="720"/>
-          </a:p>
-        </p:txBody>
-      </p:sp>
-      <p:sp>
-        <p:nvSpPr>
-          <p:cNvPr id="449" name="T"/>
-          <p:cNvSpPr txBox="1"/>
-          <p:nvPr/>
-        </p:nvSpPr>
-        <p:spPr>
-          <a:xfrm>
-            <a:off x="10800000" y="3840480"/>
-            <a:ext cx="380000" cy="97300"/>
-          </a:xfrm>
-          <a:prstGeom prst="rect">
-            <a:avLst/>
-          </a:prstGeom>
-          <a:noFill/>
-        </p:spPr>
-        <p:txBody>
-          <a:bodyPr wrap="none" lIns="0" tIns="0" rIns="0" bIns="0" anchor="ctr"/>
-          <a:lstStyle/>
-          <a:p>
-            <a:pPr algn="r">
-              <a:buNone/>
-            </a:pPr>
-            <a:r>
-              <a:rPr lang="id-ID" sz="720" b="1" dirty="0">
-                <a:solidFill>
-                  <a:srgbClr val="D9600B"/>
-                </a:solidFill>
-                <a:latin typeface="Roboto"/>
-                <a:ea typeface="Roboto"/>
-                <a:cs typeface="Roboto"/>
-              </a:rPr>
-              <a:t>± 461</a:t>
-            </a:r>
-            <a:endParaRPr lang="id-ID" sz="720"/>
-          </a:p>
-        </p:txBody>
-      </p:sp>
-      <p:sp>
-        <p:nvSpPr>
-          <p:cNvPr id="450" name="T"/>
-          <p:cNvSpPr txBox="1"/>
-          <p:nvPr/>
-        </p:nvSpPr>
-        <p:spPr>
-          <a:xfrm>
-            <a:off x="11201600" y="3840480"/>
-            <a:ext cx="200000" cy="97300"/>
-          </a:xfrm>
-          <a:prstGeom prst="rect">
-            <a:avLst/>
-          </a:prstGeom>
-          <a:noFill/>
-        </p:spPr>
-        <p:txBody>
-          <a:bodyPr wrap="none" lIns="0" tIns="0" rIns="0" bIns="0" anchor="ctr"/>
-          <a:lstStyle/>
-          <a:p>
-            <a:pPr algn="l">
-              <a:buNone/>
-            </a:pPr>
-            <a:r>
-              <a:rPr lang="id-ID" sz="720" b="1" dirty="0">
-                <a:solidFill>
-                  <a:srgbClr val="D9600B"/>
-                </a:solidFill>
-                <a:latin typeface="Roboto"/>
-                <a:ea typeface="Roboto"/>
-                <a:cs typeface="Roboto"/>
-              </a:rPr>
-              <a:t>ha</a:t>
-            </a:r>
-            <a:endParaRPr lang="id-ID" sz="720"/>
-          </a:p>
-        </p:txBody>
-      </p:sp>
-      <p:cxnSp>
-        <p:nvCxnSpPr>
-          <p:cNvPr id="451" name="L"/>
-          <p:cNvCxnSpPr/>
-          <p:nvPr/>
-        </p:nvCxnSpPr>
-        <p:spPr>
-          <a:xfrm>
-            <a:off x="8668512" y="3949943"/>
-            <a:ext cx="2809951" cy="0"/>
-          </a:xfrm>
-          <a:prstGeom prst="line">
-            <a:avLst/>
-          </a:prstGeom>
-          <a:ln w="9525">
-            <a:solidFill>
-              <a:srgbClr val="F1F2F4"/>
-            </a:solidFill>
-          </a:ln>
-        </p:spPr>
-      </p:cxnSp>
-      <p:sp>
-        <p:nvSpPr>
-          <p:cNvPr id="452" name="K"/>
-          <p:cNvSpPr/>
-          <p:nvPr/>
-        </p:nvSpPr>
-        <p:spPr>
-          <a:xfrm>
-            <a:off x="8668512" y="3962106"/>
-            <a:ext cx="97300" cy="97300"/>
-          </a:xfrm>
-          <a:prstGeom prst="ellipse">
-            <a:avLst/>
-          </a:prstGeom>
-          <a:solidFill>
-            <a:srgbClr val="D9600B"/>
-          </a:solidFill>
-          <a:ln>
-            <a:noFill/>
-          </a:ln>
-        </p:spPr>
-      </p:sp>
-      <p:pic>
-        <p:nvPicPr>
-          <p:cNvPr id="453" name="G"/>
-          <p:cNvPicPr>
-            <a:picLocks noChangeAspect="1"/>
-          </p:cNvPicPr>
-          <p:nvPr/>
-        </p:nvPicPr>
-        <p:blipFill>
-          <a:blip r:embed="rIdM12"/>
-          <a:stretch>
-            <a:fillRect/>
-          </a:stretch>
-        </p:blipFill>
-        <p:spPr>
-          <a:xfrm>
-            <a:off x="8686999" y="3980593"/>
-            <a:ext cx="60326" cy="60326"/>
-          </a:xfrm>
-          <a:prstGeom prst="rect">
-            <a:avLst/>
-          </a:prstGeom>
-        </p:spPr>
-      </p:pic>
-      <p:sp>
-        <p:nvSpPr>
-          <p:cNvPr id="454" name="K"/>
-          <p:cNvSpPr/>
-          <p:nvPr/>
-        </p:nvSpPr>
-        <p:spPr>
-          <a:xfrm>
-            <a:off x="8736622" y="3942646"/>
+            <a:off x="8736622" y="3821020"/>
             <a:ext cx="53515" cy="53515"/>
           </a:xfrm>
           <a:prstGeom prst="ellipse">
@@ -6872,13 +6667,13 @@
       </p:sp>
       <p:sp>
         <p:nvSpPr>
-          <p:cNvPr id="455" name="T"/>
-          <p:cNvSpPr txBox="1"/>
-          <p:nvPr/>
-        </p:nvSpPr>
-        <p:spPr>
-          <a:xfrm>
-            <a:off x="8736622" y="3942646"/>
+          <p:cNvPr id="448" name="T"/>
+          <p:cNvSpPr txBox="1"/>
+          <p:nvPr/>
+        </p:nvSpPr>
+        <p:spPr>
+          <a:xfrm>
+            <a:off x="8736622" y="3821020"/>
             <a:ext cx="53515" cy="53515"/>
           </a:xfrm>
           <a:prstGeom prst="rect">
@@ -6910,13 +6705,13 @@
       </p:sp>
       <p:sp>
         <p:nvSpPr>
-          <p:cNvPr id="456" name="T"/>
-          <p:cNvSpPr txBox="1"/>
-          <p:nvPr/>
-        </p:nvSpPr>
-        <p:spPr>
-          <a:xfrm>
-            <a:off x="8869680" y="3928460"/>
+          <p:cNvPr id="449" name="T"/>
+          <p:cNvSpPr txBox="1"/>
+          <p:nvPr/>
+        </p:nvSpPr>
+        <p:spPr>
+          <a:xfrm>
+            <a:off x="8869680" y="3806834"/>
             <a:ext cx="1758391" cy="164592"/>
           </a:xfrm>
           <a:prstGeom prst="rect">
@@ -6940,7 +6735,7 @@
                 <a:ea typeface="Roboto"/>
                 <a:cs typeface="Roboto"/>
               </a:rPr>
-              <a:t>Papua Selatan</a:t>
+              <a:t>Kalimantan Timur</a:t>
             </a:r>
             <a:endParaRPr lang="id-ID" sz="760"/>
           </a:p>
@@ -6948,13 +6743,13 @@
       </p:sp>
       <p:sp>
         <p:nvSpPr>
-          <p:cNvPr id="457" name="K"/>
+          <p:cNvPr id="450" name="K"/>
           <p:cNvSpPr/>
           <p:nvPr/>
         </p:nvSpPr>
         <p:spPr>
           <a:xfrm>
-            <a:off x="10470000" y="3962106"/>
+            <a:off x="10470000" y="3840480"/>
             <a:ext cx="1070000" cy="97300"/>
           </a:xfrm>
           <a:prstGeom prst="roundRect">
@@ -6972,7 +6767,7 @@
       </p:sp>
       <p:pic>
         <p:nvPicPr>
-          <p:cNvPr id="458" name="G"/>
+          <p:cNvPr id="451" name="G"/>
           <p:cNvPicPr>
             <a:picLocks noChangeAspect="1"/>
           </p:cNvPicPr>
@@ -6986,7 +6781,7 @@
         </p:blipFill>
         <p:spPr>
           <a:xfrm>
-            <a:off x="10520000" y="3977674"/>
+            <a:off x="10520000" y="3856048"/>
             <a:ext cx="66164" cy="66164"/>
           </a:xfrm>
           <a:prstGeom prst="rect">
@@ -6996,13 +6791,13 @@
       </p:pic>
       <p:sp>
         <p:nvSpPr>
-          <p:cNvPr id="459" name="T"/>
-          <p:cNvSpPr txBox="1"/>
-          <p:nvPr/>
-        </p:nvSpPr>
-        <p:spPr>
-          <a:xfrm>
-            <a:off x="10650000" y="3962106"/>
+          <p:cNvPr id="452" name="T"/>
+          <p:cNvSpPr txBox="1"/>
+          <p:nvPr/>
+        </p:nvSpPr>
+        <p:spPr>
+          <a:xfrm>
+            <a:off x="10650000" y="3840480"/>
             <a:ext cx="260000" cy="97300"/>
           </a:xfrm>
           <a:prstGeom prst="rect">
@@ -7034,13 +6829,13 @@
       </p:sp>
       <p:sp>
         <p:nvSpPr>
-          <p:cNvPr id="460" name="T"/>
-          <p:cNvSpPr txBox="1"/>
-          <p:nvPr/>
-        </p:nvSpPr>
-        <p:spPr>
-          <a:xfrm>
-            <a:off x="10800000" y="3962106"/>
+          <p:cNvPr id="453" name="T"/>
+          <p:cNvSpPr txBox="1"/>
+          <p:nvPr/>
+        </p:nvSpPr>
+        <p:spPr>
+          <a:xfrm>
+            <a:off x="10800000" y="3840480"/>
             <a:ext cx="380000" cy="97300"/>
           </a:xfrm>
           <a:prstGeom prst="rect">
@@ -7064,7 +6859,7 @@
                 <a:ea typeface="Roboto"/>
                 <a:cs typeface="Roboto"/>
               </a:rPr>
-              <a:t>± 373</a:t>
+              <a:t>± 461</a:t>
             </a:r>
             <a:endParaRPr lang="id-ID" sz="720"/>
           </a:p>
@@ -7072,13 +6867,13 @@
       </p:sp>
       <p:sp>
         <p:nvSpPr>
-          <p:cNvPr id="461" name="T"/>
-          <p:cNvSpPr txBox="1"/>
-          <p:nvPr/>
-        </p:nvSpPr>
-        <p:spPr>
-          <a:xfrm>
-            <a:off x="11201600" y="3962106"/>
+          <p:cNvPr id="454" name="T"/>
+          <p:cNvSpPr txBox="1"/>
+          <p:nvPr/>
+        </p:nvSpPr>
+        <p:spPr>
+          <a:xfrm>
+            <a:off x="11201600" y="3840480"/>
             <a:ext cx="200000" cy="97300"/>
           </a:xfrm>
           <a:prstGeom prst="rect">
@@ -7110,13 +6905,13 @@
       </p:sp>
       <p:cxnSp>
         <p:nvCxnSpPr>
-          <p:cNvPr id="462" name="L"/>
+          <p:cNvPr id="455" name="L"/>
           <p:cNvCxnSpPr/>
           <p:nvPr/>
         </p:nvCxnSpPr>
         <p:spPr>
           <a:xfrm>
-            <a:off x="8668512" y="4071569"/>
+            <a:off x="8668512" y="3949943"/>
             <a:ext cx="2809951" cy="0"/>
           </a:xfrm>
           <a:prstGeom prst="line">
@@ -7131,13 +6926,13 @@
       </p:cxnSp>
       <p:sp>
         <p:nvSpPr>
-          <p:cNvPr id="463" name="K"/>
+          <p:cNvPr id="456" name="K"/>
           <p:cNvSpPr/>
           <p:nvPr/>
         </p:nvSpPr>
         <p:spPr>
           <a:xfrm>
-            <a:off x="8668512" y="4083732"/>
+            <a:off x="8668512" y="3962106"/>
             <a:ext cx="97300" cy="97300"/>
           </a:xfrm>
           <a:prstGeom prst="ellipse">
@@ -7153,7 +6948,7 @@
       </p:sp>
       <p:pic>
         <p:nvPicPr>
-          <p:cNvPr id="464" name="G"/>
+          <p:cNvPr id="457" name="G"/>
           <p:cNvPicPr>
             <a:picLocks noChangeAspect="1"/>
           </p:cNvPicPr>
@@ -7167,7 +6962,7 @@
         </p:blipFill>
         <p:spPr>
           <a:xfrm>
-            <a:off x="8686999" y="4102219"/>
+            <a:off x="8686999" y="3980593"/>
             <a:ext cx="60326" cy="60326"/>
           </a:xfrm>
           <a:prstGeom prst="rect">
@@ -7177,280 +6972,13 @@
       </p:pic>
       <p:sp>
         <p:nvSpPr>
-          <p:cNvPr id="465" name="T"/>
-          <p:cNvSpPr txBox="1"/>
-          <p:nvPr/>
-        </p:nvSpPr>
-        <p:spPr>
-          <a:xfrm>
-            <a:off x="8869680" y="4050086"/>
-            <a:ext cx="1758391" cy="164592"/>
-          </a:xfrm>
-          <a:prstGeom prst="rect">
-            <a:avLst/>
-          </a:prstGeom>
-          <a:noFill/>
-        </p:spPr>
-        <p:txBody>
-          <a:bodyPr wrap="none" lIns="0" tIns="0" rIns="0" bIns="0" anchor="ctr"/>
-          <a:lstStyle/>
-          <a:p>
-            <a:pPr algn="l">
-              <a:buNone/>
-            </a:pPr>
-            <a:r>
-              <a:rPr lang="id-ID" sz="760" b="1" dirty="0">
-                <a:solidFill>
-                  <a:srgbClr val="1A1A1A"/>
-                </a:solidFill>
-                <a:latin typeface="Roboto"/>
-                <a:ea typeface="Roboto"/>
-                <a:cs typeface="Roboto"/>
-              </a:rPr>
-              <a:t>Sulawesi Selatan</a:t>
-            </a:r>
-            <a:endParaRPr lang="id-ID" sz="760"/>
-          </a:p>
-        </p:txBody>
-      </p:sp>
-      <p:sp>
-        <p:nvSpPr>
-          <p:cNvPr id="466" name="K"/>
+          <p:cNvPr id="458" name="K"/>
           <p:cNvSpPr/>
           <p:nvPr/>
         </p:nvSpPr>
         <p:spPr>
           <a:xfrm>
-            <a:off x="10470000" y="4083732"/>
-            <a:ext cx="1070000" cy="97300"/>
-          </a:xfrm>
-          <a:prstGeom prst="roundRect">
-            <a:avLst>
-              <a:gd name="adj" fmla="val 50000"/>
-            </a:avLst>
-          </a:prstGeom>
-          <a:solidFill>
-            <a:srgbClr val="FBE7D6"/>
-          </a:solidFill>
-          <a:ln>
-            <a:noFill/>
-          </a:ln>
-        </p:spPr>
-      </p:sp>
-      <p:pic>
-        <p:nvPicPr>
-          <p:cNvPr id="467" name="G"/>
-          <p:cNvPicPr>
-            <a:picLocks noChangeAspect="1"/>
-          </p:cNvPicPr>
-          <p:nvPr/>
-        </p:nvPicPr>
-        <p:blipFill>
-          <a:blip r:embed="rIdM13"/>
-          <a:stretch>
-            <a:fillRect/>
-          </a:stretch>
-        </p:blipFill>
-        <p:spPr>
-          <a:xfrm>
-            <a:off x="10520000" y="4099300"/>
-            <a:ext cx="66164" cy="66164"/>
-          </a:xfrm>
-          <a:prstGeom prst="rect">
-            <a:avLst/>
-          </a:prstGeom>
-        </p:spPr>
-      </p:pic>
-      <p:sp>
-        <p:nvSpPr>
-          <p:cNvPr id="468" name="T"/>
-          <p:cNvSpPr txBox="1"/>
-          <p:nvPr/>
-        </p:nvSpPr>
-        <p:spPr>
-          <a:xfrm>
-            <a:off x="10650000" y="4083732"/>
-            <a:ext cx="260000" cy="97300"/>
-          </a:xfrm>
-          <a:prstGeom prst="rect">
-            <a:avLst/>
-          </a:prstGeom>
-          <a:noFill/>
-        </p:spPr>
-        <p:txBody>
-          <a:bodyPr wrap="none" lIns="0" tIns="0" rIns="0" bIns="0" anchor="ctr"/>
-          <a:lstStyle/>
-          <a:p>
-            <a:pPr algn="l">
-              <a:buNone/>
-            </a:pPr>
-            <a:r>
-              <a:rPr lang="id-ID" sz="720" b="1" dirty="0">
-                <a:solidFill>
-                  <a:srgbClr val="D9600B"/>
-                </a:solidFill>
-                <a:latin typeface="Roboto"/>
-                <a:ea typeface="Roboto"/>
-                <a:cs typeface="Roboto"/>
-              </a:rPr>
-              <a:t>sisa</a:t>
-            </a:r>
-            <a:endParaRPr lang="id-ID" sz="720"/>
-          </a:p>
-        </p:txBody>
-      </p:sp>
-      <p:sp>
-        <p:nvSpPr>
-          <p:cNvPr id="469" name="T"/>
-          <p:cNvSpPr txBox="1"/>
-          <p:nvPr/>
-        </p:nvSpPr>
-        <p:spPr>
-          <a:xfrm>
-            <a:off x="10800000" y="4083732"/>
-            <a:ext cx="380000" cy="97300"/>
-          </a:xfrm>
-          <a:prstGeom prst="rect">
-            <a:avLst/>
-          </a:prstGeom>
-          <a:noFill/>
-        </p:spPr>
-        <p:txBody>
-          <a:bodyPr wrap="none" lIns="0" tIns="0" rIns="0" bIns="0" anchor="ctr"/>
-          <a:lstStyle/>
-          <a:p>
-            <a:pPr algn="r">
-              <a:buNone/>
-            </a:pPr>
-            <a:r>
-              <a:rPr lang="id-ID" sz="720" b="1" dirty="0">
-                <a:solidFill>
-                  <a:srgbClr val="D9600B"/>
-                </a:solidFill>
-                <a:latin typeface="Roboto"/>
-                <a:ea typeface="Roboto"/>
-                <a:cs typeface="Roboto"/>
-              </a:rPr>
-              <a:t>± 95</a:t>
-            </a:r>
-            <a:endParaRPr lang="id-ID" sz="720"/>
-          </a:p>
-        </p:txBody>
-      </p:sp>
-      <p:sp>
-        <p:nvSpPr>
-          <p:cNvPr id="470" name="T"/>
-          <p:cNvSpPr txBox="1"/>
-          <p:nvPr/>
-        </p:nvSpPr>
-        <p:spPr>
-          <a:xfrm>
-            <a:off x="11201600" y="4083732"/>
-            <a:ext cx="200000" cy="97300"/>
-          </a:xfrm>
-          <a:prstGeom prst="rect">
-            <a:avLst/>
-          </a:prstGeom>
-          <a:noFill/>
-        </p:spPr>
-        <p:txBody>
-          <a:bodyPr wrap="none" lIns="0" tIns="0" rIns="0" bIns="0" anchor="ctr"/>
-          <a:lstStyle/>
-          <a:p>
-            <a:pPr algn="l">
-              <a:buNone/>
-            </a:pPr>
-            <a:r>
-              <a:rPr lang="id-ID" sz="720" b="1" dirty="0">
-                <a:solidFill>
-                  <a:srgbClr val="D9600B"/>
-                </a:solidFill>
-                <a:latin typeface="Roboto"/>
-                <a:ea typeface="Roboto"/>
-                <a:cs typeface="Roboto"/>
-              </a:rPr>
-              <a:t>ha</a:t>
-            </a:r>
-            <a:endParaRPr lang="id-ID" sz="720"/>
-          </a:p>
-        </p:txBody>
-      </p:sp>
-      <p:cxnSp>
-        <p:nvCxnSpPr>
-          <p:cNvPr id="471" name="L"/>
-          <p:cNvCxnSpPr/>
-          <p:nvPr/>
-        </p:nvCxnSpPr>
-        <p:spPr>
-          <a:xfrm>
-            <a:off x="8668512" y="4193195"/>
-            <a:ext cx="2809951" cy="0"/>
-          </a:xfrm>
-          <a:prstGeom prst="line">
-            <a:avLst/>
-          </a:prstGeom>
-          <a:ln w="9525">
-            <a:solidFill>
-              <a:srgbClr val="F1F2F4"/>
-            </a:solidFill>
-          </a:ln>
-        </p:spPr>
-      </p:cxnSp>
-      <p:sp>
-        <p:nvSpPr>
-          <p:cNvPr id="472" name="K"/>
-          <p:cNvSpPr/>
-          <p:nvPr/>
-        </p:nvSpPr>
-        <p:spPr>
-          <a:xfrm>
-            <a:off x="8668512" y="4205358"/>
-            <a:ext cx="97300" cy="97300"/>
-          </a:xfrm>
-          <a:prstGeom prst="ellipse">
-            <a:avLst/>
-          </a:prstGeom>
-          <a:solidFill>
-            <a:srgbClr val="D9600B"/>
-          </a:solidFill>
-          <a:ln>
-            <a:noFill/>
-          </a:ln>
-        </p:spPr>
-      </p:sp>
-      <p:pic>
-        <p:nvPicPr>
-          <p:cNvPr id="473" name="G"/>
-          <p:cNvPicPr>
-            <a:picLocks noChangeAspect="1"/>
-          </p:cNvPicPr>
-          <p:nvPr/>
-        </p:nvPicPr>
-        <p:blipFill>
-          <a:blip r:embed="rIdM12"/>
-          <a:stretch>
-            <a:fillRect/>
-          </a:stretch>
-        </p:blipFill>
-        <p:spPr>
-          <a:xfrm>
-            <a:off x="8686999" y="4223845"/>
-            <a:ext cx="60326" cy="60326"/>
-          </a:xfrm>
-          <a:prstGeom prst="rect">
-            <a:avLst/>
-          </a:prstGeom>
-        </p:spPr>
-      </p:pic>
-      <p:sp>
-        <p:nvSpPr>
-          <p:cNvPr id="474" name="K"/>
-          <p:cNvSpPr/>
-          <p:nvPr/>
-        </p:nvSpPr>
-        <p:spPr>
-          <a:xfrm>
-            <a:off x="8736622" y="4185898"/>
+            <a:off x="8736622" y="3942646"/>
             <a:ext cx="53515" cy="53515"/>
           </a:xfrm>
           <a:prstGeom prst="ellipse">
@@ -7468,13 +6996,13 @@
       </p:sp>
       <p:sp>
         <p:nvSpPr>
-          <p:cNvPr id="475" name="T"/>
-          <p:cNvSpPr txBox="1"/>
-          <p:nvPr/>
-        </p:nvSpPr>
-        <p:spPr>
-          <a:xfrm>
-            <a:off x="8736622" y="4185898"/>
+          <p:cNvPr id="459" name="T"/>
+          <p:cNvSpPr txBox="1"/>
+          <p:nvPr/>
+        </p:nvSpPr>
+        <p:spPr>
+          <a:xfrm>
+            <a:off x="8736622" y="3942646"/>
             <a:ext cx="53515" cy="53515"/>
           </a:xfrm>
           <a:prstGeom prst="rect">
@@ -7506,13 +7034,13 @@
       </p:sp>
       <p:sp>
         <p:nvSpPr>
-          <p:cNvPr id="476" name="T"/>
-          <p:cNvSpPr txBox="1"/>
-          <p:nvPr/>
-        </p:nvSpPr>
-        <p:spPr>
-          <a:xfrm>
-            <a:off x="8869680" y="4171712"/>
+          <p:cNvPr id="460" name="T"/>
+          <p:cNvSpPr txBox="1"/>
+          <p:nvPr/>
+        </p:nvSpPr>
+        <p:spPr>
+          <a:xfrm>
+            <a:off x="8869680" y="3928460"/>
             <a:ext cx="1758391" cy="164592"/>
           </a:xfrm>
           <a:prstGeom prst="rect">
@@ -7536,7 +7064,7 @@
                 <a:ea typeface="Roboto"/>
                 <a:cs typeface="Roboto"/>
               </a:rPr>
-              <a:t>Sulawesi Tenggara</a:t>
+              <a:t>Papua Selatan</a:t>
             </a:r>
             <a:endParaRPr lang="id-ID" sz="760"/>
           </a:p>
@@ -7544,13 +7072,13 @@
       </p:sp>
       <p:sp>
         <p:nvSpPr>
-          <p:cNvPr id="477" name="K"/>
+          <p:cNvPr id="461" name="K"/>
           <p:cNvSpPr/>
           <p:nvPr/>
         </p:nvSpPr>
         <p:spPr>
           <a:xfrm>
-            <a:off x="10470000" y="4205358"/>
+            <a:off x="10470000" y="3962106"/>
             <a:ext cx="1070000" cy="97300"/>
           </a:xfrm>
           <a:prstGeom prst="roundRect">
@@ -7568,7 +7096,7 @@
       </p:sp>
       <p:pic>
         <p:nvPicPr>
-          <p:cNvPr id="478" name="G"/>
+          <p:cNvPr id="462" name="G"/>
           <p:cNvPicPr>
             <a:picLocks noChangeAspect="1"/>
           </p:cNvPicPr>
@@ -7582,7 +7110,7 @@
         </p:blipFill>
         <p:spPr>
           <a:xfrm>
-            <a:off x="10520000" y="4220926"/>
+            <a:off x="10520000" y="3977674"/>
             <a:ext cx="66164" cy="66164"/>
           </a:xfrm>
           <a:prstGeom prst="rect">
@@ -7592,13 +7120,13 @@
       </p:pic>
       <p:sp>
         <p:nvSpPr>
-          <p:cNvPr id="479" name="T"/>
-          <p:cNvSpPr txBox="1"/>
-          <p:nvPr/>
-        </p:nvSpPr>
-        <p:spPr>
-          <a:xfrm>
-            <a:off x="10650000" y="4205358"/>
+          <p:cNvPr id="463" name="T"/>
+          <p:cNvSpPr txBox="1"/>
+          <p:nvPr/>
+        </p:nvSpPr>
+        <p:spPr>
+          <a:xfrm>
+            <a:off x="10650000" y="3962106"/>
             <a:ext cx="260000" cy="97300"/>
           </a:xfrm>
           <a:prstGeom prst="rect">
@@ -7630,13 +7158,13 @@
       </p:sp>
       <p:sp>
         <p:nvSpPr>
-          <p:cNvPr id="480" name="T"/>
-          <p:cNvSpPr txBox="1"/>
-          <p:nvPr/>
-        </p:nvSpPr>
-        <p:spPr>
-          <a:xfrm>
-            <a:off x="10800000" y="4205358"/>
+          <p:cNvPr id="464" name="T"/>
+          <p:cNvSpPr txBox="1"/>
+          <p:nvPr/>
+        </p:nvSpPr>
+        <p:spPr>
+          <a:xfrm>
+            <a:off x="10800000" y="3962106"/>
             <a:ext cx="380000" cy="97300"/>
           </a:xfrm>
           <a:prstGeom prst="rect">
@@ -7660,7 +7188,7 @@
                 <a:ea typeface="Roboto"/>
                 <a:cs typeface="Roboto"/>
               </a:rPr>
-              <a:t>± 79</a:t>
+              <a:t>± 373</a:t>
             </a:r>
             <a:endParaRPr lang="id-ID" sz="720"/>
           </a:p>
@@ -7668,13 +7196,13 @@
       </p:sp>
       <p:sp>
         <p:nvSpPr>
-          <p:cNvPr id="481" name="T"/>
-          <p:cNvSpPr txBox="1"/>
-          <p:nvPr/>
-        </p:nvSpPr>
-        <p:spPr>
-          <a:xfrm>
-            <a:off x="11201600" y="4205358"/>
+          <p:cNvPr id="465" name="T"/>
+          <p:cNvSpPr txBox="1"/>
+          <p:nvPr/>
+        </p:nvSpPr>
+        <p:spPr>
+          <a:xfrm>
+            <a:off x="11201600" y="3962106"/>
             <a:ext cx="200000" cy="97300"/>
           </a:xfrm>
           <a:prstGeom prst="rect">
@@ -7706,13 +7234,13 @@
       </p:sp>
       <p:cxnSp>
         <p:nvCxnSpPr>
-          <p:cNvPr id="482" name="L"/>
+          <p:cNvPr id="466" name="L"/>
           <p:cNvCxnSpPr/>
           <p:nvPr/>
         </p:nvCxnSpPr>
         <p:spPr>
           <a:xfrm>
-            <a:off x="8668512" y="4314821"/>
+            <a:off x="8668512" y="4071569"/>
             <a:ext cx="2809951" cy="0"/>
           </a:xfrm>
           <a:prstGeom prst="line">
@@ -7727,13 +7255,13 @@
       </p:cxnSp>
       <p:sp>
         <p:nvSpPr>
-          <p:cNvPr id="483" name="K"/>
+          <p:cNvPr id="467" name="K"/>
           <p:cNvSpPr/>
           <p:nvPr/>
         </p:nvSpPr>
         <p:spPr>
           <a:xfrm>
-            <a:off x="8668512" y="4326984"/>
+            <a:off x="8668512" y="4083732"/>
             <a:ext cx="97300" cy="97300"/>
           </a:xfrm>
           <a:prstGeom prst="ellipse">
@@ -7749,7 +7277,7 @@
       </p:sp>
       <p:pic>
         <p:nvPicPr>
-          <p:cNvPr id="484" name="G"/>
+          <p:cNvPr id="468" name="G"/>
           <p:cNvPicPr>
             <a:picLocks noChangeAspect="1"/>
           </p:cNvPicPr>
@@ -7763,7 +7291,7 @@
         </p:blipFill>
         <p:spPr>
           <a:xfrm>
-            <a:off x="8686999" y="4345471"/>
+            <a:off x="8686999" y="4102219"/>
             <a:ext cx="60326" cy="60326"/>
           </a:xfrm>
           <a:prstGeom prst="rect">
@@ -7773,13 +7301,13 @@
       </p:pic>
       <p:sp>
         <p:nvSpPr>
-          <p:cNvPr id="485" name="T"/>
-          <p:cNvSpPr txBox="1"/>
-          <p:nvPr/>
-        </p:nvSpPr>
-        <p:spPr>
-          <a:xfrm>
-            <a:off x="8869680" y="4293338"/>
+          <p:cNvPr id="469" name="T"/>
+          <p:cNvSpPr txBox="1"/>
+          <p:nvPr/>
+        </p:nvSpPr>
+        <p:spPr>
+          <a:xfrm>
+            <a:off x="8869680" y="4050086"/>
             <a:ext cx="1758391" cy="164592"/>
           </a:xfrm>
           <a:prstGeom prst="rect">
@@ -7803,7 +7331,7 @@
                 <a:ea typeface="Roboto"/>
                 <a:cs typeface="Roboto"/>
               </a:rPr>
-              <a:t>Sulawesi Tengah</a:t>
+              <a:t>Sulawesi Selatan</a:t>
             </a:r>
             <a:endParaRPr lang="id-ID" sz="760"/>
           </a:p>
@@ -7811,13 +7339,13 @@
       </p:sp>
       <p:sp>
         <p:nvSpPr>
-          <p:cNvPr id="486" name="K"/>
+          <p:cNvPr id="470" name="K"/>
           <p:cNvSpPr/>
           <p:nvPr/>
         </p:nvSpPr>
         <p:spPr>
           <a:xfrm>
-            <a:off x="10470000" y="4326984"/>
+            <a:off x="10470000" y="4083732"/>
             <a:ext cx="1070000" cy="97300"/>
           </a:xfrm>
           <a:prstGeom prst="roundRect">
@@ -7835,7 +7363,7 @@
       </p:sp>
       <p:pic>
         <p:nvPicPr>
-          <p:cNvPr id="487" name="G"/>
+          <p:cNvPr id="471" name="G"/>
           <p:cNvPicPr>
             <a:picLocks noChangeAspect="1"/>
           </p:cNvPicPr>
@@ -7849,7 +7377,7 @@
         </p:blipFill>
         <p:spPr>
           <a:xfrm>
-            <a:off x="10520000" y="4342552"/>
+            <a:off x="10520000" y="4099300"/>
             <a:ext cx="66164" cy="66164"/>
           </a:xfrm>
           <a:prstGeom prst="rect">
@@ -7859,13 +7387,13 @@
       </p:pic>
       <p:sp>
         <p:nvSpPr>
-          <p:cNvPr id="488" name="T"/>
-          <p:cNvSpPr txBox="1"/>
-          <p:nvPr/>
-        </p:nvSpPr>
-        <p:spPr>
-          <a:xfrm>
-            <a:off x="10650000" y="4326984"/>
+          <p:cNvPr id="472" name="T"/>
+          <p:cNvSpPr txBox="1"/>
+          <p:nvPr/>
+        </p:nvSpPr>
+        <p:spPr>
+          <a:xfrm>
+            <a:off x="10650000" y="4083732"/>
             <a:ext cx="260000" cy="97300"/>
           </a:xfrm>
           <a:prstGeom prst="rect">
@@ -7897,13 +7425,13 @@
       </p:sp>
       <p:sp>
         <p:nvSpPr>
-          <p:cNvPr id="489" name="T"/>
-          <p:cNvSpPr txBox="1"/>
-          <p:nvPr/>
-        </p:nvSpPr>
-        <p:spPr>
-          <a:xfrm>
-            <a:off x="10800000" y="4326984"/>
+          <p:cNvPr id="473" name="T"/>
+          <p:cNvSpPr txBox="1"/>
+          <p:nvPr/>
+        </p:nvSpPr>
+        <p:spPr>
+          <a:xfrm>
+            <a:off x="10800000" y="4083732"/>
             <a:ext cx="380000" cy="97300"/>
           </a:xfrm>
           <a:prstGeom prst="rect">
@@ -7927,7 +7455,7 @@
                 <a:ea typeface="Roboto"/>
                 <a:cs typeface="Roboto"/>
               </a:rPr>
-              <a:t>± 64</a:t>
+              <a:t>± 95</a:t>
             </a:r>
             <a:endParaRPr lang="id-ID" sz="720"/>
           </a:p>
@@ -7935,13 +7463,13 @@
       </p:sp>
       <p:sp>
         <p:nvSpPr>
-          <p:cNvPr id="490" name="T"/>
-          <p:cNvSpPr txBox="1"/>
-          <p:nvPr/>
-        </p:nvSpPr>
-        <p:spPr>
-          <a:xfrm>
-            <a:off x="11201600" y="4326984"/>
+          <p:cNvPr id="474" name="T"/>
+          <p:cNvSpPr txBox="1"/>
+          <p:nvPr/>
+        </p:nvSpPr>
+        <p:spPr>
+          <a:xfrm>
+            <a:off x="11201600" y="4083732"/>
             <a:ext cx="200000" cy="97300"/>
           </a:xfrm>
           <a:prstGeom prst="rect">
@@ -7973,13 +7501,13 @@
       </p:sp>
       <p:cxnSp>
         <p:nvCxnSpPr>
-          <p:cNvPr id="491" name="L"/>
+          <p:cNvPr id="475" name="L"/>
           <p:cNvCxnSpPr/>
           <p:nvPr/>
         </p:nvCxnSpPr>
         <p:spPr>
           <a:xfrm>
-            <a:off x="8668512" y="4436447"/>
+            <a:off x="8668512" y="4193195"/>
             <a:ext cx="2809951" cy="0"/>
           </a:xfrm>
           <a:prstGeom prst="line">
@@ -7994,13 +7522,13 @@
       </p:cxnSp>
       <p:sp>
         <p:nvSpPr>
-          <p:cNvPr id="492" name="K"/>
+          <p:cNvPr id="476" name="K"/>
           <p:cNvSpPr/>
           <p:nvPr/>
         </p:nvSpPr>
         <p:spPr>
           <a:xfrm>
-            <a:off x="8668512" y="4448610"/>
+            <a:off x="8668512" y="4205358"/>
             <a:ext cx="97300" cy="97300"/>
           </a:xfrm>
           <a:prstGeom prst="ellipse">
@@ -8016,7 +7544,7 @@
       </p:sp>
       <p:pic>
         <p:nvPicPr>
-          <p:cNvPr id="493" name="G"/>
+          <p:cNvPr id="477" name="G"/>
           <p:cNvPicPr>
             <a:picLocks noChangeAspect="1"/>
           </p:cNvPicPr>
@@ -8030,7 +7558,7 @@
         </p:blipFill>
         <p:spPr>
           <a:xfrm>
-            <a:off x="8686999" y="4467097"/>
+            <a:off x="8686999" y="4223845"/>
             <a:ext cx="60326" cy="60326"/>
           </a:xfrm>
           <a:prstGeom prst="rect">
@@ -8040,280 +7568,13 @@
       </p:pic>
       <p:sp>
         <p:nvSpPr>
-          <p:cNvPr id="494" name="T"/>
-          <p:cNvSpPr txBox="1"/>
-          <p:nvPr/>
-        </p:nvSpPr>
-        <p:spPr>
-          <a:xfrm>
-            <a:off x="8869680" y="4414964"/>
-            <a:ext cx="1758391" cy="164592"/>
-          </a:xfrm>
-          <a:prstGeom prst="rect">
-            <a:avLst/>
-          </a:prstGeom>
-          <a:noFill/>
-        </p:spPr>
-        <p:txBody>
-          <a:bodyPr wrap="none" lIns="0" tIns="0" rIns="0" bIns="0" anchor="ctr"/>
-          <a:lstStyle/>
-          <a:p>
-            <a:pPr algn="l">
-              <a:buNone/>
-            </a:pPr>
-            <a:r>
-              <a:rPr lang="id-ID" sz="760" b="1" dirty="0">
-                <a:solidFill>
-                  <a:srgbClr val="1A1A1A"/>
-                </a:solidFill>
-                <a:latin typeface="Roboto"/>
-                <a:ea typeface="Roboto"/>
-                <a:cs typeface="Roboto"/>
-              </a:rPr>
-              <a:t>Kalimantan Selatan</a:t>
-            </a:r>
-            <a:endParaRPr lang="id-ID" sz="760"/>
-          </a:p>
-        </p:txBody>
-      </p:sp>
-      <p:sp>
-        <p:nvSpPr>
-          <p:cNvPr id="495" name="K"/>
+          <p:cNvPr id="478" name="K"/>
           <p:cNvSpPr/>
           <p:nvPr/>
         </p:nvSpPr>
         <p:spPr>
           <a:xfrm>
-            <a:off x="10470000" y="4448610"/>
-            <a:ext cx="1070000" cy="97300"/>
-          </a:xfrm>
-          <a:prstGeom prst="roundRect">
-            <a:avLst>
-              <a:gd name="adj" fmla="val 50000"/>
-            </a:avLst>
-          </a:prstGeom>
-          <a:solidFill>
-            <a:srgbClr val="FBE7D6"/>
-          </a:solidFill>
-          <a:ln>
-            <a:noFill/>
-          </a:ln>
-        </p:spPr>
-      </p:sp>
-      <p:pic>
-        <p:nvPicPr>
-          <p:cNvPr id="496" name="G"/>
-          <p:cNvPicPr>
-            <a:picLocks noChangeAspect="1"/>
-          </p:cNvPicPr>
-          <p:nvPr/>
-        </p:nvPicPr>
-        <p:blipFill>
-          <a:blip r:embed="rIdM13"/>
-          <a:stretch>
-            <a:fillRect/>
-          </a:stretch>
-        </p:blipFill>
-        <p:spPr>
-          <a:xfrm>
-            <a:off x="10520000" y="4464178"/>
-            <a:ext cx="66164" cy="66164"/>
-          </a:xfrm>
-          <a:prstGeom prst="rect">
-            <a:avLst/>
-          </a:prstGeom>
-        </p:spPr>
-      </p:pic>
-      <p:sp>
-        <p:nvSpPr>
-          <p:cNvPr id="497" name="T"/>
-          <p:cNvSpPr txBox="1"/>
-          <p:nvPr/>
-        </p:nvSpPr>
-        <p:spPr>
-          <a:xfrm>
-            <a:off x="10650000" y="4448610"/>
-            <a:ext cx="260000" cy="97300"/>
-          </a:xfrm>
-          <a:prstGeom prst="rect">
-            <a:avLst/>
-          </a:prstGeom>
-          <a:noFill/>
-        </p:spPr>
-        <p:txBody>
-          <a:bodyPr wrap="none" lIns="0" tIns="0" rIns="0" bIns="0" anchor="ctr"/>
-          <a:lstStyle/>
-          <a:p>
-            <a:pPr algn="l">
-              <a:buNone/>
-            </a:pPr>
-            <a:r>
-              <a:rPr lang="id-ID" sz="720" b="1" dirty="0">
-                <a:solidFill>
-                  <a:srgbClr val="D9600B"/>
-                </a:solidFill>
-                <a:latin typeface="Roboto"/>
-                <a:ea typeface="Roboto"/>
-                <a:cs typeface="Roboto"/>
-              </a:rPr>
-              <a:t>sisa</a:t>
-            </a:r>
-            <a:endParaRPr lang="id-ID" sz="720"/>
-          </a:p>
-        </p:txBody>
-      </p:sp>
-      <p:sp>
-        <p:nvSpPr>
-          <p:cNvPr id="498" name="T"/>
-          <p:cNvSpPr txBox="1"/>
-          <p:nvPr/>
-        </p:nvSpPr>
-        <p:spPr>
-          <a:xfrm>
-            <a:off x="10800000" y="4448610"/>
-            <a:ext cx="380000" cy="97300"/>
-          </a:xfrm>
-          <a:prstGeom prst="rect">
-            <a:avLst/>
-          </a:prstGeom>
-          <a:noFill/>
-        </p:spPr>
-        <p:txBody>
-          <a:bodyPr wrap="none" lIns="0" tIns="0" rIns="0" bIns="0" anchor="ctr"/>
-          <a:lstStyle/>
-          <a:p>
-            <a:pPr algn="r">
-              <a:buNone/>
-            </a:pPr>
-            <a:r>
-              <a:rPr lang="id-ID" sz="720" b="1" dirty="0">
-                <a:solidFill>
-                  <a:srgbClr val="D9600B"/>
-                </a:solidFill>
-                <a:latin typeface="Roboto"/>
-                <a:ea typeface="Roboto"/>
-                <a:cs typeface="Roboto"/>
-              </a:rPr>
-              <a:t>± 62</a:t>
-            </a:r>
-            <a:endParaRPr lang="id-ID" sz="720"/>
-          </a:p>
-        </p:txBody>
-      </p:sp>
-      <p:sp>
-        <p:nvSpPr>
-          <p:cNvPr id="499" name="T"/>
-          <p:cNvSpPr txBox="1"/>
-          <p:nvPr/>
-        </p:nvSpPr>
-        <p:spPr>
-          <a:xfrm>
-            <a:off x="11201600" y="4448610"/>
-            <a:ext cx="200000" cy="97300"/>
-          </a:xfrm>
-          <a:prstGeom prst="rect">
-            <a:avLst/>
-          </a:prstGeom>
-          <a:noFill/>
-        </p:spPr>
-        <p:txBody>
-          <a:bodyPr wrap="none" lIns="0" tIns="0" rIns="0" bIns="0" anchor="ctr"/>
-          <a:lstStyle/>
-          <a:p>
-            <a:pPr algn="l">
-              <a:buNone/>
-            </a:pPr>
-            <a:r>
-              <a:rPr lang="id-ID" sz="720" b="1" dirty="0">
-                <a:solidFill>
-                  <a:srgbClr val="D9600B"/>
-                </a:solidFill>
-                <a:latin typeface="Roboto"/>
-                <a:ea typeface="Roboto"/>
-                <a:cs typeface="Roboto"/>
-              </a:rPr>
-              <a:t>ha</a:t>
-            </a:r>
-            <a:endParaRPr lang="id-ID" sz="720"/>
-          </a:p>
-        </p:txBody>
-      </p:sp>
-      <p:cxnSp>
-        <p:nvCxnSpPr>
-          <p:cNvPr id="500" name="L"/>
-          <p:cNvCxnSpPr/>
-          <p:nvPr/>
-        </p:nvCxnSpPr>
-        <p:spPr>
-          <a:xfrm>
-            <a:off x="8668512" y="4558073"/>
-            <a:ext cx="2809951" cy="0"/>
-          </a:xfrm>
-          <a:prstGeom prst="line">
-            <a:avLst/>
-          </a:prstGeom>
-          <a:ln w="9525">
-            <a:solidFill>
-              <a:srgbClr val="F1F2F4"/>
-            </a:solidFill>
-          </a:ln>
-        </p:spPr>
-      </p:cxnSp>
-      <p:sp>
-        <p:nvSpPr>
-          <p:cNvPr id="501" name="K"/>
-          <p:cNvSpPr/>
-          <p:nvPr/>
-        </p:nvSpPr>
-        <p:spPr>
-          <a:xfrm>
-            <a:off x="8668512" y="4570236"/>
-            <a:ext cx="97300" cy="97300"/>
-          </a:xfrm>
-          <a:prstGeom prst="ellipse">
-            <a:avLst/>
-          </a:prstGeom>
-          <a:solidFill>
-            <a:srgbClr val="D9600B"/>
-          </a:solidFill>
-          <a:ln>
-            <a:noFill/>
-          </a:ln>
-        </p:spPr>
-      </p:sp>
-      <p:pic>
-        <p:nvPicPr>
-          <p:cNvPr id="502" name="G"/>
-          <p:cNvPicPr>
-            <a:picLocks noChangeAspect="1"/>
-          </p:cNvPicPr>
-          <p:nvPr/>
-        </p:nvPicPr>
-        <p:blipFill>
-          <a:blip r:embed="rIdM12"/>
-          <a:stretch>
-            <a:fillRect/>
-          </a:stretch>
-        </p:blipFill>
-        <p:spPr>
-          <a:xfrm>
-            <a:off x="8686999" y="4588723"/>
-            <a:ext cx="60326" cy="60326"/>
-          </a:xfrm>
-          <a:prstGeom prst="rect">
-            <a:avLst/>
-          </a:prstGeom>
-        </p:spPr>
-      </p:pic>
-      <p:sp>
-        <p:nvSpPr>
-          <p:cNvPr id="503" name="K"/>
-          <p:cNvSpPr/>
-          <p:nvPr/>
-        </p:nvSpPr>
-        <p:spPr>
-          <a:xfrm>
-            <a:off x="8736622" y="4550776"/>
+            <a:off x="8736622" y="4185898"/>
             <a:ext cx="53515" cy="53515"/>
           </a:xfrm>
           <a:prstGeom prst="ellipse">
@@ -8331,13 +7592,13 @@
       </p:sp>
       <p:sp>
         <p:nvSpPr>
-          <p:cNvPr id="504" name="T"/>
-          <p:cNvSpPr txBox="1"/>
-          <p:nvPr/>
-        </p:nvSpPr>
-        <p:spPr>
-          <a:xfrm>
-            <a:off x="8736622" y="4550776"/>
+          <p:cNvPr id="479" name="T"/>
+          <p:cNvSpPr txBox="1"/>
+          <p:nvPr/>
+        </p:nvSpPr>
+        <p:spPr>
+          <a:xfrm>
+            <a:off x="8736622" y="4185898"/>
             <a:ext cx="53515" cy="53515"/>
           </a:xfrm>
           <a:prstGeom prst="rect">
@@ -8369,13 +7630,13 @@
       </p:sp>
       <p:sp>
         <p:nvSpPr>
-          <p:cNvPr id="505" name="T"/>
-          <p:cNvSpPr txBox="1"/>
-          <p:nvPr/>
-        </p:nvSpPr>
-        <p:spPr>
-          <a:xfrm>
-            <a:off x="8869680" y="4536590"/>
+          <p:cNvPr id="480" name="T"/>
+          <p:cNvSpPr txBox="1"/>
+          <p:nvPr/>
+        </p:nvSpPr>
+        <p:spPr>
+          <a:xfrm>
+            <a:off x="8869680" y="4171712"/>
             <a:ext cx="1758391" cy="164592"/>
           </a:xfrm>
           <a:prstGeom prst="rect">
@@ -8399,7 +7660,7 @@
                 <a:ea typeface="Roboto"/>
                 <a:cs typeface="Roboto"/>
               </a:rPr>
-              <a:t>Sumatera Selatan</a:t>
+              <a:t>Sulawesi Tenggara</a:t>
             </a:r>
             <a:endParaRPr lang="id-ID" sz="760"/>
           </a:p>
@@ -8407,13 +7668,13 @@
       </p:sp>
       <p:sp>
         <p:nvSpPr>
-          <p:cNvPr id="506" name="K"/>
+          <p:cNvPr id="481" name="K"/>
           <p:cNvSpPr/>
           <p:nvPr/>
         </p:nvSpPr>
         <p:spPr>
           <a:xfrm>
-            <a:off x="10470000" y="4570236"/>
+            <a:off x="10470000" y="4205358"/>
             <a:ext cx="1070000" cy="97300"/>
           </a:xfrm>
           <a:prstGeom prst="roundRect">
@@ -8431,7 +7692,7 @@
       </p:sp>
       <p:pic>
         <p:nvPicPr>
-          <p:cNvPr id="507" name="G"/>
+          <p:cNvPr id="482" name="G"/>
           <p:cNvPicPr>
             <a:picLocks noChangeAspect="1"/>
           </p:cNvPicPr>
@@ -8445,7 +7706,7 @@
         </p:blipFill>
         <p:spPr>
           <a:xfrm>
-            <a:off x="10520000" y="4585804"/>
+            <a:off x="10520000" y="4220926"/>
             <a:ext cx="66164" cy="66164"/>
           </a:xfrm>
           <a:prstGeom prst="rect">
@@ -8455,13 +7716,13 @@
       </p:pic>
       <p:sp>
         <p:nvSpPr>
-          <p:cNvPr id="508" name="T"/>
-          <p:cNvSpPr txBox="1"/>
-          <p:nvPr/>
-        </p:nvSpPr>
-        <p:spPr>
-          <a:xfrm>
-            <a:off x="10650000" y="4570236"/>
+          <p:cNvPr id="483" name="T"/>
+          <p:cNvSpPr txBox="1"/>
+          <p:nvPr/>
+        </p:nvSpPr>
+        <p:spPr>
+          <a:xfrm>
+            <a:off x="10650000" y="4205358"/>
             <a:ext cx="260000" cy="97300"/>
           </a:xfrm>
           <a:prstGeom prst="rect">
@@ -8493,13 +7754,13 @@
       </p:sp>
       <p:sp>
         <p:nvSpPr>
-          <p:cNvPr id="509" name="T"/>
-          <p:cNvSpPr txBox="1"/>
-          <p:nvPr/>
-        </p:nvSpPr>
-        <p:spPr>
-          <a:xfrm>
-            <a:off x="10800000" y="4570236"/>
+          <p:cNvPr id="484" name="T"/>
+          <p:cNvSpPr txBox="1"/>
+          <p:nvPr/>
+        </p:nvSpPr>
+        <p:spPr>
+          <a:xfrm>
+            <a:off x="10800000" y="4205358"/>
             <a:ext cx="380000" cy="97300"/>
           </a:xfrm>
           <a:prstGeom prst="rect">
@@ -8523,7 +7784,7 @@
                 <a:ea typeface="Roboto"/>
                 <a:cs typeface="Roboto"/>
               </a:rPr>
-              <a:t>± 35</a:t>
+              <a:t>± 79</a:t>
             </a:r>
             <a:endParaRPr lang="id-ID" sz="720"/>
           </a:p>
@@ -8531,13 +7792,13 @@
       </p:sp>
       <p:sp>
         <p:nvSpPr>
-          <p:cNvPr id="510" name="T"/>
-          <p:cNvSpPr txBox="1"/>
-          <p:nvPr/>
-        </p:nvSpPr>
-        <p:spPr>
-          <a:xfrm>
-            <a:off x="11201600" y="4570236"/>
+          <p:cNvPr id="485" name="T"/>
+          <p:cNvSpPr txBox="1"/>
+          <p:nvPr/>
+        </p:nvSpPr>
+        <p:spPr>
+          <a:xfrm>
+            <a:off x="11201600" y="4205358"/>
             <a:ext cx="200000" cy="97300"/>
           </a:xfrm>
           <a:prstGeom prst="rect">
@@ -8569,13 +7830,13 @@
       </p:sp>
       <p:cxnSp>
         <p:nvCxnSpPr>
-          <p:cNvPr id="511" name="L"/>
+          <p:cNvPr id="486" name="L"/>
           <p:cNvCxnSpPr/>
           <p:nvPr/>
         </p:nvCxnSpPr>
         <p:spPr>
           <a:xfrm>
-            <a:off x="8668512" y="4679699"/>
+            <a:off x="8668512" y="4314821"/>
             <a:ext cx="2809951" cy="0"/>
           </a:xfrm>
           <a:prstGeom prst="line">
@@ -8590,20 +7851,20 @@
       </p:cxnSp>
       <p:sp>
         <p:nvSpPr>
-          <p:cNvPr id="512" name="K"/>
+          <p:cNvPr id="487" name="K"/>
           <p:cNvSpPr/>
           <p:nvPr/>
         </p:nvSpPr>
         <p:spPr>
           <a:xfrm>
-            <a:off x="8668512" y="4691862"/>
+            <a:off x="8668512" y="4326984"/>
             <a:ext cx="97300" cy="97300"/>
           </a:xfrm>
           <a:prstGeom prst="ellipse">
             <a:avLst/>
           </a:prstGeom>
           <a:solidFill>
-            <a:srgbClr val="B08A3E"/>
+            <a:srgbClr val="D9600B"/>
           </a:solidFill>
           <a:ln>
             <a:noFill/>
@@ -8612,21 +7873,21 @@
       </p:sp>
       <p:pic>
         <p:nvPicPr>
-          <p:cNvPr id="513" name="G"/>
+          <p:cNvPr id="488" name="G"/>
           <p:cNvPicPr>
             <a:picLocks noChangeAspect="1"/>
           </p:cNvPicPr>
           <p:nvPr/>
         </p:nvPicPr>
         <p:blipFill>
-          <a:blip r:embed="rIdM14"/>
+          <a:blip r:embed="rIdM12"/>
           <a:stretch>
             <a:fillRect/>
           </a:stretch>
         </p:blipFill>
         <p:spPr>
           <a:xfrm>
-            <a:off x="8686999" y="4710349"/>
+            <a:off x="8686999" y="4345471"/>
             <a:ext cx="60326" cy="60326"/>
           </a:xfrm>
           <a:prstGeom prst="rect">
@@ -8636,13 +7897,13 @@
       </p:pic>
       <p:sp>
         <p:nvSpPr>
-          <p:cNvPr id="514" name="T"/>
-          <p:cNvSpPr txBox="1"/>
-          <p:nvPr/>
-        </p:nvSpPr>
-        <p:spPr>
-          <a:xfrm>
-            <a:off x="8869680" y="4658216"/>
+          <p:cNvPr id="489" name="T"/>
+          <p:cNvSpPr txBox="1"/>
+          <p:nvPr/>
+        </p:nvSpPr>
+        <p:spPr>
+          <a:xfrm>
+            <a:off x="8869680" y="4293338"/>
             <a:ext cx="1758391" cy="164592"/>
           </a:xfrm>
           <a:prstGeom prst="rect">
@@ -8666,18 +7927,7 @@
                 <a:ea typeface="Roboto"/>
                 <a:cs typeface="Roboto"/>
               </a:rPr>
-              <a:t>Kekeringan</a:t>
-            </a:r>
-            <a:r>
-              <a:rPr lang="id-ID" sz="760" dirty="0">
-                <a:solidFill>
-                  <a:srgbClr val="2E3440"/>
-                </a:solidFill>
-                <a:latin typeface="Roboto"/>
-                <a:ea typeface="Roboto"/>
-                <a:cs typeface="Roboto"/>
-              </a:rPr>
-              <a:t>, 7 kab/kota di 4 provinsi</a:t>
+              <a:t>Sulawesi Tengah</a:t>
             </a:r>
             <a:endParaRPr lang="id-ID" sz="760"/>
           </a:p>
@@ -8685,13 +7935,13 @@
       </p:sp>
       <p:sp>
         <p:nvSpPr>
-          <p:cNvPr id="515" name="K"/>
+          <p:cNvPr id="490" name="K"/>
           <p:cNvSpPr/>
           <p:nvPr/>
         </p:nvSpPr>
         <p:spPr>
           <a:xfrm>
-            <a:off x="10470000" y="4691862"/>
+            <a:off x="10470000" y="4326984"/>
             <a:ext cx="1070000" cy="97300"/>
           </a:xfrm>
           <a:prstGeom prst="roundRect">
@@ -8700,7 +7950,7 @@
             </a:avLst>
           </a:prstGeom>
           <a:solidFill>
-            <a:srgbClr val="F4ECDC"/>
+            <a:srgbClr val="FBE7D6"/>
           </a:solidFill>
           <a:ln>
             <a:noFill/>
@@ -8709,21 +7959,21 @@
       </p:sp>
       <p:pic>
         <p:nvPicPr>
-          <p:cNvPr id="516" name="G"/>
+          <p:cNvPr id="491" name="G"/>
           <p:cNvPicPr>
             <a:picLocks noChangeAspect="1"/>
           </p:cNvPicPr>
           <p:nvPr/>
         </p:nvPicPr>
         <p:blipFill>
-          <a:blip r:embed="rIdM15"/>
+          <a:blip r:embed="rIdM13"/>
           <a:stretch>
             <a:fillRect/>
           </a:stretch>
         </p:blipFill>
         <p:spPr>
           <a:xfrm>
-            <a:off x="10520000" y="4707430"/>
+            <a:off x="10520000" y="4342552"/>
             <a:ext cx="66164" cy="66164"/>
           </a:xfrm>
           <a:prstGeom prst="rect">
@@ -8733,14 +7983,14 @@
       </p:pic>
       <p:sp>
         <p:nvSpPr>
-          <p:cNvPr id="517" name="T"/>
-          <p:cNvSpPr txBox="1"/>
-          <p:nvPr/>
-        </p:nvSpPr>
-        <p:spPr>
-          <a:xfrm>
-            <a:off x="10680000" y="4691862"/>
-            <a:ext cx="500000" cy="97300"/>
+          <p:cNvPr id="492" name="T"/>
+          <p:cNvSpPr txBox="1"/>
+          <p:nvPr/>
+        </p:nvSpPr>
+        <p:spPr>
+          <a:xfrm>
+            <a:off x="10650000" y="4326984"/>
+            <a:ext cx="260000" cy="97300"/>
           </a:xfrm>
           <a:prstGeom prst="rect">
             <a:avLst/>
@@ -8751,19 +8001,57 @@
           <a:bodyPr wrap="none" lIns="0" tIns="0" rIns="0" bIns="0" anchor="ctr"/>
           <a:lstStyle/>
           <a:p>
+            <a:pPr algn="l">
+              <a:buNone/>
+            </a:pPr>
+            <a:r>
+              <a:rPr lang="id-ID" sz="720" b="1" dirty="0">
+                <a:solidFill>
+                  <a:srgbClr val="D9600B"/>
+                </a:solidFill>
+                <a:latin typeface="Roboto"/>
+                <a:ea typeface="Roboto"/>
+                <a:cs typeface="Roboto"/>
+              </a:rPr>
+              <a:t>sisa</a:t>
+            </a:r>
+            <a:endParaRPr lang="id-ID" sz="720"/>
+          </a:p>
+        </p:txBody>
+      </p:sp>
+      <p:sp>
+        <p:nvSpPr>
+          <p:cNvPr id="493" name="T"/>
+          <p:cNvSpPr txBox="1"/>
+          <p:nvPr/>
+        </p:nvSpPr>
+        <p:spPr>
+          <a:xfrm>
+            <a:off x="10800000" y="4326984"/>
+            <a:ext cx="380000" cy="97300"/>
+          </a:xfrm>
+          <a:prstGeom prst="rect">
+            <a:avLst/>
+          </a:prstGeom>
+          <a:noFill/>
+        </p:spPr>
+        <p:txBody>
+          <a:bodyPr wrap="none" lIns="0" tIns="0" rIns="0" bIns="0" anchor="ctr"/>
+          <a:lstStyle/>
+          <a:p>
             <a:pPr algn="r">
               <a:buNone/>
             </a:pPr>
             <a:r>
               <a:rPr lang="id-ID" sz="720" b="1" dirty="0">
                 <a:solidFill>
-                  <a:srgbClr val="8A6A2E"/>
-                </a:solidFill>
-                <a:latin typeface="Roboto"/>
-                <a:ea typeface="Roboto"/>
-                <a:cs typeface="Roboto"/>
-              </a:rPr>
-              <a:t>24.400</a:t>
+                  <a:srgbClr val="D9600B"/>
+                </a:solidFill>
+                <a:latin typeface="Roboto"/>
+                <a:ea typeface="Roboto"/>
+                <a:cs typeface="Roboto"/>
+              </a:rPr>
+              <a:t>± 64</a:t>
             </a:r>
             <a:endParaRPr lang="id-ID" sz="720"/>
           </a:p>
@@ -8771,14 +8059,14 @@
       </p:sp>
       <p:sp>
         <p:nvSpPr>
-          <p:cNvPr id="518" name="T"/>
-          <p:cNvSpPr txBox="1"/>
-          <p:nvPr/>
-        </p:nvSpPr>
-        <p:spPr>
-          <a:xfrm>
-            <a:off x="11201600" y="4691862"/>
-            <a:ext cx="300000" cy="97300"/>
+          <p:cNvPr id="494" name="T"/>
+          <p:cNvSpPr txBox="1"/>
+          <p:nvPr/>
+        </p:nvSpPr>
+        <p:spPr>
+          <a:xfrm>
+            <a:off x="11201600" y="4326984"/>
+            <a:ext cx="200000" cy="97300"/>
           </a:xfrm>
           <a:prstGeom prst="rect">
             <a:avLst/>
@@ -8795,13 +8083,13 @@
             <a:r>
               <a:rPr lang="id-ID" sz="720" b="1" dirty="0">
                 <a:solidFill>
-                  <a:srgbClr val="8A6A2E"/>
-                </a:solidFill>
-                <a:latin typeface="Roboto"/>
-                <a:ea typeface="Roboto"/>
-                <a:cs typeface="Roboto"/>
-              </a:rPr>
-              <a:t>KK</a:t>
+                  <a:srgbClr val="D9600B"/>
+                </a:solidFill>
+                <a:latin typeface="Roboto"/>
+                <a:ea typeface="Roboto"/>
+                <a:cs typeface="Roboto"/>
+              </a:rPr>
+              <a:t>ha</a:t>
             </a:r>
             <a:endParaRPr lang="id-ID" sz="720"/>
           </a:p>
@@ -8809,13 +8097,13 @@
       </p:sp>
       <p:cxnSp>
         <p:nvCxnSpPr>
-          <p:cNvPr id="519" name="L"/>
+          <p:cNvPr id="495" name="L"/>
           <p:cNvCxnSpPr/>
           <p:nvPr/>
         </p:nvCxnSpPr>
         <p:spPr>
           <a:xfrm>
-            <a:off x="8668512" y="4801325"/>
+            <a:off x="8668512" y="4436447"/>
             <a:ext cx="2809951" cy="0"/>
           </a:xfrm>
           <a:prstGeom prst="line">
@@ -8830,20 +8118,20 @@
       </p:cxnSp>
       <p:sp>
         <p:nvSpPr>
-          <p:cNvPr id="520" name="K"/>
+          <p:cNvPr id="496" name="K"/>
           <p:cNvSpPr/>
           <p:nvPr/>
         </p:nvSpPr>
         <p:spPr>
           <a:xfrm>
-            <a:off x="8668512" y="4813488"/>
+            <a:off x="8668512" y="4448610"/>
             <a:ext cx="97300" cy="97300"/>
           </a:xfrm>
           <a:prstGeom prst="ellipse">
             <a:avLst/>
           </a:prstGeom>
           <a:solidFill>
-            <a:srgbClr val="2F6FB5"/>
+            <a:srgbClr val="D9600B"/>
           </a:solidFill>
           <a:ln>
             <a:noFill/>
@@ -8852,21 +8140,21 @@
       </p:sp>
       <p:pic>
         <p:nvPicPr>
-          <p:cNvPr id="521" name="G"/>
+          <p:cNvPr id="497" name="G"/>
           <p:cNvPicPr>
             <a:picLocks noChangeAspect="1"/>
           </p:cNvPicPr>
           <p:nvPr/>
         </p:nvPicPr>
         <p:blipFill>
-          <a:blip r:embed="rIdM16"/>
+          <a:blip r:embed="rIdM12"/>
           <a:stretch>
             <a:fillRect/>
           </a:stretch>
         </p:blipFill>
         <p:spPr>
           <a:xfrm>
-            <a:off x="8686999" y="4831975"/>
+            <a:off x="8686999" y="4467097"/>
             <a:ext cx="60326" cy="60326"/>
           </a:xfrm>
           <a:prstGeom prst="rect">
@@ -8876,13 +8164,280 @@
       </p:pic>
       <p:sp>
         <p:nvSpPr>
-          <p:cNvPr id="522" name="K"/>
+          <p:cNvPr id="498" name="T"/>
+          <p:cNvSpPr txBox="1"/>
+          <p:nvPr/>
+        </p:nvSpPr>
+        <p:spPr>
+          <a:xfrm>
+            <a:off x="8869680" y="4414964"/>
+            <a:ext cx="1758391" cy="164592"/>
+          </a:xfrm>
+          <a:prstGeom prst="rect">
+            <a:avLst/>
+          </a:prstGeom>
+          <a:noFill/>
+        </p:spPr>
+        <p:txBody>
+          <a:bodyPr wrap="none" lIns="0" tIns="0" rIns="0" bIns="0" anchor="ctr"/>
+          <a:lstStyle/>
+          <a:p>
+            <a:pPr algn="l">
+              <a:buNone/>
+            </a:pPr>
+            <a:r>
+              <a:rPr lang="id-ID" sz="760" b="1" dirty="0">
+                <a:solidFill>
+                  <a:srgbClr val="1A1A1A"/>
+                </a:solidFill>
+                <a:latin typeface="Roboto"/>
+                <a:ea typeface="Roboto"/>
+                <a:cs typeface="Roboto"/>
+              </a:rPr>
+              <a:t>Kalimantan Selatan</a:t>
+            </a:r>
+            <a:endParaRPr lang="id-ID" sz="760"/>
+          </a:p>
+        </p:txBody>
+      </p:sp>
+      <p:sp>
+        <p:nvSpPr>
+          <p:cNvPr id="499" name="K"/>
           <p:cNvSpPr/>
           <p:nvPr/>
         </p:nvSpPr>
         <p:spPr>
           <a:xfrm>
-            <a:off x="8736622" y="4794028"/>
+            <a:off x="10470000" y="4448610"/>
+            <a:ext cx="1070000" cy="97300"/>
+          </a:xfrm>
+          <a:prstGeom prst="roundRect">
+            <a:avLst>
+              <a:gd name="adj" fmla="val 50000"/>
+            </a:avLst>
+          </a:prstGeom>
+          <a:solidFill>
+            <a:srgbClr val="FBE7D6"/>
+          </a:solidFill>
+          <a:ln>
+            <a:noFill/>
+          </a:ln>
+        </p:spPr>
+      </p:sp>
+      <p:pic>
+        <p:nvPicPr>
+          <p:cNvPr id="500" name="G"/>
+          <p:cNvPicPr>
+            <a:picLocks noChangeAspect="1"/>
+          </p:cNvPicPr>
+          <p:nvPr/>
+        </p:nvPicPr>
+        <p:blipFill>
+          <a:blip r:embed="rIdM13"/>
+          <a:stretch>
+            <a:fillRect/>
+          </a:stretch>
+        </p:blipFill>
+        <p:spPr>
+          <a:xfrm>
+            <a:off x="10520000" y="4464178"/>
+            <a:ext cx="66164" cy="66164"/>
+          </a:xfrm>
+          <a:prstGeom prst="rect">
+            <a:avLst/>
+          </a:prstGeom>
+        </p:spPr>
+      </p:pic>
+      <p:sp>
+        <p:nvSpPr>
+          <p:cNvPr id="501" name="T"/>
+          <p:cNvSpPr txBox="1"/>
+          <p:nvPr/>
+        </p:nvSpPr>
+        <p:spPr>
+          <a:xfrm>
+            <a:off x="10650000" y="4448610"/>
+            <a:ext cx="260000" cy="97300"/>
+          </a:xfrm>
+          <a:prstGeom prst="rect">
+            <a:avLst/>
+          </a:prstGeom>
+          <a:noFill/>
+        </p:spPr>
+        <p:txBody>
+          <a:bodyPr wrap="none" lIns="0" tIns="0" rIns="0" bIns="0" anchor="ctr"/>
+          <a:lstStyle/>
+          <a:p>
+            <a:pPr algn="l">
+              <a:buNone/>
+            </a:pPr>
+            <a:r>
+              <a:rPr lang="id-ID" sz="720" b="1" dirty="0">
+                <a:solidFill>
+                  <a:srgbClr val="D9600B"/>
+                </a:solidFill>
+                <a:latin typeface="Roboto"/>
+                <a:ea typeface="Roboto"/>
+                <a:cs typeface="Roboto"/>
+              </a:rPr>
+              <a:t>sisa</a:t>
+            </a:r>
+            <a:endParaRPr lang="id-ID" sz="720"/>
+          </a:p>
+        </p:txBody>
+      </p:sp>
+      <p:sp>
+        <p:nvSpPr>
+          <p:cNvPr id="502" name="T"/>
+          <p:cNvSpPr txBox="1"/>
+          <p:nvPr/>
+        </p:nvSpPr>
+        <p:spPr>
+          <a:xfrm>
+            <a:off x="10800000" y="4448610"/>
+            <a:ext cx="380000" cy="97300"/>
+          </a:xfrm>
+          <a:prstGeom prst="rect">
+            <a:avLst/>
+          </a:prstGeom>
+          <a:noFill/>
+        </p:spPr>
+        <p:txBody>
+          <a:bodyPr wrap="none" lIns="0" tIns="0" rIns="0" bIns="0" anchor="ctr"/>
+          <a:lstStyle/>
+          <a:p>
+            <a:pPr algn="r">
+              <a:buNone/>
+            </a:pPr>
+            <a:r>
+              <a:rPr lang="id-ID" sz="720" b="1" dirty="0">
+                <a:solidFill>
+                  <a:srgbClr val="D9600B"/>
+                </a:solidFill>
+                <a:latin typeface="Roboto"/>
+                <a:ea typeface="Roboto"/>
+                <a:cs typeface="Roboto"/>
+              </a:rPr>
+              <a:t>± 62</a:t>
+            </a:r>
+            <a:endParaRPr lang="id-ID" sz="720"/>
+          </a:p>
+        </p:txBody>
+      </p:sp>
+      <p:sp>
+        <p:nvSpPr>
+          <p:cNvPr id="503" name="T"/>
+          <p:cNvSpPr txBox="1"/>
+          <p:nvPr/>
+        </p:nvSpPr>
+        <p:spPr>
+          <a:xfrm>
+            <a:off x="11201600" y="4448610"/>
+            <a:ext cx="200000" cy="97300"/>
+          </a:xfrm>
+          <a:prstGeom prst="rect">
+            <a:avLst/>
+          </a:prstGeom>
+          <a:noFill/>
+        </p:spPr>
+        <p:txBody>
+          <a:bodyPr wrap="none" lIns="0" tIns="0" rIns="0" bIns="0" anchor="ctr"/>
+          <a:lstStyle/>
+          <a:p>
+            <a:pPr algn="l">
+              <a:buNone/>
+            </a:pPr>
+            <a:r>
+              <a:rPr lang="id-ID" sz="720" b="1" dirty="0">
+                <a:solidFill>
+                  <a:srgbClr val="D9600B"/>
+                </a:solidFill>
+                <a:latin typeface="Roboto"/>
+                <a:ea typeface="Roboto"/>
+                <a:cs typeface="Roboto"/>
+              </a:rPr>
+              <a:t>ha</a:t>
+            </a:r>
+            <a:endParaRPr lang="id-ID" sz="720"/>
+          </a:p>
+        </p:txBody>
+      </p:sp>
+      <p:cxnSp>
+        <p:nvCxnSpPr>
+          <p:cNvPr id="504" name="L"/>
+          <p:cNvCxnSpPr/>
+          <p:nvPr/>
+        </p:nvCxnSpPr>
+        <p:spPr>
+          <a:xfrm>
+            <a:off x="8668512" y="4558073"/>
+            <a:ext cx="2809951" cy="0"/>
+          </a:xfrm>
+          <a:prstGeom prst="line">
+            <a:avLst/>
+          </a:prstGeom>
+          <a:ln w="9525">
+            <a:solidFill>
+              <a:srgbClr val="F1F2F4"/>
+            </a:solidFill>
+          </a:ln>
+        </p:spPr>
+      </p:cxnSp>
+      <p:sp>
+        <p:nvSpPr>
+          <p:cNvPr id="505" name="K"/>
+          <p:cNvSpPr/>
+          <p:nvPr/>
+        </p:nvSpPr>
+        <p:spPr>
+          <a:xfrm>
+            <a:off x="8668512" y="4570236"/>
+            <a:ext cx="97300" cy="97300"/>
+          </a:xfrm>
+          <a:prstGeom prst="ellipse">
+            <a:avLst/>
+          </a:prstGeom>
+          <a:solidFill>
+            <a:srgbClr val="D9600B"/>
+          </a:solidFill>
+          <a:ln>
+            <a:noFill/>
+          </a:ln>
+        </p:spPr>
+      </p:sp>
+      <p:pic>
+        <p:nvPicPr>
+          <p:cNvPr id="506" name="G"/>
+          <p:cNvPicPr>
+            <a:picLocks noChangeAspect="1"/>
+          </p:cNvPicPr>
+          <p:nvPr/>
+        </p:nvPicPr>
+        <p:blipFill>
+          <a:blip r:embed="rIdM12"/>
+          <a:stretch>
+            <a:fillRect/>
+          </a:stretch>
+        </p:blipFill>
+        <p:spPr>
+          <a:xfrm>
+            <a:off x="8686999" y="4588723"/>
+            <a:ext cx="60326" cy="60326"/>
+          </a:xfrm>
+          <a:prstGeom prst="rect">
+            <a:avLst/>
+          </a:prstGeom>
+        </p:spPr>
+      </p:pic>
+      <p:sp>
+        <p:nvSpPr>
+          <p:cNvPr id="507" name="K"/>
+          <p:cNvSpPr/>
+          <p:nvPr/>
+        </p:nvSpPr>
+        <p:spPr>
+          <a:xfrm>
+            <a:off x="8736622" y="4550776"/>
             <a:ext cx="53515" cy="53515"/>
           </a:xfrm>
           <a:prstGeom prst="ellipse">
@@ -8900,8 +8455,553 @@
       </p:sp>
       <p:sp>
         <p:nvSpPr>
-          <p:cNvPr id="523" name="T"/>
-          <p:cNvSpPr txBox="1"/>
+          <p:cNvPr id="508" name="T"/>
+          <p:cNvSpPr txBox="1"/>
+          <p:nvPr/>
+        </p:nvSpPr>
+        <p:spPr>
+          <a:xfrm>
+            <a:off x="8736622" y="4550776"/>
+            <a:ext cx="53515" cy="53515"/>
+          </a:xfrm>
+          <a:prstGeom prst="rect">
+            <a:avLst/>
+          </a:prstGeom>
+          <a:noFill/>
+        </p:spPr>
+        <p:txBody>
+          <a:bodyPr wrap="square" lIns="0" tIns="0" rIns="0" bIns="0" anchor="ctr"/>
+          <a:lstStyle/>
+          <a:p>
+            <a:pPr algn="ctr">
+              <a:buNone/>
+            </a:pPr>
+            <a:r>
+              <a:rPr lang="id-ID" sz="700" b="1" dirty="0">
+                <a:solidFill>
+                  <a:srgbClr val="FFFFFF"/>
+                </a:solidFill>
+                <a:latin typeface="Roboto"/>
+                <a:ea typeface="Roboto"/>
+                <a:cs typeface="Roboto"/>
+              </a:rPr>
+              <a:t>!</a:t>
+            </a:r>
+            <a:endParaRPr lang="id-ID" sz="500"/>
+          </a:p>
+        </p:txBody>
+      </p:sp>
+      <p:sp>
+        <p:nvSpPr>
+          <p:cNvPr id="509" name="T"/>
+          <p:cNvSpPr txBox="1"/>
+          <p:nvPr/>
+        </p:nvSpPr>
+        <p:spPr>
+          <a:xfrm>
+            <a:off x="8869680" y="4536590"/>
+            <a:ext cx="1758391" cy="164592"/>
+          </a:xfrm>
+          <a:prstGeom prst="rect">
+            <a:avLst/>
+          </a:prstGeom>
+          <a:noFill/>
+        </p:spPr>
+        <p:txBody>
+          <a:bodyPr wrap="none" lIns="0" tIns="0" rIns="0" bIns="0" anchor="ctr"/>
+          <a:lstStyle/>
+          <a:p>
+            <a:pPr algn="l">
+              <a:buNone/>
+            </a:pPr>
+            <a:r>
+              <a:rPr lang="id-ID" sz="760" b="1" dirty="0">
+                <a:solidFill>
+                  <a:srgbClr val="1A1A1A"/>
+                </a:solidFill>
+                <a:latin typeface="Roboto"/>
+                <a:ea typeface="Roboto"/>
+                <a:cs typeface="Roboto"/>
+              </a:rPr>
+              <a:t>Sumatera Selatan</a:t>
+            </a:r>
+            <a:endParaRPr lang="id-ID" sz="760"/>
+          </a:p>
+        </p:txBody>
+      </p:sp>
+      <p:sp>
+        <p:nvSpPr>
+          <p:cNvPr id="510" name="K"/>
+          <p:cNvSpPr/>
+          <p:nvPr/>
+        </p:nvSpPr>
+        <p:spPr>
+          <a:xfrm>
+            <a:off x="10470000" y="4570236"/>
+            <a:ext cx="1070000" cy="97300"/>
+          </a:xfrm>
+          <a:prstGeom prst="roundRect">
+            <a:avLst>
+              <a:gd name="adj" fmla="val 50000"/>
+            </a:avLst>
+          </a:prstGeom>
+          <a:solidFill>
+            <a:srgbClr val="FBE7D6"/>
+          </a:solidFill>
+          <a:ln>
+            <a:noFill/>
+          </a:ln>
+        </p:spPr>
+      </p:sp>
+      <p:pic>
+        <p:nvPicPr>
+          <p:cNvPr id="511" name="G"/>
+          <p:cNvPicPr>
+            <a:picLocks noChangeAspect="1"/>
+          </p:cNvPicPr>
+          <p:nvPr/>
+        </p:nvPicPr>
+        <p:blipFill>
+          <a:blip r:embed="rIdM13"/>
+          <a:stretch>
+            <a:fillRect/>
+          </a:stretch>
+        </p:blipFill>
+        <p:spPr>
+          <a:xfrm>
+            <a:off x="10520000" y="4585804"/>
+            <a:ext cx="66164" cy="66164"/>
+          </a:xfrm>
+          <a:prstGeom prst="rect">
+            <a:avLst/>
+          </a:prstGeom>
+        </p:spPr>
+      </p:pic>
+      <p:sp>
+        <p:nvSpPr>
+          <p:cNvPr id="512" name="T"/>
+          <p:cNvSpPr txBox="1"/>
+          <p:nvPr/>
+        </p:nvSpPr>
+        <p:spPr>
+          <a:xfrm>
+            <a:off x="10650000" y="4570236"/>
+            <a:ext cx="260000" cy="97300"/>
+          </a:xfrm>
+          <a:prstGeom prst="rect">
+            <a:avLst/>
+          </a:prstGeom>
+          <a:noFill/>
+        </p:spPr>
+        <p:txBody>
+          <a:bodyPr wrap="none" lIns="0" tIns="0" rIns="0" bIns="0" anchor="ctr"/>
+          <a:lstStyle/>
+          <a:p>
+            <a:pPr algn="l">
+              <a:buNone/>
+            </a:pPr>
+            <a:r>
+              <a:rPr lang="id-ID" sz="720" b="1" dirty="0">
+                <a:solidFill>
+                  <a:srgbClr val="D9600B"/>
+                </a:solidFill>
+                <a:latin typeface="Roboto"/>
+                <a:ea typeface="Roboto"/>
+                <a:cs typeface="Roboto"/>
+              </a:rPr>
+              <a:t>sisa</a:t>
+            </a:r>
+            <a:endParaRPr lang="id-ID" sz="720"/>
+          </a:p>
+        </p:txBody>
+      </p:sp>
+      <p:sp>
+        <p:nvSpPr>
+          <p:cNvPr id="513" name="T"/>
+          <p:cNvSpPr txBox="1"/>
+          <p:nvPr/>
+        </p:nvSpPr>
+        <p:spPr>
+          <a:xfrm>
+            <a:off x="10800000" y="4570236"/>
+            <a:ext cx="380000" cy="97300"/>
+          </a:xfrm>
+          <a:prstGeom prst="rect">
+            <a:avLst/>
+          </a:prstGeom>
+          <a:noFill/>
+        </p:spPr>
+        <p:txBody>
+          <a:bodyPr wrap="none" lIns="0" tIns="0" rIns="0" bIns="0" anchor="ctr"/>
+          <a:lstStyle/>
+          <a:p>
+            <a:pPr algn="r">
+              <a:buNone/>
+            </a:pPr>
+            <a:r>
+              <a:rPr lang="id-ID" sz="720" b="1" dirty="0">
+                <a:solidFill>
+                  <a:srgbClr val="D9600B"/>
+                </a:solidFill>
+                <a:latin typeface="Roboto"/>
+                <a:ea typeface="Roboto"/>
+                <a:cs typeface="Roboto"/>
+              </a:rPr>
+              <a:t>± 35</a:t>
+            </a:r>
+            <a:endParaRPr lang="id-ID" sz="720"/>
+          </a:p>
+        </p:txBody>
+      </p:sp>
+      <p:sp>
+        <p:nvSpPr>
+          <p:cNvPr id="514" name="T"/>
+          <p:cNvSpPr txBox="1"/>
+          <p:nvPr/>
+        </p:nvSpPr>
+        <p:spPr>
+          <a:xfrm>
+            <a:off x="11201600" y="4570236"/>
+            <a:ext cx="200000" cy="97300"/>
+          </a:xfrm>
+          <a:prstGeom prst="rect">
+            <a:avLst/>
+          </a:prstGeom>
+          <a:noFill/>
+        </p:spPr>
+        <p:txBody>
+          <a:bodyPr wrap="none" lIns="0" tIns="0" rIns="0" bIns="0" anchor="ctr"/>
+          <a:lstStyle/>
+          <a:p>
+            <a:pPr algn="l">
+              <a:buNone/>
+            </a:pPr>
+            <a:r>
+              <a:rPr lang="id-ID" sz="720" b="1" dirty="0">
+                <a:solidFill>
+                  <a:srgbClr val="D9600B"/>
+                </a:solidFill>
+                <a:latin typeface="Roboto"/>
+                <a:ea typeface="Roboto"/>
+                <a:cs typeface="Roboto"/>
+              </a:rPr>
+              <a:t>ha</a:t>
+            </a:r>
+            <a:endParaRPr lang="id-ID" sz="720"/>
+          </a:p>
+        </p:txBody>
+      </p:sp>
+      <p:cxnSp>
+        <p:nvCxnSpPr>
+          <p:cNvPr id="515" name="L"/>
+          <p:cNvCxnSpPr/>
+          <p:nvPr/>
+        </p:nvCxnSpPr>
+        <p:spPr>
+          <a:xfrm>
+            <a:off x="8668512" y="4679699"/>
+            <a:ext cx="2809951" cy="0"/>
+          </a:xfrm>
+          <a:prstGeom prst="line">
+            <a:avLst/>
+          </a:prstGeom>
+          <a:ln w="9525">
+            <a:solidFill>
+              <a:srgbClr val="F1F2F4"/>
+            </a:solidFill>
+          </a:ln>
+        </p:spPr>
+      </p:cxnSp>
+      <p:sp>
+        <p:nvSpPr>
+          <p:cNvPr id="516" name="K"/>
+          <p:cNvSpPr/>
+          <p:nvPr/>
+        </p:nvSpPr>
+        <p:spPr>
+          <a:xfrm>
+            <a:off x="8668512" y="4691862"/>
+            <a:ext cx="97300" cy="97300"/>
+          </a:xfrm>
+          <a:prstGeom prst="ellipse">
+            <a:avLst/>
+          </a:prstGeom>
+          <a:solidFill>
+            <a:srgbClr val="B08A3E"/>
+          </a:solidFill>
+          <a:ln>
+            <a:noFill/>
+          </a:ln>
+        </p:spPr>
+      </p:sp>
+      <p:pic>
+        <p:nvPicPr>
+          <p:cNvPr id="517" name="G"/>
+          <p:cNvPicPr>
+            <a:picLocks noChangeAspect="1"/>
+          </p:cNvPicPr>
+          <p:nvPr/>
+        </p:nvPicPr>
+        <p:blipFill>
+          <a:blip r:embed="rIdM14"/>
+          <a:stretch>
+            <a:fillRect/>
+          </a:stretch>
+        </p:blipFill>
+        <p:spPr>
+          <a:xfrm>
+            <a:off x="8686999" y="4710349"/>
+            <a:ext cx="60326" cy="60326"/>
+          </a:xfrm>
+          <a:prstGeom prst="rect">
+            <a:avLst/>
+          </a:prstGeom>
+        </p:spPr>
+      </p:pic>
+      <p:sp>
+        <p:nvSpPr>
+          <p:cNvPr id="518" name="T"/>
+          <p:cNvSpPr txBox="1"/>
+          <p:nvPr/>
+        </p:nvSpPr>
+        <p:spPr>
+          <a:xfrm>
+            <a:off x="8869680" y="4658216"/>
+            <a:ext cx="1758391" cy="164592"/>
+          </a:xfrm>
+          <a:prstGeom prst="rect">
+            <a:avLst/>
+          </a:prstGeom>
+          <a:noFill/>
+        </p:spPr>
+        <p:txBody>
+          <a:bodyPr wrap="none" lIns="0" tIns="0" rIns="0" bIns="0" anchor="ctr"/>
+          <a:lstStyle/>
+          <a:p>
+            <a:pPr algn="l">
+              <a:buNone/>
+            </a:pPr>
+            <a:r>
+              <a:rPr lang="id-ID" sz="760" b="1" dirty="0">
+                <a:solidFill>
+                  <a:srgbClr val="1A1A1A"/>
+                </a:solidFill>
+                <a:latin typeface="Roboto"/>
+                <a:ea typeface="Roboto"/>
+                <a:cs typeface="Roboto"/>
+              </a:rPr>
+              <a:t>Kekeringan</a:t>
+            </a:r>
+            <a:r>
+              <a:rPr lang="id-ID" sz="760" dirty="0">
+                <a:solidFill>
+                  <a:srgbClr val="2E3440"/>
+                </a:solidFill>
+                <a:latin typeface="Roboto"/>
+                <a:ea typeface="Roboto"/>
+                <a:cs typeface="Roboto"/>
+              </a:rPr>
+              <a:t>, 7 kab/kota di 4 provinsi</a:t>
+            </a:r>
+            <a:endParaRPr lang="id-ID" sz="760"/>
+          </a:p>
+        </p:txBody>
+      </p:sp>
+      <p:sp>
+        <p:nvSpPr>
+          <p:cNvPr id="519" name="K"/>
+          <p:cNvSpPr/>
+          <p:nvPr/>
+        </p:nvSpPr>
+        <p:spPr>
+          <a:xfrm>
+            <a:off x="10470000" y="4691862"/>
+            <a:ext cx="1070000" cy="97300"/>
+          </a:xfrm>
+          <a:prstGeom prst="roundRect">
+            <a:avLst>
+              <a:gd name="adj" fmla="val 50000"/>
+            </a:avLst>
+          </a:prstGeom>
+          <a:solidFill>
+            <a:srgbClr val="F4ECDC"/>
+          </a:solidFill>
+          <a:ln>
+            <a:noFill/>
+          </a:ln>
+        </p:spPr>
+      </p:sp>
+      <p:pic>
+        <p:nvPicPr>
+          <p:cNvPr id="520" name="G"/>
+          <p:cNvPicPr>
+            <a:picLocks noChangeAspect="1"/>
+          </p:cNvPicPr>
+          <p:nvPr/>
+        </p:nvPicPr>
+        <p:blipFill>
+          <a:blip r:embed="rIdM15"/>
+          <a:stretch>
+            <a:fillRect/>
+          </a:stretch>
+        </p:blipFill>
+        <p:spPr>
+          <a:xfrm>
+            <a:off x="10520000" y="4707430"/>
+            <a:ext cx="66164" cy="66164"/>
+          </a:xfrm>
+          <a:prstGeom prst="rect">
+            <a:avLst/>
+          </a:prstGeom>
+        </p:spPr>
+      </p:pic>
+      <p:sp>
+        <p:nvSpPr>
+          <p:cNvPr id="521" name="T"/>
+          <p:cNvSpPr txBox="1"/>
+          <p:nvPr/>
+        </p:nvSpPr>
+        <p:spPr>
+          <a:xfrm>
+            <a:off x="10680000" y="4691862"/>
+            <a:ext cx="500000" cy="97300"/>
+          </a:xfrm>
+          <a:prstGeom prst="rect">
+            <a:avLst/>
+          </a:prstGeom>
+          <a:noFill/>
+        </p:spPr>
+        <p:txBody>
+          <a:bodyPr wrap="none" lIns="0" tIns="0" rIns="0" bIns="0" anchor="ctr"/>
+          <a:lstStyle/>
+          <a:p>
+            <a:pPr algn="r">
+              <a:buNone/>
+            </a:pPr>
+            <a:r>
+              <a:rPr lang="id-ID" sz="720" b="1" dirty="0">
+                <a:solidFill>
+                  <a:srgbClr val="8A6A2E"/>
+                </a:solidFill>
+                <a:latin typeface="Roboto"/>
+                <a:ea typeface="Roboto"/>
+                <a:cs typeface="Roboto"/>
+              </a:rPr>
+              <a:t>24.400</a:t>
+            </a:r>
+            <a:endParaRPr lang="id-ID" sz="720"/>
+          </a:p>
+        </p:txBody>
+      </p:sp>
+      <p:sp>
+        <p:nvSpPr>
+          <p:cNvPr id="522" name="T"/>
+          <p:cNvSpPr txBox="1"/>
+          <p:nvPr/>
+        </p:nvSpPr>
+        <p:spPr>
+          <a:xfrm>
+            <a:off x="11201600" y="4691862"/>
+            <a:ext cx="300000" cy="97300"/>
+          </a:xfrm>
+          <a:prstGeom prst="rect">
+            <a:avLst/>
+          </a:prstGeom>
+          <a:noFill/>
+        </p:spPr>
+        <p:txBody>
+          <a:bodyPr wrap="none" lIns="0" tIns="0" rIns="0" bIns="0" anchor="ctr"/>
+          <a:lstStyle/>
+          <a:p>
+            <a:pPr algn="l">
+              <a:buNone/>
+            </a:pPr>
+            <a:r>
+              <a:rPr lang="id-ID" sz="720" b="1" dirty="0">
+                <a:solidFill>
+                  <a:srgbClr val="8A6A2E"/>
+                </a:solidFill>
+                <a:latin typeface="Roboto"/>
+                <a:ea typeface="Roboto"/>
+                <a:cs typeface="Roboto"/>
+              </a:rPr>
+              <a:t>KK</a:t>
+            </a:r>
+            <a:endParaRPr lang="id-ID" sz="720"/>
+          </a:p>
+        </p:txBody>
+      </p:sp>
+      <p:cxnSp>
+        <p:nvCxnSpPr>
+          <p:cNvPr id="523" name="L"/>
+          <p:cNvCxnSpPr/>
+          <p:nvPr/>
+        </p:nvCxnSpPr>
+        <p:spPr>
+          <a:xfrm>
+            <a:off x="8668512" y="4801325"/>
+            <a:ext cx="2809951" cy="0"/>
+          </a:xfrm>
+          <a:prstGeom prst="line">
+            <a:avLst/>
+          </a:prstGeom>
+          <a:ln w="9525">
+            <a:solidFill>
+              <a:srgbClr val="F1F2F4"/>
+            </a:solidFill>
+          </a:ln>
+        </p:spPr>
+      </p:cxnSp>
+      <p:sp>
+        <p:nvSpPr>
+          <p:cNvPr id="524" name="K"/>
+          <p:cNvSpPr/>
+          <p:nvPr/>
+        </p:nvSpPr>
+        <p:spPr>
+          <a:xfrm>
+            <a:off x="8668512" y="4813488"/>
+            <a:ext cx="97300" cy="97300"/>
+          </a:xfrm>
+          <a:prstGeom prst="ellipse">
+            <a:avLst/>
+          </a:prstGeom>
+          <a:solidFill>
+            <a:srgbClr val="2F6FB5"/>
+          </a:solidFill>
+          <a:ln>
+            <a:noFill/>
+          </a:ln>
+        </p:spPr>
+      </p:sp>
+      <p:pic>
+        <p:nvPicPr>
+          <p:cNvPr id="525" name="G"/>
+          <p:cNvPicPr>
+            <a:picLocks noChangeAspect="1"/>
+          </p:cNvPicPr>
+          <p:nvPr/>
+        </p:nvPicPr>
+        <p:blipFill>
+          <a:blip r:embed="rIdM16"/>
+          <a:stretch>
+            <a:fillRect/>
+          </a:stretch>
+        </p:blipFill>
+        <p:spPr>
+          <a:xfrm>
+            <a:off x="8686999" y="4831975"/>
+            <a:ext cx="60326" cy="60326"/>
+          </a:xfrm>
+          <a:prstGeom prst="rect">
+            <a:avLst/>
+          </a:prstGeom>
+        </p:spPr>
+      </p:pic>
+      <p:sp>
+        <p:nvSpPr>
+          <p:cNvPr id="526" name="K"/>
+          <p:cNvSpPr/>
           <p:nvPr/>
         </p:nvSpPr>
         <p:spPr>
@@ -8909,6 +9009,30 @@
             <a:off x="8736622" y="4794028"/>
             <a:ext cx="53515" cy="53515"/>
           </a:xfrm>
+          <a:prstGeom prst="ellipse">
+            <a:avLst/>
+          </a:prstGeom>
+          <a:solidFill>
+            <a:srgbClr val="C8102E"/>
+          </a:solidFill>
+          <a:ln w="6350">
+            <a:solidFill>
+              <a:srgbClr val="FFFFFF"/>
+            </a:solidFill>
+          </a:ln>
+        </p:spPr>
+      </p:sp>
+      <p:sp>
+        <p:nvSpPr>
+          <p:cNvPr id="527" name="T"/>
+          <p:cNvSpPr txBox="1"/>
+          <p:nvPr/>
+        </p:nvSpPr>
+        <p:spPr>
+          <a:xfrm>
+            <a:off x="8736622" y="4794028"/>
+            <a:ext cx="53515" cy="53515"/>
+          </a:xfrm>
           <a:prstGeom prst="rect">
             <a:avLst/>
           </a:prstGeom>
@@ -8938,7 +9062,7 @@
       </p:sp>
       <p:sp>
         <p:nvSpPr>
-          <p:cNvPr id="524" name="T"/>
+          <p:cNvPr id="528" name="T"/>
           <p:cNvSpPr txBox="1"/>
           <p:nvPr/>
         </p:nvSpPr>
@@ -8987,7 +9111,7 @@
       </p:sp>
       <p:sp>
         <p:nvSpPr>
-          <p:cNvPr id="525" name="K"/>
+          <p:cNvPr id="529" name="K"/>
           <p:cNvSpPr/>
           <p:nvPr/>
         </p:nvSpPr>
@@ -9011,7 +9135,7 @@
       </p:sp>
       <p:pic>
         <p:nvPicPr>
-          <p:cNvPr id="526" name="G"/>
+          <p:cNvPr id="530" name="G"/>
           <p:cNvPicPr>
             <a:picLocks noChangeAspect="1"/>
           </p:cNvPicPr>
@@ -9035,7 +9159,7 @@
       </p:pic>
       <p:sp>
         <p:nvSpPr>
-          <p:cNvPr id="527" name="T"/>
+          <p:cNvPr id="531" name="T"/>
           <p:cNvSpPr txBox="1"/>
           <p:nvPr/>
         </p:nvSpPr>
@@ -9073,7 +9197,7 @@
       </p:sp>
       <p:sp>
         <p:nvSpPr>
-          <p:cNvPr id="528" name="T"/>
+          <p:cNvPr id="532" name="T"/>
           <p:cNvSpPr txBox="1"/>
           <p:nvPr/>
         </p:nvSpPr>
@@ -9111,7 +9235,7 @@
       </p:sp>
       <p:cxnSp>
         <p:nvCxnSpPr>
-          <p:cNvPr id="529" name="L"/>
+          <p:cNvPr id="533" name="L"/>
           <p:cNvCxnSpPr/>
           <p:nvPr/>
         </p:nvCxnSpPr>
@@ -9132,7 +9256,7 @@
       </p:cxnSp>
       <p:sp>
         <p:nvSpPr>
-          <p:cNvPr id="530" name="K"/>
+          <p:cNvPr id="534" name="K"/>
           <p:cNvSpPr/>
           <p:nvPr/>
         </p:nvSpPr>
@@ -9154,7 +9278,7 @@
       </p:sp>
       <p:pic>
         <p:nvPicPr>
-          <p:cNvPr id="531" name="G"/>
+          <p:cNvPr id="535" name="G"/>
           <p:cNvPicPr>
             <a:picLocks noChangeAspect="1"/>
           </p:cNvPicPr>
@@ -9178,7 +9302,7 @@
       </p:pic>
       <p:sp>
         <p:nvSpPr>
-          <p:cNvPr id="532" name="T"/>
+          <p:cNvPr id="536" name="T"/>
           <p:cNvSpPr txBox="1"/>
           <p:nvPr/>
         </p:nvSpPr>
@@ -9227,7 +9351,7 @@
       </p:sp>
       <p:sp>
         <p:nvSpPr>
-          <p:cNvPr id="533" name="K"/>
+          <p:cNvPr id="537" name="K"/>
           <p:cNvSpPr/>
           <p:nvPr/>
         </p:nvSpPr>
@@ -9251,7 +9375,7 @@
       </p:sp>
       <p:pic>
         <p:nvPicPr>
-          <p:cNvPr id="534" name="G"/>
+          <p:cNvPr id="538" name="G"/>
           <p:cNvPicPr>
             <a:picLocks noChangeAspect="1"/>
           </p:cNvPicPr>
@@ -9275,14 +9399,14 @@
       </p:pic>
       <p:sp>
         <p:nvSpPr>
-          <p:cNvPr id="535" name="T"/>
-          <p:cNvSpPr txBox="1"/>
-          <p:nvPr/>
-        </p:nvSpPr>
-        <p:spPr>
-          <a:xfrm>
-            <a:off x="10650000" y="4935114"/>
-            <a:ext cx="260000" cy="97300"/>
+          <p:cNvPr id="539" name="T"/>
+          <p:cNvSpPr txBox="1"/>
+          <p:nvPr/>
+        </p:nvSpPr>
+        <p:spPr>
+          <a:xfrm>
+            <a:off x="10680000" y="4935114"/>
+            <a:ext cx="500000" cy="97300"/>
           </a:xfrm>
           <a:prstGeom prst="rect">
             <a:avLst/>
@@ -9293,7 +9417,7 @@
           <a:bodyPr wrap="none" lIns="0" tIns="0" rIns="0" bIns="0" anchor="ctr"/>
           <a:lstStyle/>
           <a:p>
-            <a:pPr algn="l">
+            <a:pPr algn="r">
               <a:buNone/>
             </a:pPr>
             <a:r>
@@ -9305,7 +9429,7 @@
                 <a:ea typeface="Roboto"/>
                 <a:cs typeface="Roboto"/>
               </a:rPr>
-              <a:t>luas</a:t>
+              <a:t>± 15,5</a:t>
             </a:r>
             <a:endParaRPr lang="id-ID" sz="720"/>
           </a:p>
@@ -9313,52 +9437,14 @@
       </p:sp>
       <p:sp>
         <p:nvSpPr>
-          <p:cNvPr id="536" name="T"/>
-          <p:cNvSpPr txBox="1"/>
-          <p:nvPr/>
-        </p:nvSpPr>
-        <p:spPr>
-          <a:xfrm>
-            <a:off x="10800000" y="4935114"/>
-            <a:ext cx="380000" cy="97300"/>
-          </a:xfrm>
-          <a:prstGeom prst="rect">
-            <a:avLst/>
-          </a:prstGeom>
-          <a:noFill/>
-        </p:spPr>
-        <p:txBody>
-          <a:bodyPr wrap="none" lIns="0" tIns="0" rIns="0" bIns="0" anchor="ctr"/>
-          <a:lstStyle/>
-          <a:p>
-            <a:pPr algn="r">
-              <a:buNone/>
-            </a:pPr>
-            <a:r>
-              <a:rPr lang="id-ID" sz="720" b="1" dirty="0">
-                <a:solidFill>
-                  <a:srgbClr val="A23B2A"/>
-                </a:solidFill>
-                <a:latin typeface="Roboto"/>
-                <a:ea typeface="Roboto"/>
-                <a:cs typeface="Roboto"/>
-              </a:rPr>
-              <a:t>± 15,5</a:t>
-            </a:r>
-            <a:endParaRPr lang="id-ID" sz="720"/>
-          </a:p>
-        </p:txBody>
-      </p:sp>
-      <p:sp>
-        <p:nvSpPr>
-          <p:cNvPr id="537" name="T"/>
+          <p:cNvPr id="540" name="T"/>
           <p:cNvSpPr txBox="1"/>
           <p:nvPr/>
         </p:nvSpPr>
         <p:spPr>
           <a:xfrm>
             <a:off x="11201600" y="4935114"/>
-            <a:ext cx="200000" cy="97300"/>
+            <a:ext cx="300000" cy="97300"/>
           </a:xfrm>
           <a:prstGeom prst="rect">
             <a:avLst/>
@@ -9389,7 +9475,7 @@
       </p:sp>
       <p:cxnSp>
         <p:nvCxnSpPr>
-          <p:cNvPr id="538" name="L"/>
+          <p:cNvPr id="541" name="L"/>
           <p:cNvCxnSpPr/>
           <p:nvPr/>
         </p:nvCxnSpPr>
@@ -9410,7 +9496,7 @@
       </p:cxnSp>
       <p:sp>
         <p:nvSpPr>
-          <p:cNvPr id="539" name="K"/>
+          <p:cNvPr id="542" name="K"/>
           <p:cNvSpPr/>
           <p:nvPr/>
         </p:nvSpPr>
@@ -9432,7 +9518,7 @@
       </p:sp>
       <p:pic>
         <p:nvPicPr>
-          <p:cNvPr id="540" name="G"/>
+          <p:cNvPr id="543" name="G"/>
           <p:cNvPicPr>
             <a:picLocks noChangeAspect="1"/>
           </p:cNvPicPr>
@@ -9456,7 +9542,7 @@
       </p:pic>
       <p:sp>
         <p:nvSpPr>
-          <p:cNvPr id="541" name="T"/>
+          <p:cNvPr id="544" name="T"/>
           <p:cNvSpPr txBox="1"/>
           <p:nvPr/>
         </p:nvSpPr>
@@ -9494,7 +9580,7 @@
       </p:sp>
       <p:sp>
         <p:nvSpPr>
-          <p:cNvPr id="542" name="K"/>
+          <p:cNvPr id="545" name="K"/>
           <p:cNvSpPr/>
           <p:nvPr/>
         </p:nvSpPr>
@@ -9518,7 +9604,7 @@
       </p:sp>
       <p:pic>
         <p:nvPicPr>
-          <p:cNvPr id="543" name="G"/>
+          <p:cNvPr id="546" name="G"/>
           <p:cNvPicPr>
             <a:picLocks noChangeAspect="1"/>
           </p:cNvPicPr>
@@ -9542,7 +9628,7 @@
       </p:pic>
       <p:sp>
         <p:nvSpPr>
-          <p:cNvPr id="544" name="T"/>
+          <p:cNvPr id="547" name="T"/>
           <p:cNvSpPr txBox="1"/>
           <p:nvPr/>
         </p:nvSpPr>
@@ -9580,7 +9666,7 @@
       </p:sp>
       <p:sp>
         <p:nvSpPr>
-          <p:cNvPr id="545" name="T"/>
+          <p:cNvPr id="548" name="T"/>
           <p:cNvSpPr txBox="1"/>
           <p:nvPr/>
         </p:nvSpPr>
@@ -9618,7 +9704,7 @@
       </p:sp>
       <p:cxnSp>
         <p:nvCxnSpPr>
-          <p:cNvPr id="546" name="L"/>
+          <p:cNvPr id="549" name="L"/>
           <p:cNvCxnSpPr/>
           <p:nvPr/>
         </p:nvCxnSpPr>
@@ -9639,7 +9725,7 @@
       </p:cxnSp>
       <p:sp>
         <p:nvSpPr>
-          <p:cNvPr id="547" name="K"/>
+          <p:cNvPr id="550" name="K"/>
           <p:cNvSpPr/>
           <p:nvPr/>
         </p:nvSpPr>
@@ -9661,7 +9747,7 @@
       </p:sp>
       <p:pic>
         <p:nvPicPr>
-          <p:cNvPr id="548" name="G"/>
+          <p:cNvPr id="551" name="G"/>
           <p:cNvPicPr>
             <a:picLocks noChangeAspect="1"/>
           </p:cNvPicPr>
@@ -9685,7 +9771,7 @@
       </p:pic>
       <p:sp>
         <p:nvSpPr>
-          <p:cNvPr id="549" name="T"/>
+          <p:cNvPr id="552" name="T"/>
           <p:cNvSpPr txBox="1"/>
           <p:nvPr/>
         </p:nvSpPr>
@@ -9734,7 +9820,7 @@
       </p:sp>
       <p:sp>
         <p:nvSpPr>
-          <p:cNvPr id="550" name="K"/>
+          <p:cNvPr id="553" name="K"/>
           <p:cNvSpPr/>
           <p:nvPr/>
         </p:nvSpPr>
@@ -9758,7 +9844,7 @@
       </p:sp>
       <p:pic>
         <p:nvPicPr>
-          <p:cNvPr id="551" name="G"/>
+          <p:cNvPr id="554" name="G"/>
           <p:cNvPicPr>
             <a:picLocks noChangeAspect="1"/>
           </p:cNvPicPr>
@@ -9782,7 +9868,7 @@
       </p:pic>
       <p:sp>
         <p:nvSpPr>
-          <p:cNvPr id="552" name="T"/>
+          <p:cNvPr id="555" name="T"/>
           <p:cNvSpPr txBox="1"/>
           <p:nvPr/>
         </p:nvSpPr>
@@ -9820,7 +9906,7 @@
       </p:sp>
       <p:sp>
         <p:nvSpPr>
-          <p:cNvPr id="553" name="T"/>
+          <p:cNvPr id="556" name="T"/>
           <p:cNvSpPr txBox="1"/>
           <p:nvPr/>
         </p:nvSpPr>
@@ -9858,7 +9944,7 @@
       </p:sp>
       <p:sp>
         <p:nvSpPr>
-          <p:cNvPr id="554" name="K"/>
+          <p:cNvPr id="557" name="K"/>
           <p:cNvSpPr/>
           <p:nvPr/>
         </p:nvSpPr>
@@ -9882,7 +9968,7 @@
       </p:sp>
       <p:sp>
         <p:nvSpPr>
-          <p:cNvPr id="555" name="T"/>
+          <p:cNvPr id="558" name="T"/>
           <p:cNvSpPr txBox="1"/>
           <p:nvPr/>
         </p:nvSpPr>
@@ -9920,7 +10006,7 @@
       </p:sp>
       <p:sp>
         <p:nvSpPr>
-          <p:cNvPr id="556" name="K"/>
+          <p:cNvPr id="559" name="K"/>
           <p:cNvSpPr/>
           <p:nvPr/>
         </p:nvSpPr>
@@ -9942,7 +10028,7 @@
       </p:sp>
       <p:pic>
         <p:nvPicPr>
-          <p:cNvPr id="557" name="G"/>
+          <p:cNvPr id="560" name="G"/>
           <p:cNvPicPr>
             <a:picLocks noChangeAspect="1"/>
           </p:cNvPicPr>
@@ -9966,7 +10052,7 @@
       </p:pic>
       <p:sp>
         <p:nvSpPr>
-          <p:cNvPr id="558" name="T"/>
+          <p:cNvPr id="561" name="T"/>
           <p:cNvSpPr txBox="1"/>
           <p:nvPr/>
         </p:nvSpPr>
@@ -10004,7 +10090,7 @@
       </p:sp>
       <p:sp>
         <p:nvSpPr>
-          <p:cNvPr id="559" name="T"/>
+          <p:cNvPr id="562" name="T"/>
           <p:cNvSpPr txBox="1"/>
           <p:nvPr/>
         </p:nvSpPr>
@@ -10059,7 +10145,7 @@
       </p:sp>
       <p:cxnSp>
         <p:nvCxnSpPr>
-          <p:cNvPr id="560" name="L"/>
+          <p:cNvPr id="563" name="L"/>
           <p:cNvCxnSpPr/>
           <p:nvPr/>
         </p:nvCxnSpPr>
@@ -10080,7 +10166,7 @@
       </p:cxnSp>
       <p:sp>
         <p:nvSpPr>
-          <p:cNvPr id="561" name="K"/>
+          <p:cNvPr id="564" name="K"/>
           <p:cNvSpPr/>
           <p:nvPr/>
         </p:nvSpPr>
@@ -10102,7 +10188,7 @@
       </p:sp>
       <p:pic>
         <p:nvPicPr>
-          <p:cNvPr id="562" name="G"/>
+          <p:cNvPr id="565" name="G"/>
           <p:cNvPicPr>
             <a:picLocks noChangeAspect="1"/>
           </p:cNvPicPr>
@@ -10126,7 +10212,7 @@
       </p:pic>
       <p:sp>
         <p:nvSpPr>
-          <p:cNvPr id="563" name="T"/>
+          <p:cNvPr id="566" name="T"/>
           <p:cNvSpPr txBox="1"/>
           <p:nvPr/>
         </p:nvSpPr>
@@ -10164,7 +10250,7 @@
       </p:sp>
       <p:sp>
         <p:nvSpPr>
-          <p:cNvPr id="564" name="T"/>
+          <p:cNvPr id="567" name="T"/>
           <p:cNvSpPr txBox="1"/>
           <p:nvPr/>
         </p:nvSpPr>
@@ -10219,7 +10305,7 @@
       </p:sp>
       <p:cxnSp>
         <p:nvCxnSpPr>
-          <p:cNvPr id="565" name="L"/>
+          <p:cNvPr id="568" name="L"/>
           <p:cNvCxnSpPr/>
           <p:nvPr/>
         </p:nvCxnSpPr>
@@ -10240,7 +10326,7 @@
       </p:cxnSp>
       <p:sp>
         <p:nvSpPr>
-          <p:cNvPr id="566" name="K"/>
+          <p:cNvPr id="569" name="K"/>
           <p:cNvSpPr/>
           <p:nvPr/>
         </p:nvSpPr>
@@ -10262,7 +10348,7 @@
       </p:sp>
       <p:pic>
         <p:nvPicPr>
-          <p:cNvPr id="567" name="G"/>
+          <p:cNvPr id="570" name="G"/>
           <p:cNvPicPr>
             <a:picLocks noChangeAspect="1"/>
           </p:cNvPicPr>
@@ -10286,7 +10372,7 @@
       </p:pic>
       <p:sp>
         <p:nvSpPr>
-          <p:cNvPr id="568" name="T"/>
+          <p:cNvPr id="571" name="T"/>
           <p:cNvSpPr txBox="1"/>
           <p:nvPr/>
         </p:nvSpPr>
@@ -10324,7 +10410,7 @@
       </p:sp>
       <p:sp>
         <p:nvSpPr>
-          <p:cNvPr id="569" name="T"/>
+          <p:cNvPr id="572" name="T"/>
           <p:cNvSpPr txBox="1"/>
           <p:nvPr/>
         </p:nvSpPr>

</xml_diff>

<commit_message>
feat(laporan): tindak lanjut BNPB diisi dari data harian, air tanpa data 'dalam proses pendataan'
</commit_message>
<xml_diff>
--- a/data/laporan-bnpb/harian-2026-10-28/Laporan Kejadian Bencana Harian 281026.pptx
+++ b/data/laporan-bnpb/harian-2026-10-28/Laporan Kejadian Bencana Harian 281026.pptx
@@ -10120,7 +10120,7 @@
                 <a:ea typeface="Roboto"/>
                 <a:cs typeface="Roboto"/>
               </a:rPr>
-              <a:t>•  Kalimantan Timur sisa ±461 ha belum padam</a:t>
+              <a:t>•  Kal. Timur ±461 ha dan Papua Selatan ±373 ha belum padam</a:t>
             </a:r>
             <a:endParaRPr lang="id-ID" sz="820"/>
           </a:p>
@@ -10137,7 +10137,7 @@
                 <a:ea typeface="Roboto"/>
                 <a:cs typeface="Roboto"/>
               </a:rPr>
-              <a:t>•  Papua Selatan sisa ±373 ha belum padam</a:t>
+              <a:t>•  Patroli dan pendinginan: Sul. Tenggara, Sum. Selatan</a:t>
             </a:r>
             <a:endParaRPr lang="id-ID" sz="820"/>
           </a:p>
@@ -10280,7 +10280,7 @@
                 <a:ea typeface="Roboto"/>
                 <a:cs typeface="Roboto"/>
               </a:rPr>
-              <a:t>•  Masker dan layanan ISPA: Pekanbaru</a:t>
+              <a:t>•  Masker dan layanan ISPA: Pekanbaru, Palangka Raya</a:t>
             </a:r>
             <a:endParaRPr lang="id-ID" sz="820"/>
           </a:p>
@@ -10297,7 +10297,7 @@
                 <a:ea typeface="Roboto"/>
                 <a:cs typeface="Roboto"/>
               </a:rPr>
-              <a:t>•  PM2.5 tingkat Berbahaya (BMKG)</a:t>
+              <a:t>•  Pengungsi: gempa NTT ±27.345, karhutla Babel ±307 jiwa</a:t>
             </a:r>
             <a:endParaRPr lang="id-ID" sz="820"/>
           </a:p>
@@ -10440,7 +10440,7 @@
                 <a:ea typeface="Roboto"/>
                 <a:cs typeface="Roboto"/>
               </a:rPr>
-              <a:t>•  Air bersih untuk ±24.400 KK di 7 kab/kota, 4 provinsi</a:t>
+              <a:t>•  Tersalur 407.700 liter, 52 tangki untuk ±24.400 KK</a:t>
             </a:r>
             <a:endParaRPr lang="id-ID" sz="820"/>
           </a:p>
@@ -10457,7 +10457,7 @@
                 <a:ea typeface="Roboto"/>
                 <a:cs typeface="Roboto"/>
               </a:rPr>
-              <a:t>•  Tersalur 407.700 liter, 52 tangki</a:t>
+              <a:t>•  Percepat pendataan dan distribusi: Seram Bagian Barat</a:t>
             </a:r>
             <a:endParaRPr lang="id-ID" sz="820"/>
           </a:p>
@@ -19408,7 +19408,7 @@
         <p:spPr>
           <a:xfrm>
             <a:off x="9930000" y="3499866"/>
-            <a:ext cx="880000" cy="164592"/>
+            <a:ext cx="1548463" cy="164592"/>
           </a:xfrm>
           <a:prstGeom prst="roundRect">
             <a:avLst>
@@ -19457,8 +19457,8 @@
         </p:nvSpPr>
         <p:spPr>
           <a:xfrm>
-            <a:off x="10100000" y="3499866"/>
-            <a:ext cx="690000" cy="164592"/>
+            <a:off x="10120000" y="3499866"/>
+            <a:ext cx="1318463" cy="164592"/>
           </a:xfrm>
           <a:prstGeom prst="rect">
             <a:avLst/>
@@ -19469,7 +19469,7 @@
           <a:bodyPr wrap="none" lIns="0" tIns="0" rIns="0" bIns="0" anchor="ctr"/>
           <a:lstStyle/>
           <a:p>
-            <a:pPr algn="ctr">
+            <a:pPr algn="l">
               <a:buNone/>
             </a:pPr>
             <a:r>
@@ -19481,9 +19481,9 @@
                 <a:ea typeface="Roboto"/>
                 <a:cs typeface="Roboto"/>
               </a:rPr>
-              <a:t>belum ada data</a:t>
-            </a:r>
-            <a:endParaRPr lang="id-ID" sz="650"/>
+              <a:t>dalam proses pendataan</a:t>
+            </a:r>
+            <a:endParaRPr lang="id-ID" sz="680"/>
           </a:p>
         </p:txBody>
       </p:sp>

</xml_diff>

<commit_message>
feat(laporan): legenda ikon bencana lainnya, kepala kolom kekeringan rata tengah
</commit_message>
<xml_diff>
--- a/data/laporan-bnpb/harian-2026-10-28/Laporan Kejadian Bencana Harian 281026.pptx
+++ b/data/laporan-bnpb/harian-2026-10-28/Laporan Kejadian Bencana Harian 281026.pptx
@@ -10638,7 +10638,7 @@
       </p:sp>
       <p:sp>
         <p:nvSpPr>
-          <p:cNvPr id="790" name="T"/>
+          <p:cNvPr id="802" name="T"/>
           <p:cNvSpPr txBox="1"/>
           <p:nvPr/>
         </p:nvSpPr>
@@ -15694,14 +15694,14 @@
       </p:sp>
       <p:sp>
         <p:nvSpPr>
-          <p:cNvPr id="656" name="K"/>
+          <p:cNvPr id="668" name="K"/>
           <p:cNvSpPr/>
           <p:nvPr/>
         </p:nvSpPr>
         <p:spPr>
           <a:xfrm>
             <a:off x="7406640" y="1325880"/>
-            <a:ext cx="4236415" cy="2450592"/>
+            <a:ext cx="4236415" cy="2221992"/>
           </a:xfrm>
           <a:prstGeom prst="roundRect">
             <a:avLst>
@@ -15720,7 +15720,7 @@
       </p:sp>
       <p:sp>
         <p:nvSpPr>
-          <p:cNvPr id="657" name="K"/>
+          <p:cNvPr id="669" name="K"/>
           <p:cNvSpPr/>
           <p:nvPr/>
         </p:nvSpPr>
@@ -15744,7 +15744,7 @@
       </p:sp>
       <p:sp>
         <p:nvSpPr>
-          <p:cNvPr id="658" name="K"/>
+          <p:cNvPr id="670" name="K"/>
           <p:cNvSpPr/>
           <p:nvPr/>
         </p:nvSpPr>
@@ -15766,7 +15766,7 @@
       </p:sp>
       <p:sp>
         <p:nvSpPr>
-          <p:cNvPr id="659" name="K"/>
+          <p:cNvPr id="671" name="K"/>
           <p:cNvSpPr/>
           <p:nvPr/>
         </p:nvSpPr>
@@ -15788,7 +15788,7 @@
       </p:sp>
       <p:pic>
         <p:nvPicPr>
-          <p:cNvPr id="660" name="G"/>
+          <p:cNvPr id="672" name="G"/>
           <p:cNvPicPr>
             <a:picLocks noChangeAspect="1"/>
           </p:cNvPicPr>
@@ -15812,7 +15812,7 @@
       </p:pic>
       <p:sp>
         <p:nvSpPr>
-          <p:cNvPr id="661" name="T"/>
+          <p:cNvPr id="673" name="T"/>
           <p:cNvSpPr txBox="1"/>
           <p:nvPr/>
         </p:nvSpPr>
@@ -15850,7 +15850,7 @@
       </p:sp>
       <p:sp>
         <p:nvSpPr>
-          <p:cNvPr id="662" name="T"/>
+          <p:cNvPr id="674" name="T"/>
           <p:cNvSpPr txBox="1"/>
           <p:nvPr/>
         </p:nvSpPr>
@@ -15888,7 +15888,7 @@
       </p:sp>
       <p:sp>
         <p:nvSpPr>
-          <p:cNvPr id="663" name="T"/>
+          <p:cNvPr id="675" name="T"/>
           <p:cNvSpPr txBox="1"/>
           <p:nvPr/>
         </p:nvSpPr>
@@ -15926,14 +15926,14 @@
       </p:sp>
       <p:sp>
         <p:nvSpPr>
-          <p:cNvPr id="664" name="T"/>
-          <p:cNvSpPr txBox="1"/>
-          <p:nvPr/>
-        </p:nvSpPr>
-        <p:spPr>
-          <a:xfrm>
-            <a:off x="8650000" y="1856232"/>
-            <a:ext cx="1200000" cy="146304"/>
+          <p:cNvPr id="676" name="T"/>
+          <p:cNvSpPr txBox="1"/>
+          <p:nvPr/>
+        </p:nvSpPr>
+        <p:spPr>
+          <a:xfrm>
+            <a:off x="8620000" y="1856232"/>
+            <a:ext cx="1280000" cy="146304"/>
           </a:xfrm>
           <a:prstGeom prst="rect">
             <a:avLst/>
@@ -15944,7 +15944,7 @@
           <a:bodyPr wrap="square" lIns="0" tIns="0" rIns="0" bIns="0" anchor="t"/>
           <a:lstStyle/>
           <a:p>
-            <a:pPr algn="l">
+            <a:pPr algn="ctr">
               <a:buNone/>
             </a:pPr>
             <a:r>
@@ -15964,14 +15964,14 @@
       </p:sp>
       <p:sp>
         <p:nvSpPr>
-          <p:cNvPr id="665" name="T"/>
+          <p:cNvPr id="677" name="T"/>
           <p:cNvSpPr txBox="1"/>
           <p:nvPr/>
         </p:nvSpPr>
         <p:spPr>
           <a:xfrm>
             <a:off x="9930000" y="1856232"/>
-            <a:ext cx="1200000" cy="146304"/>
+            <a:ext cx="1548463" cy="146304"/>
           </a:xfrm>
           <a:prstGeom prst="rect">
             <a:avLst/>
@@ -15982,7 +15982,7 @@
           <a:bodyPr wrap="square" lIns="0" tIns="0" rIns="0" bIns="0" anchor="t"/>
           <a:lstStyle/>
           <a:p>
-            <a:pPr algn="l">
+            <a:pPr algn="ctr">
               <a:buNone/>
             </a:pPr>
             <a:r>
@@ -16002,7 +16002,7 @@
       </p:sp>
       <p:cxnSp>
         <p:nvCxnSpPr>
-          <p:cNvPr id="666" name="L"/>
+          <p:cNvPr id="678" name="L"/>
           <p:cNvCxnSpPr/>
           <p:nvPr/>
         </p:nvCxnSpPr>
@@ -16023,14 +16023,14 @@
       </p:cxnSp>
       <p:sp>
         <p:nvSpPr>
-          <p:cNvPr id="667" name="K"/>
+          <p:cNvPr id="679" name="K"/>
           <p:cNvSpPr/>
           <p:nvPr/>
         </p:nvSpPr>
         <p:spPr>
           <a:xfrm>
-            <a:off x="7571232" y="2055571"/>
-            <a:ext cx="3907231" cy="172821"/>
+            <a:off x="7571232" y="2053285"/>
+            <a:ext cx="3907231" cy="148818"/>
           </a:xfrm>
           <a:prstGeom prst="roundRect">
             <a:avLst>
@@ -16047,14 +16047,14 @@
       </p:sp>
       <p:sp>
         <p:nvSpPr>
-          <p:cNvPr id="668" name="T"/>
+          <p:cNvPr id="680" name="T"/>
           <p:cNvSpPr txBox="1"/>
           <p:nvPr/>
         </p:nvSpPr>
         <p:spPr>
           <a:xfrm>
             <a:off x="7662672" y="2039112"/>
-            <a:ext cx="1000000" cy="205740"/>
+            <a:ext cx="1000000" cy="177165"/>
           </a:xfrm>
           <a:prstGeom prst="rect">
             <a:avLst/>
@@ -16085,14 +16085,14 @@
       </p:sp>
       <p:sp>
         <p:nvSpPr>
-          <p:cNvPr id="669" name="T"/>
+          <p:cNvPr id="681" name="T"/>
           <p:cNvSpPr txBox="1"/>
           <p:nvPr/>
         </p:nvSpPr>
         <p:spPr>
           <a:xfrm>
             <a:off x="8620000" y="2039112"/>
-            <a:ext cx="380000" cy="205740"/>
+            <a:ext cx="380000" cy="177165"/>
           </a:xfrm>
           <a:prstGeom prst="rect">
             <a:avLst/>
@@ -16123,14 +16123,14 @@
       </p:sp>
       <p:sp>
         <p:nvSpPr>
-          <p:cNvPr id="670" name="T"/>
+          <p:cNvPr id="682" name="T"/>
           <p:cNvSpPr txBox="1"/>
           <p:nvPr/>
         </p:nvSpPr>
         <p:spPr>
           <a:xfrm>
             <a:off x="9024000" y="2039112"/>
-            <a:ext cx="200000" cy="205740"/>
+            <a:ext cx="200000" cy="177165"/>
           </a:xfrm>
           <a:prstGeom prst="rect">
             <a:avLst/>
@@ -16161,14 +16161,14 @@
       </p:sp>
       <p:sp>
         <p:nvSpPr>
-          <p:cNvPr id="671" name="T"/>
+          <p:cNvPr id="683" name="T"/>
           <p:cNvSpPr txBox="1"/>
           <p:nvPr/>
         </p:nvSpPr>
         <p:spPr>
           <a:xfrm>
             <a:off x="9240000" y="2039112"/>
-            <a:ext cx="400000" cy="205740"/>
+            <a:ext cx="400000" cy="177165"/>
           </a:xfrm>
           <a:prstGeom prst="rect">
             <a:avLst/>
@@ -16199,14 +16199,14 @@
       </p:sp>
       <p:sp>
         <p:nvSpPr>
-          <p:cNvPr id="672" name="T"/>
+          <p:cNvPr id="684" name="T"/>
           <p:cNvSpPr txBox="1"/>
           <p:nvPr/>
         </p:nvSpPr>
         <p:spPr>
           <a:xfrm>
             <a:off x="9664000" y="2039112"/>
-            <a:ext cx="260000" cy="205740"/>
+            <a:ext cx="260000" cy="177165"/>
           </a:xfrm>
           <a:prstGeom prst="rect">
             <a:avLst/>
@@ -16237,13 +16237,13 @@
       </p:sp>
       <p:sp>
         <p:nvSpPr>
-          <p:cNvPr id="673" name="K"/>
+          <p:cNvPr id="685" name="K"/>
           <p:cNvSpPr/>
           <p:nvPr/>
         </p:nvSpPr>
         <p:spPr>
           <a:xfrm>
-            <a:off x="9930000" y="2059686"/>
+            <a:off x="9930000" y="2045398"/>
             <a:ext cx="880000" cy="164592"/>
           </a:xfrm>
           <a:prstGeom prst="roundRect">
@@ -16263,7 +16263,7 @@
       </p:sp>
       <p:pic>
         <p:nvPicPr>
-          <p:cNvPr id="674" name="G"/>
+          <p:cNvPr id="686" name="G"/>
           <p:cNvPicPr>
             <a:picLocks noChangeAspect="1"/>
           </p:cNvPicPr>
@@ -16277,7 +16277,7 @@
         </p:blipFill>
         <p:spPr>
           <a:xfrm>
-            <a:off x="9985000" y="2091686"/>
+            <a:off x="9985000" y="2077398"/>
             <a:ext cx="100584" cy="100584"/>
           </a:xfrm>
           <a:prstGeom prst="rect">
@@ -16287,13 +16287,13 @@
       </p:pic>
       <p:sp>
         <p:nvSpPr>
-          <p:cNvPr id="675" name="T"/>
-          <p:cNvSpPr txBox="1"/>
-          <p:nvPr/>
-        </p:nvSpPr>
-        <p:spPr>
-          <a:xfrm>
-            <a:off x="10120000" y="2059686"/>
+          <p:cNvPr id="687" name="T"/>
+          <p:cNvSpPr txBox="1"/>
+          <p:nvPr/>
+        </p:nvSpPr>
+        <p:spPr>
+          <a:xfrm>
+            <a:off x="10120000" y="2045398"/>
             <a:ext cx="430000" cy="164592"/>
           </a:xfrm>
           <a:prstGeom prst="rect">
@@ -16325,13 +16325,13 @@
       </p:sp>
       <p:sp>
         <p:nvSpPr>
-          <p:cNvPr id="676" name="T"/>
-          <p:cNvSpPr txBox="1"/>
-          <p:nvPr/>
-        </p:nvSpPr>
-        <p:spPr>
-          <a:xfrm>
-            <a:off x="10571600" y="2059686"/>
+          <p:cNvPr id="688" name="T"/>
+          <p:cNvSpPr txBox="1"/>
+          <p:nvPr/>
+        </p:nvSpPr>
+        <p:spPr>
+          <a:xfrm>
+            <a:off x="10571600" y="2045398"/>
             <a:ext cx="200000" cy="164592"/>
           </a:xfrm>
           <a:prstGeom prst="rect">
@@ -16363,13 +16363,13 @@
       </p:sp>
       <p:sp>
         <p:nvSpPr>
-          <p:cNvPr id="677" name="K"/>
+          <p:cNvPr id="689" name="K"/>
           <p:cNvSpPr/>
           <p:nvPr/>
         </p:nvSpPr>
         <p:spPr>
           <a:xfrm>
-            <a:off x="10870000" y="2059686"/>
+            <a:off x="10870000" y="2045398"/>
             <a:ext cx="608463" cy="164592"/>
           </a:xfrm>
           <a:prstGeom prst="roundRect">
@@ -16389,7 +16389,7 @@
       </p:sp>
       <p:pic>
         <p:nvPicPr>
-          <p:cNvPr id="678" name="G"/>
+          <p:cNvPr id="690" name="G"/>
           <p:cNvPicPr>
             <a:picLocks noChangeAspect="1"/>
           </p:cNvPicPr>
@@ -16403,7 +16403,7 @@
         </p:blipFill>
         <p:spPr>
           <a:xfrm>
-            <a:off x="10910000" y="2087118"/>
+            <a:off x="10910000" y="2072830"/>
             <a:ext cx="109728" cy="109728"/>
           </a:xfrm>
           <a:prstGeom prst="rect">
@@ -16413,13 +16413,13 @@
       </p:pic>
       <p:sp>
         <p:nvSpPr>
-          <p:cNvPr id="679" name="T"/>
-          <p:cNvSpPr txBox="1"/>
-          <p:nvPr/>
-        </p:nvSpPr>
-        <p:spPr>
-          <a:xfrm>
-            <a:off x="11050000" y="2059686"/>
+          <p:cNvPr id="691" name="T"/>
+          <p:cNvSpPr txBox="1"/>
+          <p:nvPr/>
+        </p:nvSpPr>
+        <p:spPr>
+          <a:xfrm>
+            <a:off x="11050000" y="2045398"/>
             <a:ext cx="120000" cy="164592"/>
           </a:xfrm>
           <a:prstGeom prst="rect">
@@ -16451,13 +16451,13 @@
       </p:sp>
       <p:sp>
         <p:nvSpPr>
-          <p:cNvPr id="680" name="T"/>
-          <p:cNvSpPr txBox="1"/>
-          <p:nvPr/>
-        </p:nvSpPr>
-        <p:spPr>
-          <a:xfrm>
-            <a:off x="11191600" y="2059686"/>
+          <p:cNvPr id="692" name="T"/>
+          <p:cNvSpPr txBox="1"/>
+          <p:nvPr/>
+        </p:nvSpPr>
+        <p:spPr>
+          <a:xfrm>
+            <a:off x="11191600" y="2045398"/>
             <a:ext cx="300000" cy="164592"/>
           </a:xfrm>
           <a:prstGeom prst="rect">
@@ -16489,13 +16489,13 @@
       </p:sp>
       <p:sp>
         <p:nvSpPr>
-          <p:cNvPr id="681" name="K"/>
+          <p:cNvPr id="693" name="K"/>
           <p:cNvSpPr/>
           <p:nvPr/>
         </p:nvSpPr>
         <p:spPr>
           <a:xfrm>
-            <a:off x="7571232" y="2265426"/>
+            <a:off x="7571232" y="2222563"/>
             <a:ext cx="164592" cy="164592"/>
           </a:xfrm>
           <a:prstGeom prst="ellipse">
@@ -16511,7 +16511,7 @@
       </p:sp>
       <p:pic>
         <p:nvPicPr>
-          <p:cNvPr id="682" name="G"/>
+          <p:cNvPr id="694" name="G"/>
           <p:cNvPicPr>
             <a:picLocks noChangeAspect="1"/>
           </p:cNvPicPr>
@@ -16525,7 +16525,7 @@
         </p:blipFill>
         <p:spPr>
           <a:xfrm>
-            <a:off x="7600858" y="2295052"/>
+            <a:off x="7600858" y="2252190"/>
             <a:ext cx="105338" cy="105338"/>
           </a:xfrm>
           <a:prstGeom prst="rect">
@@ -16535,14 +16535,14 @@
       </p:pic>
       <p:sp>
         <p:nvSpPr>
-          <p:cNvPr id="683" name="T"/>
-          <p:cNvSpPr txBox="1"/>
-          <p:nvPr/>
-        </p:nvSpPr>
-        <p:spPr>
-          <a:xfrm>
-            <a:off x="7799832" y="2244852"/>
-            <a:ext cx="1100000" cy="205740"/>
+          <p:cNvPr id="695" name="T"/>
+          <p:cNvSpPr txBox="1"/>
+          <p:nvPr/>
+        </p:nvSpPr>
+        <p:spPr>
+          <a:xfrm>
+            <a:off x="7799832" y="2216277"/>
+            <a:ext cx="1100000" cy="177165"/>
           </a:xfrm>
           <a:prstGeom prst="rect">
             <a:avLst/>
@@ -16573,14 +16573,14 @@
       </p:sp>
       <p:sp>
         <p:nvSpPr>
-          <p:cNvPr id="684" name="T"/>
-          <p:cNvSpPr txBox="1"/>
-          <p:nvPr/>
-        </p:nvSpPr>
-        <p:spPr>
-          <a:xfrm>
-            <a:off x="8620000" y="2244852"/>
-            <a:ext cx="380000" cy="205740"/>
+          <p:cNvPr id="696" name="T"/>
+          <p:cNvSpPr txBox="1"/>
+          <p:nvPr/>
+        </p:nvSpPr>
+        <p:spPr>
+          <a:xfrm>
+            <a:off x="8620000" y="2216277"/>
+            <a:ext cx="380000" cy="177165"/>
           </a:xfrm>
           <a:prstGeom prst="rect">
             <a:avLst/>
@@ -16611,14 +16611,14 @@
       </p:sp>
       <p:sp>
         <p:nvSpPr>
-          <p:cNvPr id="685" name="T"/>
-          <p:cNvSpPr txBox="1"/>
-          <p:nvPr/>
-        </p:nvSpPr>
-        <p:spPr>
-          <a:xfrm>
-            <a:off x="9024000" y="2244852"/>
-            <a:ext cx="200000" cy="205740"/>
+          <p:cNvPr id="697" name="T"/>
+          <p:cNvSpPr txBox="1"/>
+          <p:nvPr/>
+        </p:nvSpPr>
+        <p:spPr>
+          <a:xfrm>
+            <a:off x="9024000" y="2216277"/>
+            <a:ext cx="200000" cy="177165"/>
           </a:xfrm>
           <a:prstGeom prst="rect">
             <a:avLst/>
@@ -16649,14 +16649,14 @@
       </p:sp>
       <p:sp>
         <p:nvSpPr>
-          <p:cNvPr id="686" name="T"/>
-          <p:cNvSpPr txBox="1"/>
-          <p:nvPr/>
-        </p:nvSpPr>
-        <p:spPr>
-          <a:xfrm>
-            <a:off x="9240000" y="2244852"/>
-            <a:ext cx="400000" cy="205740"/>
+          <p:cNvPr id="698" name="T"/>
+          <p:cNvSpPr txBox="1"/>
+          <p:nvPr/>
+        </p:nvSpPr>
+        <p:spPr>
+          <a:xfrm>
+            <a:off x="9240000" y="2216277"/>
+            <a:ext cx="400000" cy="177165"/>
           </a:xfrm>
           <a:prstGeom prst="rect">
             <a:avLst/>
@@ -16687,14 +16687,14 @@
       </p:sp>
       <p:sp>
         <p:nvSpPr>
-          <p:cNvPr id="687" name="T"/>
-          <p:cNvSpPr txBox="1"/>
-          <p:nvPr/>
-        </p:nvSpPr>
-        <p:spPr>
-          <a:xfrm>
-            <a:off x="9664000" y="2244852"/>
-            <a:ext cx="260000" cy="205740"/>
+          <p:cNvPr id="699" name="T"/>
+          <p:cNvSpPr txBox="1"/>
+          <p:nvPr/>
+        </p:nvSpPr>
+        <p:spPr>
+          <a:xfrm>
+            <a:off x="9664000" y="2216277"/>
+            <a:ext cx="260000" cy="177165"/>
           </a:xfrm>
           <a:prstGeom prst="rect">
             <a:avLst/>
@@ -16725,13 +16725,13 @@
       </p:sp>
       <p:sp>
         <p:nvSpPr>
-          <p:cNvPr id="688" name="K"/>
+          <p:cNvPr id="700" name="K"/>
           <p:cNvSpPr/>
           <p:nvPr/>
         </p:nvSpPr>
         <p:spPr>
           <a:xfrm>
-            <a:off x="9930000" y="2265426"/>
+            <a:off x="9930000" y="2222563"/>
             <a:ext cx="880000" cy="164592"/>
           </a:xfrm>
           <a:prstGeom prst="roundRect">
@@ -16751,7 +16751,7 @@
       </p:sp>
       <p:pic>
         <p:nvPicPr>
-          <p:cNvPr id="689" name="G"/>
+          <p:cNvPr id="701" name="G"/>
           <p:cNvPicPr>
             <a:picLocks noChangeAspect="1"/>
           </p:cNvPicPr>
@@ -16765,7 +16765,7 @@
         </p:blipFill>
         <p:spPr>
           <a:xfrm>
-            <a:off x="9985000" y="2297426"/>
+            <a:off x="9985000" y="2254563"/>
             <a:ext cx="100584" cy="100584"/>
           </a:xfrm>
           <a:prstGeom prst="rect">
@@ -16775,13 +16775,13 @@
       </p:pic>
       <p:sp>
         <p:nvSpPr>
-          <p:cNvPr id="690" name="T"/>
-          <p:cNvSpPr txBox="1"/>
-          <p:nvPr/>
-        </p:nvSpPr>
-        <p:spPr>
-          <a:xfrm>
-            <a:off x="10120000" y="2265426"/>
+          <p:cNvPr id="702" name="T"/>
+          <p:cNvSpPr txBox="1"/>
+          <p:nvPr/>
+        </p:nvSpPr>
+        <p:spPr>
+          <a:xfrm>
+            <a:off x="10120000" y="2222563"/>
             <a:ext cx="430000" cy="164592"/>
           </a:xfrm>
           <a:prstGeom prst="rect">
@@ -16813,13 +16813,13 @@
       </p:sp>
       <p:sp>
         <p:nvSpPr>
-          <p:cNvPr id="691" name="T"/>
-          <p:cNvSpPr txBox="1"/>
-          <p:nvPr/>
-        </p:nvSpPr>
-        <p:spPr>
-          <a:xfrm>
-            <a:off x="10571600" y="2265426"/>
+          <p:cNvPr id="703" name="T"/>
+          <p:cNvSpPr txBox="1"/>
+          <p:nvPr/>
+        </p:nvSpPr>
+        <p:spPr>
+          <a:xfrm>
+            <a:off x="10571600" y="2222563"/>
             <a:ext cx="200000" cy="164592"/>
           </a:xfrm>
           <a:prstGeom prst="rect">
@@ -16851,13 +16851,13 @@
       </p:sp>
       <p:sp>
         <p:nvSpPr>
-          <p:cNvPr id="692" name="K"/>
+          <p:cNvPr id="704" name="K"/>
           <p:cNvSpPr/>
           <p:nvPr/>
         </p:nvSpPr>
         <p:spPr>
           <a:xfrm>
-            <a:off x="10870000" y="2265426"/>
+            <a:off x="10870000" y="2222563"/>
             <a:ext cx="608463" cy="164592"/>
           </a:xfrm>
           <a:prstGeom prst="roundRect">
@@ -16877,7 +16877,7 @@
       </p:sp>
       <p:pic>
         <p:nvPicPr>
-          <p:cNvPr id="693" name="G"/>
+          <p:cNvPr id="705" name="G"/>
           <p:cNvPicPr>
             <a:picLocks noChangeAspect="1"/>
           </p:cNvPicPr>
@@ -16891,7 +16891,7 @@
         </p:blipFill>
         <p:spPr>
           <a:xfrm>
-            <a:off x="10910000" y="2292858"/>
+            <a:off x="10910000" y="2249995"/>
             <a:ext cx="109728" cy="109728"/>
           </a:xfrm>
           <a:prstGeom prst="rect">
@@ -16901,13 +16901,13 @@
       </p:pic>
       <p:sp>
         <p:nvSpPr>
-          <p:cNvPr id="694" name="T"/>
-          <p:cNvSpPr txBox="1"/>
-          <p:nvPr/>
-        </p:nvSpPr>
-        <p:spPr>
-          <a:xfrm>
-            <a:off x="11050000" y="2265426"/>
+          <p:cNvPr id="706" name="T"/>
+          <p:cNvSpPr txBox="1"/>
+          <p:nvPr/>
+        </p:nvSpPr>
+        <p:spPr>
+          <a:xfrm>
+            <a:off x="11050000" y="2222563"/>
             <a:ext cx="120000" cy="164592"/>
           </a:xfrm>
           <a:prstGeom prst="rect">
@@ -16939,13 +16939,13 @@
       </p:sp>
       <p:sp>
         <p:nvSpPr>
-          <p:cNvPr id="695" name="T"/>
-          <p:cNvSpPr txBox="1"/>
-          <p:nvPr/>
-        </p:nvSpPr>
-        <p:spPr>
-          <a:xfrm>
-            <a:off x="11191600" y="2265426"/>
+          <p:cNvPr id="707" name="T"/>
+          <p:cNvSpPr txBox="1"/>
+          <p:nvPr/>
+        </p:nvSpPr>
+        <p:spPr>
+          <a:xfrm>
+            <a:off x="11191600" y="2222563"/>
             <a:ext cx="300000" cy="164592"/>
           </a:xfrm>
           <a:prstGeom prst="rect">
@@ -16977,13 +16977,13 @@
       </p:sp>
       <p:cxnSp>
         <p:nvCxnSpPr>
-          <p:cNvPr id="696" name="L"/>
+          <p:cNvPr id="708" name="L"/>
           <p:cNvCxnSpPr/>
           <p:nvPr/>
         </p:nvCxnSpPr>
         <p:spPr>
           <a:xfrm>
-            <a:off x="7571232" y="2450592"/>
+            <a:off x="7571232" y="2393442"/>
             <a:ext cx="3907231" cy="0"/>
           </a:xfrm>
           <a:prstGeom prst="line">
@@ -16998,13 +16998,13 @@
       </p:cxnSp>
       <p:sp>
         <p:nvSpPr>
-          <p:cNvPr id="697" name="K"/>
+          <p:cNvPr id="709" name="K"/>
           <p:cNvSpPr/>
           <p:nvPr/>
         </p:nvSpPr>
         <p:spPr>
           <a:xfrm>
-            <a:off x="7571232" y="2471166"/>
+            <a:off x="7571232" y="2399728"/>
             <a:ext cx="164592" cy="164592"/>
           </a:xfrm>
           <a:prstGeom prst="ellipse">
@@ -17020,7 +17020,7 @@
       </p:sp>
       <p:pic>
         <p:nvPicPr>
-          <p:cNvPr id="698" name="G"/>
+          <p:cNvPr id="710" name="G"/>
           <p:cNvPicPr>
             <a:picLocks noChangeAspect="1"/>
           </p:cNvPicPr>
@@ -17034,7 +17034,7 @@
         </p:blipFill>
         <p:spPr>
           <a:xfrm>
-            <a:off x="7600858" y="2500792"/>
+            <a:off x="7600858" y="2429355"/>
             <a:ext cx="105338" cy="105338"/>
           </a:xfrm>
           <a:prstGeom prst="rect">
@@ -17044,14 +17044,14 @@
       </p:pic>
       <p:sp>
         <p:nvSpPr>
-          <p:cNvPr id="699" name="T"/>
-          <p:cNvSpPr txBox="1"/>
-          <p:nvPr/>
-        </p:nvSpPr>
-        <p:spPr>
-          <a:xfrm>
-            <a:off x="7799832" y="2450592"/>
-            <a:ext cx="1100000" cy="205740"/>
+          <p:cNvPr id="711" name="T"/>
+          <p:cNvSpPr txBox="1"/>
+          <p:nvPr/>
+        </p:nvSpPr>
+        <p:spPr>
+          <a:xfrm>
+            <a:off x="7799832" y="2393442"/>
+            <a:ext cx="1100000" cy="177165"/>
           </a:xfrm>
           <a:prstGeom prst="rect">
             <a:avLst/>
@@ -17082,14 +17082,14 @@
       </p:sp>
       <p:sp>
         <p:nvSpPr>
-          <p:cNvPr id="700" name="T"/>
-          <p:cNvSpPr txBox="1"/>
-          <p:nvPr/>
-        </p:nvSpPr>
-        <p:spPr>
-          <a:xfrm>
-            <a:off x="8620000" y="2450592"/>
-            <a:ext cx="380000" cy="205740"/>
+          <p:cNvPr id="712" name="T"/>
+          <p:cNvSpPr txBox="1"/>
+          <p:nvPr/>
+        </p:nvSpPr>
+        <p:spPr>
+          <a:xfrm>
+            <a:off x="8620000" y="2393442"/>
+            <a:ext cx="380000" cy="177165"/>
           </a:xfrm>
           <a:prstGeom prst="rect">
             <a:avLst/>
@@ -17120,14 +17120,14 @@
       </p:sp>
       <p:sp>
         <p:nvSpPr>
-          <p:cNvPr id="701" name="T"/>
-          <p:cNvSpPr txBox="1"/>
-          <p:nvPr/>
-        </p:nvSpPr>
-        <p:spPr>
-          <a:xfrm>
-            <a:off x="9024000" y="2450592"/>
-            <a:ext cx="200000" cy="205740"/>
+          <p:cNvPr id="713" name="T"/>
+          <p:cNvSpPr txBox="1"/>
+          <p:nvPr/>
+        </p:nvSpPr>
+        <p:spPr>
+          <a:xfrm>
+            <a:off x="9024000" y="2393442"/>
+            <a:ext cx="200000" cy="177165"/>
           </a:xfrm>
           <a:prstGeom prst="rect">
             <a:avLst/>
@@ -17158,14 +17158,14 @@
       </p:sp>
       <p:sp>
         <p:nvSpPr>
-          <p:cNvPr id="702" name="T"/>
-          <p:cNvSpPr txBox="1"/>
-          <p:nvPr/>
-        </p:nvSpPr>
-        <p:spPr>
-          <a:xfrm>
-            <a:off x="9240000" y="2450592"/>
-            <a:ext cx="400000" cy="205740"/>
+          <p:cNvPr id="714" name="T"/>
+          <p:cNvSpPr txBox="1"/>
+          <p:nvPr/>
+        </p:nvSpPr>
+        <p:spPr>
+          <a:xfrm>
+            <a:off x="9240000" y="2393442"/>
+            <a:ext cx="400000" cy="177165"/>
           </a:xfrm>
           <a:prstGeom prst="rect">
             <a:avLst/>
@@ -17196,14 +17196,14 @@
       </p:sp>
       <p:sp>
         <p:nvSpPr>
-          <p:cNvPr id="703" name="T"/>
-          <p:cNvSpPr txBox="1"/>
-          <p:nvPr/>
-        </p:nvSpPr>
-        <p:spPr>
-          <a:xfrm>
-            <a:off x="9664000" y="2450592"/>
-            <a:ext cx="260000" cy="205740"/>
+          <p:cNvPr id="715" name="T"/>
+          <p:cNvSpPr txBox="1"/>
+          <p:nvPr/>
+        </p:nvSpPr>
+        <p:spPr>
+          <a:xfrm>
+            <a:off x="9664000" y="2393442"/>
+            <a:ext cx="260000" cy="177165"/>
           </a:xfrm>
           <a:prstGeom prst="rect">
             <a:avLst/>
@@ -17234,13 +17234,13 @@
       </p:sp>
       <p:sp>
         <p:nvSpPr>
-          <p:cNvPr id="704" name="K"/>
+          <p:cNvPr id="716" name="K"/>
           <p:cNvSpPr/>
           <p:nvPr/>
         </p:nvSpPr>
         <p:spPr>
           <a:xfrm>
-            <a:off x="9930000" y="2471166"/>
+            <a:off x="9930000" y="2399728"/>
             <a:ext cx="880000" cy="164592"/>
           </a:xfrm>
           <a:prstGeom prst="roundRect">
@@ -17260,7 +17260,7 @@
       </p:sp>
       <p:pic>
         <p:nvPicPr>
-          <p:cNvPr id="705" name="G"/>
+          <p:cNvPr id="717" name="G"/>
           <p:cNvPicPr>
             <a:picLocks noChangeAspect="1"/>
           </p:cNvPicPr>
@@ -17274,7 +17274,7 @@
         </p:blipFill>
         <p:spPr>
           <a:xfrm>
-            <a:off x="9985000" y="2503166"/>
+            <a:off x="9985000" y="2431728"/>
             <a:ext cx="100584" cy="100584"/>
           </a:xfrm>
           <a:prstGeom prst="rect">
@@ -17284,13 +17284,13 @@
       </p:pic>
       <p:sp>
         <p:nvSpPr>
-          <p:cNvPr id="706" name="T"/>
-          <p:cNvSpPr txBox="1"/>
-          <p:nvPr/>
-        </p:nvSpPr>
-        <p:spPr>
-          <a:xfrm>
-            <a:off x="10120000" y="2471166"/>
+          <p:cNvPr id="718" name="T"/>
+          <p:cNvSpPr txBox="1"/>
+          <p:nvPr/>
+        </p:nvSpPr>
+        <p:spPr>
+          <a:xfrm>
+            <a:off x="10120000" y="2399728"/>
             <a:ext cx="430000" cy="164592"/>
           </a:xfrm>
           <a:prstGeom prst="rect">
@@ -17322,13 +17322,13 @@
       </p:sp>
       <p:sp>
         <p:nvSpPr>
-          <p:cNvPr id="707" name="T"/>
-          <p:cNvSpPr txBox="1"/>
-          <p:nvPr/>
-        </p:nvSpPr>
-        <p:spPr>
-          <a:xfrm>
-            <a:off x="10571600" y="2471166"/>
+          <p:cNvPr id="719" name="T"/>
+          <p:cNvSpPr txBox="1"/>
+          <p:nvPr/>
+        </p:nvSpPr>
+        <p:spPr>
+          <a:xfrm>
+            <a:off x="10571600" y="2399728"/>
             <a:ext cx="200000" cy="164592"/>
           </a:xfrm>
           <a:prstGeom prst="rect">
@@ -17360,13 +17360,13 @@
       </p:sp>
       <p:sp>
         <p:nvSpPr>
-          <p:cNvPr id="708" name="K"/>
+          <p:cNvPr id="720" name="K"/>
           <p:cNvSpPr/>
           <p:nvPr/>
         </p:nvSpPr>
         <p:spPr>
           <a:xfrm>
-            <a:off x="10870000" y="2471166"/>
+            <a:off x="10870000" y="2399728"/>
             <a:ext cx="608463" cy="164592"/>
           </a:xfrm>
           <a:prstGeom prst="roundRect">
@@ -17386,7 +17386,7 @@
       </p:sp>
       <p:pic>
         <p:nvPicPr>
-          <p:cNvPr id="709" name="G"/>
+          <p:cNvPr id="721" name="G"/>
           <p:cNvPicPr>
             <a:picLocks noChangeAspect="1"/>
           </p:cNvPicPr>
@@ -17400,7 +17400,7 @@
         </p:blipFill>
         <p:spPr>
           <a:xfrm>
-            <a:off x="10910000" y="2498598"/>
+            <a:off x="10910000" y="2427160"/>
             <a:ext cx="109728" cy="109728"/>
           </a:xfrm>
           <a:prstGeom prst="rect">
@@ -17410,13 +17410,13 @@
       </p:pic>
       <p:sp>
         <p:nvSpPr>
-          <p:cNvPr id="710" name="T"/>
-          <p:cNvSpPr txBox="1"/>
-          <p:nvPr/>
-        </p:nvSpPr>
-        <p:spPr>
-          <a:xfrm>
-            <a:off x="11050000" y="2471166"/>
+          <p:cNvPr id="722" name="T"/>
+          <p:cNvSpPr txBox="1"/>
+          <p:nvPr/>
+        </p:nvSpPr>
+        <p:spPr>
+          <a:xfrm>
+            <a:off x="11050000" y="2399728"/>
             <a:ext cx="120000" cy="164592"/>
           </a:xfrm>
           <a:prstGeom prst="rect">
@@ -17448,13 +17448,13 @@
       </p:sp>
       <p:sp>
         <p:nvSpPr>
-          <p:cNvPr id="711" name="T"/>
-          <p:cNvSpPr txBox="1"/>
-          <p:nvPr/>
-        </p:nvSpPr>
-        <p:spPr>
-          <a:xfrm>
-            <a:off x="11191600" y="2471166"/>
+          <p:cNvPr id="723" name="T"/>
+          <p:cNvSpPr txBox="1"/>
+          <p:nvPr/>
+        </p:nvSpPr>
+        <p:spPr>
+          <a:xfrm>
+            <a:off x="11191600" y="2399728"/>
             <a:ext cx="300000" cy="164592"/>
           </a:xfrm>
           <a:prstGeom prst="rect">
@@ -17486,13 +17486,13 @@
       </p:sp>
       <p:cxnSp>
         <p:nvCxnSpPr>
-          <p:cNvPr id="712" name="L"/>
+          <p:cNvPr id="724" name="L"/>
           <p:cNvCxnSpPr/>
           <p:nvPr/>
         </p:nvCxnSpPr>
         <p:spPr>
           <a:xfrm>
-            <a:off x="7571232" y="2656332"/>
+            <a:off x="7571232" y="2570607"/>
             <a:ext cx="3907231" cy="0"/>
           </a:xfrm>
           <a:prstGeom prst="line">
@@ -17507,13 +17507,13 @@
       </p:cxnSp>
       <p:sp>
         <p:nvSpPr>
-          <p:cNvPr id="713" name="K"/>
+          <p:cNvPr id="725" name="K"/>
           <p:cNvSpPr/>
           <p:nvPr/>
         </p:nvSpPr>
         <p:spPr>
           <a:xfrm>
-            <a:off x="7571232" y="2676906"/>
+            <a:off x="7571232" y="2576893"/>
             <a:ext cx="164592" cy="164592"/>
           </a:xfrm>
           <a:prstGeom prst="ellipse">
@@ -17529,7 +17529,7 @@
       </p:sp>
       <p:pic>
         <p:nvPicPr>
-          <p:cNvPr id="714" name="G"/>
+          <p:cNvPr id="726" name="G"/>
           <p:cNvPicPr>
             <a:picLocks noChangeAspect="1"/>
           </p:cNvPicPr>
@@ -17543,7 +17543,7 @@
         </p:blipFill>
         <p:spPr>
           <a:xfrm>
-            <a:off x="7600858" y="2706532"/>
+            <a:off x="7600858" y="2606520"/>
             <a:ext cx="105338" cy="105338"/>
           </a:xfrm>
           <a:prstGeom prst="rect">
@@ -17553,14 +17553,14 @@
       </p:pic>
       <p:sp>
         <p:nvSpPr>
-          <p:cNvPr id="715" name="T"/>
-          <p:cNvSpPr txBox="1"/>
-          <p:nvPr/>
-        </p:nvSpPr>
-        <p:spPr>
-          <a:xfrm>
-            <a:off x="7799832" y="2656332"/>
-            <a:ext cx="1100000" cy="205740"/>
+          <p:cNvPr id="727" name="T"/>
+          <p:cNvSpPr txBox="1"/>
+          <p:nvPr/>
+        </p:nvSpPr>
+        <p:spPr>
+          <a:xfrm>
+            <a:off x="7799832" y="2570607"/>
+            <a:ext cx="1100000" cy="177165"/>
           </a:xfrm>
           <a:prstGeom prst="rect">
             <a:avLst/>
@@ -17591,14 +17591,14 @@
       </p:sp>
       <p:sp>
         <p:nvSpPr>
-          <p:cNvPr id="716" name="T"/>
-          <p:cNvSpPr txBox="1"/>
-          <p:nvPr/>
-        </p:nvSpPr>
-        <p:spPr>
-          <a:xfrm>
-            <a:off x="8620000" y="2656332"/>
-            <a:ext cx="380000" cy="205740"/>
+          <p:cNvPr id="728" name="T"/>
+          <p:cNvSpPr txBox="1"/>
+          <p:nvPr/>
+        </p:nvSpPr>
+        <p:spPr>
+          <a:xfrm>
+            <a:off x="8620000" y="2570607"/>
+            <a:ext cx="380000" cy="177165"/>
           </a:xfrm>
           <a:prstGeom prst="rect">
             <a:avLst/>
@@ -17629,14 +17629,14 @@
       </p:sp>
       <p:sp>
         <p:nvSpPr>
-          <p:cNvPr id="717" name="T"/>
-          <p:cNvSpPr txBox="1"/>
-          <p:nvPr/>
-        </p:nvSpPr>
-        <p:spPr>
-          <a:xfrm>
-            <a:off x="9024000" y="2656332"/>
-            <a:ext cx="200000" cy="205740"/>
+          <p:cNvPr id="729" name="T"/>
+          <p:cNvSpPr txBox="1"/>
+          <p:nvPr/>
+        </p:nvSpPr>
+        <p:spPr>
+          <a:xfrm>
+            <a:off x="9024000" y="2570607"/>
+            <a:ext cx="200000" cy="177165"/>
           </a:xfrm>
           <a:prstGeom prst="rect">
             <a:avLst/>
@@ -17667,14 +17667,14 @@
       </p:sp>
       <p:sp>
         <p:nvSpPr>
-          <p:cNvPr id="718" name="T"/>
-          <p:cNvSpPr txBox="1"/>
-          <p:nvPr/>
-        </p:nvSpPr>
-        <p:spPr>
-          <a:xfrm>
-            <a:off x="9240000" y="2656332"/>
-            <a:ext cx="400000" cy="205740"/>
+          <p:cNvPr id="730" name="T"/>
+          <p:cNvSpPr txBox="1"/>
+          <p:nvPr/>
+        </p:nvSpPr>
+        <p:spPr>
+          <a:xfrm>
+            <a:off x="9240000" y="2570607"/>
+            <a:ext cx="400000" cy="177165"/>
           </a:xfrm>
           <a:prstGeom prst="rect">
             <a:avLst/>
@@ -17705,14 +17705,14 @@
       </p:sp>
       <p:sp>
         <p:nvSpPr>
-          <p:cNvPr id="719" name="T"/>
-          <p:cNvSpPr txBox="1"/>
-          <p:nvPr/>
-        </p:nvSpPr>
-        <p:spPr>
-          <a:xfrm>
-            <a:off x="9664000" y="2656332"/>
-            <a:ext cx="260000" cy="205740"/>
+          <p:cNvPr id="731" name="T"/>
+          <p:cNvSpPr txBox="1"/>
+          <p:nvPr/>
+        </p:nvSpPr>
+        <p:spPr>
+          <a:xfrm>
+            <a:off x="9664000" y="2570607"/>
+            <a:ext cx="260000" cy="177165"/>
           </a:xfrm>
           <a:prstGeom prst="rect">
             <a:avLst/>
@@ -17743,13 +17743,13 @@
       </p:sp>
       <p:sp>
         <p:nvSpPr>
-          <p:cNvPr id="720" name="K"/>
+          <p:cNvPr id="732" name="K"/>
           <p:cNvSpPr/>
           <p:nvPr/>
         </p:nvSpPr>
         <p:spPr>
           <a:xfrm>
-            <a:off x="9930000" y="2676906"/>
+            <a:off x="9930000" y="2576893"/>
             <a:ext cx="880000" cy="164592"/>
           </a:xfrm>
           <a:prstGeom prst="roundRect">
@@ -17769,7 +17769,7 @@
       </p:sp>
       <p:pic>
         <p:nvPicPr>
-          <p:cNvPr id="721" name="G"/>
+          <p:cNvPr id="733" name="G"/>
           <p:cNvPicPr>
             <a:picLocks noChangeAspect="1"/>
           </p:cNvPicPr>
@@ -17783,7 +17783,7 @@
         </p:blipFill>
         <p:spPr>
           <a:xfrm>
-            <a:off x="9985000" y="2708906"/>
+            <a:off x="9985000" y="2608893"/>
             <a:ext cx="100584" cy="100584"/>
           </a:xfrm>
           <a:prstGeom prst="rect">
@@ -17793,13 +17793,13 @@
       </p:pic>
       <p:sp>
         <p:nvSpPr>
-          <p:cNvPr id="722" name="T"/>
-          <p:cNvSpPr txBox="1"/>
-          <p:nvPr/>
-        </p:nvSpPr>
-        <p:spPr>
-          <a:xfrm>
-            <a:off x="10120000" y="2676906"/>
+          <p:cNvPr id="734" name="T"/>
+          <p:cNvSpPr txBox="1"/>
+          <p:nvPr/>
+        </p:nvSpPr>
+        <p:spPr>
+          <a:xfrm>
+            <a:off x="10120000" y="2576893"/>
             <a:ext cx="430000" cy="164592"/>
           </a:xfrm>
           <a:prstGeom prst="rect">
@@ -17831,13 +17831,13 @@
       </p:sp>
       <p:sp>
         <p:nvSpPr>
-          <p:cNvPr id="723" name="T"/>
-          <p:cNvSpPr txBox="1"/>
-          <p:nvPr/>
-        </p:nvSpPr>
-        <p:spPr>
-          <a:xfrm>
-            <a:off x="10571600" y="2676906"/>
+          <p:cNvPr id="735" name="T"/>
+          <p:cNvSpPr txBox="1"/>
+          <p:nvPr/>
+        </p:nvSpPr>
+        <p:spPr>
+          <a:xfrm>
+            <a:off x="10571600" y="2576893"/>
             <a:ext cx="200000" cy="164592"/>
           </a:xfrm>
           <a:prstGeom prst="rect">
@@ -17869,13 +17869,13 @@
       </p:sp>
       <p:sp>
         <p:nvSpPr>
-          <p:cNvPr id="724" name="K"/>
+          <p:cNvPr id="736" name="K"/>
           <p:cNvSpPr/>
           <p:nvPr/>
         </p:nvSpPr>
         <p:spPr>
           <a:xfrm>
-            <a:off x="10870000" y="2676906"/>
+            <a:off x="10870000" y="2576893"/>
             <a:ext cx="608463" cy="164592"/>
           </a:xfrm>
           <a:prstGeom prst="roundRect">
@@ -17895,7 +17895,7 @@
       </p:sp>
       <p:pic>
         <p:nvPicPr>
-          <p:cNvPr id="725" name="G"/>
+          <p:cNvPr id="737" name="G"/>
           <p:cNvPicPr>
             <a:picLocks noChangeAspect="1"/>
           </p:cNvPicPr>
@@ -17909,7 +17909,7 @@
         </p:blipFill>
         <p:spPr>
           <a:xfrm>
-            <a:off x="10910000" y="2704338"/>
+            <a:off x="10910000" y="2604325"/>
             <a:ext cx="109728" cy="109728"/>
           </a:xfrm>
           <a:prstGeom prst="rect">
@@ -17919,13 +17919,13 @@
       </p:pic>
       <p:sp>
         <p:nvSpPr>
-          <p:cNvPr id="726" name="T"/>
-          <p:cNvSpPr txBox="1"/>
-          <p:nvPr/>
-        </p:nvSpPr>
-        <p:spPr>
-          <a:xfrm>
-            <a:off x="11050000" y="2676906"/>
+          <p:cNvPr id="738" name="T"/>
+          <p:cNvSpPr txBox="1"/>
+          <p:nvPr/>
+        </p:nvSpPr>
+        <p:spPr>
+          <a:xfrm>
+            <a:off x="11050000" y="2576893"/>
             <a:ext cx="120000" cy="164592"/>
           </a:xfrm>
           <a:prstGeom prst="rect">
@@ -17957,13 +17957,13 @@
       </p:sp>
       <p:sp>
         <p:nvSpPr>
-          <p:cNvPr id="727" name="T"/>
-          <p:cNvSpPr txBox="1"/>
-          <p:nvPr/>
-        </p:nvSpPr>
-        <p:spPr>
-          <a:xfrm>
-            <a:off x="11191600" y="2676906"/>
+          <p:cNvPr id="739" name="T"/>
+          <p:cNvSpPr txBox="1"/>
+          <p:nvPr/>
+        </p:nvSpPr>
+        <p:spPr>
+          <a:xfrm>
+            <a:off x="11191600" y="2576893"/>
             <a:ext cx="300000" cy="164592"/>
           </a:xfrm>
           <a:prstGeom prst="rect">
@@ -17995,13 +17995,13 @@
       </p:sp>
       <p:cxnSp>
         <p:nvCxnSpPr>
-          <p:cNvPr id="728" name="L"/>
+          <p:cNvPr id="740" name="L"/>
           <p:cNvCxnSpPr/>
           <p:nvPr/>
         </p:nvCxnSpPr>
         <p:spPr>
           <a:xfrm>
-            <a:off x="7571232" y="2862072"/>
+            <a:off x="7571232" y="2747772"/>
             <a:ext cx="3907231" cy="0"/>
           </a:xfrm>
           <a:prstGeom prst="line">
@@ -18016,13 +18016,13 @@
       </p:cxnSp>
       <p:sp>
         <p:nvSpPr>
-          <p:cNvPr id="729" name="K"/>
+          <p:cNvPr id="741" name="K"/>
           <p:cNvSpPr/>
           <p:nvPr/>
         </p:nvSpPr>
         <p:spPr>
           <a:xfrm>
-            <a:off x="7571232" y="2882646"/>
+            <a:off x="7571232" y="2754058"/>
             <a:ext cx="164592" cy="164592"/>
           </a:xfrm>
           <a:prstGeom prst="ellipse">
@@ -18038,7 +18038,7 @@
       </p:sp>
       <p:pic>
         <p:nvPicPr>
-          <p:cNvPr id="730" name="G"/>
+          <p:cNvPr id="742" name="G"/>
           <p:cNvPicPr>
             <a:picLocks noChangeAspect="1"/>
           </p:cNvPicPr>
@@ -18052,7 +18052,7 @@
         </p:blipFill>
         <p:spPr>
           <a:xfrm>
-            <a:off x="7600858" y="2912272"/>
+            <a:off x="7600858" y="2783685"/>
             <a:ext cx="105338" cy="105338"/>
           </a:xfrm>
           <a:prstGeom prst="rect">
@@ -18062,14 +18062,14 @@
       </p:pic>
       <p:sp>
         <p:nvSpPr>
-          <p:cNvPr id="731" name="T"/>
-          <p:cNvSpPr txBox="1"/>
-          <p:nvPr/>
-        </p:nvSpPr>
-        <p:spPr>
-          <a:xfrm>
-            <a:off x="7799832" y="2862072"/>
-            <a:ext cx="1100000" cy="205740"/>
+          <p:cNvPr id="743" name="T"/>
+          <p:cNvSpPr txBox="1"/>
+          <p:nvPr/>
+        </p:nvSpPr>
+        <p:spPr>
+          <a:xfrm>
+            <a:off x="7799832" y="2747772"/>
+            <a:ext cx="1100000" cy="177165"/>
           </a:xfrm>
           <a:prstGeom prst="rect">
             <a:avLst/>
@@ -18100,14 +18100,14 @@
       </p:sp>
       <p:sp>
         <p:nvSpPr>
-          <p:cNvPr id="732" name="T"/>
-          <p:cNvSpPr txBox="1"/>
-          <p:nvPr/>
-        </p:nvSpPr>
-        <p:spPr>
-          <a:xfrm>
-            <a:off x="8620000" y="2862072"/>
-            <a:ext cx="380000" cy="205740"/>
+          <p:cNvPr id="744" name="T"/>
+          <p:cNvSpPr txBox="1"/>
+          <p:nvPr/>
+        </p:nvSpPr>
+        <p:spPr>
+          <a:xfrm>
+            <a:off x="8620000" y="2747772"/>
+            <a:ext cx="380000" cy="177165"/>
           </a:xfrm>
           <a:prstGeom prst="rect">
             <a:avLst/>
@@ -18138,14 +18138,14 @@
       </p:sp>
       <p:sp>
         <p:nvSpPr>
-          <p:cNvPr id="733" name="T"/>
-          <p:cNvSpPr txBox="1"/>
-          <p:nvPr/>
-        </p:nvSpPr>
-        <p:spPr>
-          <a:xfrm>
-            <a:off x="9024000" y="2862072"/>
-            <a:ext cx="200000" cy="205740"/>
+          <p:cNvPr id="745" name="T"/>
+          <p:cNvSpPr txBox="1"/>
+          <p:nvPr/>
+        </p:nvSpPr>
+        <p:spPr>
+          <a:xfrm>
+            <a:off x="9024000" y="2747772"/>
+            <a:ext cx="200000" cy="177165"/>
           </a:xfrm>
           <a:prstGeom prst="rect">
             <a:avLst/>
@@ -18176,14 +18176,14 @@
       </p:sp>
       <p:sp>
         <p:nvSpPr>
-          <p:cNvPr id="734" name="T"/>
-          <p:cNvSpPr txBox="1"/>
-          <p:nvPr/>
-        </p:nvSpPr>
-        <p:spPr>
-          <a:xfrm>
-            <a:off x="9240000" y="2862072"/>
-            <a:ext cx="400000" cy="205740"/>
+          <p:cNvPr id="746" name="T"/>
+          <p:cNvSpPr txBox="1"/>
+          <p:nvPr/>
+        </p:nvSpPr>
+        <p:spPr>
+          <a:xfrm>
+            <a:off x="9240000" y="2747772"/>
+            <a:ext cx="400000" cy="177165"/>
           </a:xfrm>
           <a:prstGeom prst="rect">
             <a:avLst/>
@@ -18214,14 +18214,14 @@
       </p:sp>
       <p:sp>
         <p:nvSpPr>
-          <p:cNvPr id="735" name="T"/>
-          <p:cNvSpPr txBox="1"/>
-          <p:nvPr/>
-        </p:nvSpPr>
-        <p:spPr>
-          <a:xfrm>
-            <a:off x="9664000" y="2862072"/>
-            <a:ext cx="260000" cy="205740"/>
+          <p:cNvPr id="747" name="T"/>
+          <p:cNvSpPr txBox="1"/>
+          <p:nvPr/>
+        </p:nvSpPr>
+        <p:spPr>
+          <a:xfrm>
+            <a:off x="9664000" y="2747772"/>
+            <a:ext cx="260000" cy="177165"/>
           </a:xfrm>
           <a:prstGeom prst="rect">
             <a:avLst/>
@@ -18252,13 +18252,13 @@
       </p:sp>
       <p:sp>
         <p:nvSpPr>
-          <p:cNvPr id="736" name="K"/>
+          <p:cNvPr id="748" name="K"/>
           <p:cNvSpPr/>
           <p:nvPr/>
         </p:nvSpPr>
         <p:spPr>
           <a:xfrm>
-            <a:off x="9930000" y="2882646"/>
+            <a:off x="9930000" y="2754058"/>
             <a:ext cx="880000" cy="164592"/>
           </a:xfrm>
           <a:prstGeom prst="roundRect">
@@ -18278,7 +18278,7 @@
       </p:sp>
       <p:pic>
         <p:nvPicPr>
-          <p:cNvPr id="737" name="G"/>
+          <p:cNvPr id="749" name="G"/>
           <p:cNvPicPr>
             <a:picLocks noChangeAspect="1"/>
           </p:cNvPicPr>
@@ -18292,7 +18292,7 @@
         </p:blipFill>
         <p:spPr>
           <a:xfrm>
-            <a:off x="9985000" y="2914646"/>
+            <a:off x="9985000" y="2786058"/>
             <a:ext cx="100584" cy="100584"/>
           </a:xfrm>
           <a:prstGeom prst="rect">
@@ -18302,13 +18302,13 @@
       </p:pic>
       <p:sp>
         <p:nvSpPr>
-          <p:cNvPr id="738" name="T"/>
-          <p:cNvSpPr txBox="1"/>
-          <p:nvPr/>
-        </p:nvSpPr>
-        <p:spPr>
-          <a:xfrm>
-            <a:off x="10120000" y="2882646"/>
+          <p:cNvPr id="750" name="T"/>
+          <p:cNvSpPr txBox="1"/>
+          <p:nvPr/>
+        </p:nvSpPr>
+        <p:spPr>
+          <a:xfrm>
+            <a:off x="10120000" y="2754058"/>
             <a:ext cx="430000" cy="164592"/>
           </a:xfrm>
           <a:prstGeom prst="rect">
@@ -18340,13 +18340,13 @@
       </p:sp>
       <p:sp>
         <p:nvSpPr>
-          <p:cNvPr id="739" name="T"/>
-          <p:cNvSpPr txBox="1"/>
-          <p:nvPr/>
-        </p:nvSpPr>
-        <p:spPr>
-          <a:xfrm>
-            <a:off x="10571600" y="2882646"/>
+          <p:cNvPr id="751" name="T"/>
+          <p:cNvSpPr txBox="1"/>
+          <p:nvPr/>
+        </p:nvSpPr>
+        <p:spPr>
+          <a:xfrm>
+            <a:off x="10571600" y="2754058"/>
             <a:ext cx="200000" cy="164592"/>
           </a:xfrm>
           <a:prstGeom prst="rect">
@@ -18378,13 +18378,13 @@
       </p:sp>
       <p:cxnSp>
         <p:nvCxnSpPr>
-          <p:cNvPr id="740" name="L"/>
+          <p:cNvPr id="752" name="L"/>
           <p:cNvCxnSpPr/>
           <p:nvPr/>
         </p:nvCxnSpPr>
         <p:spPr>
           <a:xfrm>
-            <a:off x="7571232" y="3067812"/>
+            <a:off x="7571232" y="2924937"/>
             <a:ext cx="3907231" cy="0"/>
           </a:xfrm>
           <a:prstGeom prst="line">
@@ -18399,13 +18399,13 @@
       </p:cxnSp>
       <p:sp>
         <p:nvSpPr>
-          <p:cNvPr id="741" name="K"/>
+          <p:cNvPr id="753" name="K"/>
           <p:cNvSpPr/>
           <p:nvPr/>
         </p:nvSpPr>
         <p:spPr>
           <a:xfrm>
-            <a:off x="7571232" y="3088386"/>
+            <a:off x="7571232" y="2931223"/>
             <a:ext cx="164592" cy="164592"/>
           </a:xfrm>
           <a:prstGeom prst="ellipse">
@@ -18421,7 +18421,7 @@
       </p:sp>
       <p:pic>
         <p:nvPicPr>
-          <p:cNvPr id="742" name="G"/>
+          <p:cNvPr id="754" name="G"/>
           <p:cNvPicPr>
             <a:picLocks noChangeAspect="1"/>
           </p:cNvPicPr>
@@ -18435,7 +18435,7 @@
         </p:blipFill>
         <p:spPr>
           <a:xfrm>
-            <a:off x="7600858" y="3118012"/>
+            <a:off x="7600858" y="2960850"/>
             <a:ext cx="105338" cy="105338"/>
           </a:xfrm>
           <a:prstGeom prst="rect">
@@ -18445,14 +18445,14 @@
       </p:pic>
       <p:sp>
         <p:nvSpPr>
-          <p:cNvPr id="743" name="T"/>
-          <p:cNvSpPr txBox="1"/>
-          <p:nvPr/>
-        </p:nvSpPr>
-        <p:spPr>
-          <a:xfrm>
-            <a:off x="7799832" y="3067812"/>
-            <a:ext cx="1100000" cy="205740"/>
+          <p:cNvPr id="755" name="T"/>
+          <p:cNvSpPr txBox="1"/>
+          <p:nvPr/>
+        </p:nvSpPr>
+        <p:spPr>
+          <a:xfrm>
+            <a:off x="7799832" y="2924937"/>
+            <a:ext cx="1100000" cy="177165"/>
           </a:xfrm>
           <a:prstGeom prst="rect">
             <a:avLst/>
@@ -18483,14 +18483,14 @@
       </p:sp>
       <p:sp>
         <p:nvSpPr>
-          <p:cNvPr id="744" name="T"/>
-          <p:cNvSpPr txBox="1"/>
-          <p:nvPr/>
-        </p:nvSpPr>
-        <p:spPr>
-          <a:xfrm>
-            <a:off x="8620000" y="3067812"/>
-            <a:ext cx="380000" cy="205740"/>
+          <p:cNvPr id="756" name="T"/>
+          <p:cNvSpPr txBox="1"/>
+          <p:nvPr/>
+        </p:nvSpPr>
+        <p:spPr>
+          <a:xfrm>
+            <a:off x="8620000" y="2924937"/>
+            <a:ext cx="380000" cy="177165"/>
           </a:xfrm>
           <a:prstGeom prst="rect">
             <a:avLst/>
@@ -18521,14 +18521,14 @@
       </p:sp>
       <p:sp>
         <p:nvSpPr>
-          <p:cNvPr id="745" name="T"/>
-          <p:cNvSpPr txBox="1"/>
-          <p:nvPr/>
-        </p:nvSpPr>
-        <p:spPr>
-          <a:xfrm>
-            <a:off x="9024000" y="3067812"/>
-            <a:ext cx="200000" cy="205740"/>
+          <p:cNvPr id="757" name="T"/>
+          <p:cNvSpPr txBox="1"/>
+          <p:nvPr/>
+        </p:nvSpPr>
+        <p:spPr>
+          <a:xfrm>
+            <a:off x="9024000" y="2924937"/>
+            <a:ext cx="200000" cy="177165"/>
           </a:xfrm>
           <a:prstGeom prst="rect">
             <a:avLst/>
@@ -18559,14 +18559,14 @@
       </p:sp>
       <p:sp>
         <p:nvSpPr>
-          <p:cNvPr id="746" name="T"/>
-          <p:cNvSpPr txBox="1"/>
-          <p:nvPr/>
-        </p:nvSpPr>
-        <p:spPr>
-          <a:xfrm>
-            <a:off x="9240000" y="3067812"/>
-            <a:ext cx="400000" cy="205740"/>
+          <p:cNvPr id="758" name="T"/>
+          <p:cNvSpPr txBox="1"/>
+          <p:nvPr/>
+        </p:nvSpPr>
+        <p:spPr>
+          <a:xfrm>
+            <a:off x="9240000" y="2924937"/>
+            <a:ext cx="400000" cy="177165"/>
           </a:xfrm>
           <a:prstGeom prst="rect">
             <a:avLst/>
@@ -18597,14 +18597,14 @@
       </p:sp>
       <p:sp>
         <p:nvSpPr>
-          <p:cNvPr id="747" name="T"/>
-          <p:cNvSpPr txBox="1"/>
-          <p:nvPr/>
-        </p:nvSpPr>
-        <p:spPr>
-          <a:xfrm>
-            <a:off x="9664000" y="3067812"/>
-            <a:ext cx="260000" cy="205740"/>
+          <p:cNvPr id="759" name="T"/>
+          <p:cNvSpPr txBox="1"/>
+          <p:nvPr/>
+        </p:nvSpPr>
+        <p:spPr>
+          <a:xfrm>
+            <a:off x="9664000" y="2924937"/>
+            <a:ext cx="260000" cy="177165"/>
           </a:xfrm>
           <a:prstGeom prst="rect">
             <a:avLst/>
@@ -18635,13 +18635,13 @@
       </p:sp>
       <p:sp>
         <p:nvSpPr>
-          <p:cNvPr id="748" name="K"/>
+          <p:cNvPr id="760" name="K"/>
           <p:cNvSpPr/>
           <p:nvPr/>
         </p:nvSpPr>
         <p:spPr>
           <a:xfrm>
-            <a:off x="9930000" y="3088386"/>
+            <a:off x="9930000" y="2931223"/>
             <a:ext cx="880000" cy="164592"/>
           </a:xfrm>
           <a:prstGeom prst="roundRect">
@@ -18661,7 +18661,7 @@
       </p:sp>
       <p:pic>
         <p:nvPicPr>
-          <p:cNvPr id="749" name="G"/>
+          <p:cNvPr id="761" name="G"/>
           <p:cNvPicPr>
             <a:picLocks noChangeAspect="1"/>
           </p:cNvPicPr>
@@ -18675,7 +18675,7 @@
         </p:blipFill>
         <p:spPr>
           <a:xfrm>
-            <a:off x="9985000" y="3120386"/>
+            <a:off x="9985000" y="2963223"/>
             <a:ext cx="100584" cy="100584"/>
           </a:xfrm>
           <a:prstGeom prst="rect">
@@ -18685,13 +18685,13 @@
       </p:pic>
       <p:sp>
         <p:nvSpPr>
-          <p:cNvPr id="750" name="T"/>
-          <p:cNvSpPr txBox="1"/>
-          <p:nvPr/>
-        </p:nvSpPr>
-        <p:spPr>
-          <a:xfrm>
-            <a:off x="10120000" y="3088386"/>
+          <p:cNvPr id="762" name="T"/>
+          <p:cNvSpPr txBox="1"/>
+          <p:nvPr/>
+        </p:nvSpPr>
+        <p:spPr>
+          <a:xfrm>
+            <a:off x="10120000" y="2931223"/>
             <a:ext cx="430000" cy="164592"/>
           </a:xfrm>
           <a:prstGeom prst="rect">
@@ -18723,13 +18723,13 @@
       </p:sp>
       <p:sp>
         <p:nvSpPr>
-          <p:cNvPr id="751" name="T"/>
-          <p:cNvSpPr txBox="1"/>
-          <p:nvPr/>
-        </p:nvSpPr>
-        <p:spPr>
-          <a:xfrm>
-            <a:off x="10571600" y="3088386"/>
+          <p:cNvPr id="763" name="T"/>
+          <p:cNvSpPr txBox="1"/>
+          <p:nvPr/>
+        </p:nvSpPr>
+        <p:spPr>
+          <a:xfrm>
+            <a:off x="10571600" y="2931223"/>
             <a:ext cx="200000" cy="164592"/>
           </a:xfrm>
           <a:prstGeom prst="rect">
@@ -18761,13 +18761,13 @@
       </p:sp>
       <p:cxnSp>
         <p:nvCxnSpPr>
-          <p:cNvPr id="752" name="L"/>
+          <p:cNvPr id="764" name="L"/>
           <p:cNvCxnSpPr/>
           <p:nvPr/>
         </p:nvCxnSpPr>
         <p:spPr>
           <a:xfrm>
-            <a:off x="7571232" y="3273552"/>
+            <a:off x="7571232" y="3102102"/>
             <a:ext cx="3907231" cy="0"/>
           </a:xfrm>
           <a:prstGeom prst="line">
@@ -18782,13 +18782,13 @@
       </p:cxnSp>
       <p:sp>
         <p:nvSpPr>
-          <p:cNvPr id="753" name="K"/>
+          <p:cNvPr id="765" name="K"/>
           <p:cNvSpPr/>
           <p:nvPr/>
         </p:nvSpPr>
         <p:spPr>
           <a:xfrm>
-            <a:off x="7571232" y="3294126"/>
+            <a:off x="7571232" y="3108388"/>
             <a:ext cx="164592" cy="164592"/>
           </a:xfrm>
           <a:prstGeom prst="ellipse">
@@ -18804,7 +18804,7 @@
       </p:sp>
       <p:pic>
         <p:nvPicPr>
-          <p:cNvPr id="754" name="G"/>
+          <p:cNvPr id="766" name="G"/>
           <p:cNvPicPr>
             <a:picLocks noChangeAspect="1"/>
           </p:cNvPicPr>
@@ -18818,7 +18818,7 @@
         </p:blipFill>
         <p:spPr>
           <a:xfrm>
-            <a:off x="7600858" y="3323752"/>
+            <a:off x="7600858" y="3138015"/>
             <a:ext cx="105338" cy="105338"/>
           </a:xfrm>
           <a:prstGeom prst="rect">
@@ -18828,14 +18828,14 @@
       </p:pic>
       <p:sp>
         <p:nvSpPr>
-          <p:cNvPr id="755" name="T"/>
-          <p:cNvSpPr txBox="1"/>
-          <p:nvPr/>
-        </p:nvSpPr>
-        <p:spPr>
-          <a:xfrm>
-            <a:off x="7799832" y="3273552"/>
-            <a:ext cx="1100000" cy="205740"/>
+          <p:cNvPr id="767" name="T"/>
+          <p:cNvSpPr txBox="1"/>
+          <p:nvPr/>
+        </p:nvSpPr>
+        <p:spPr>
+          <a:xfrm>
+            <a:off x="7799832" y="3102102"/>
+            <a:ext cx="1100000" cy="177165"/>
           </a:xfrm>
           <a:prstGeom prst="rect">
             <a:avLst/>
@@ -18866,14 +18866,14 @@
       </p:sp>
       <p:sp>
         <p:nvSpPr>
-          <p:cNvPr id="756" name="T"/>
-          <p:cNvSpPr txBox="1"/>
-          <p:nvPr/>
-        </p:nvSpPr>
-        <p:spPr>
-          <a:xfrm>
-            <a:off x="8620000" y="3273552"/>
-            <a:ext cx="380000" cy="205740"/>
+          <p:cNvPr id="768" name="T"/>
+          <p:cNvSpPr txBox="1"/>
+          <p:nvPr/>
+        </p:nvSpPr>
+        <p:spPr>
+          <a:xfrm>
+            <a:off x="8620000" y="3102102"/>
+            <a:ext cx="380000" cy="177165"/>
           </a:xfrm>
           <a:prstGeom prst="rect">
             <a:avLst/>
@@ -18904,14 +18904,14 @@
       </p:sp>
       <p:sp>
         <p:nvSpPr>
-          <p:cNvPr id="757" name="T"/>
-          <p:cNvSpPr txBox="1"/>
-          <p:nvPr/>
-        </p:nvSpPr>
-        <p:spPr>
-          <a:xfrm>
-            <a:off x="9024000" y="3273552"/>
-            <a:ext cx="200000" cy="205740"/>
+          <p:cNvPr id="769" name="T"/>
+          <p:cNvSpPr txBox="1"/>
+          <p:nvPr/>
+        </p:nvSpPr>
+        <p:spPr>
+          <a:xfrm>
+            <a:off x="9024000" y="3102102"/>
+            <a:ext cx="200000" cy="177165"/>
           </a:xfrm>
           <a:prstGeom prst="rect">
             <a:avLst/>
@@ -18942,14 +18942,14 @@
       </p:sp>
       <p:sp>
         <p:nvSpPr>
-          <p:cNvPr id="758" name="T"/>
-          <p:cNvSpPr txBox="1"/>
-          <p:nvPr/>
-        </p:nvSpPr>
-        <p:spPr>
-          <a:xfrm>
-            <a:off x="9240000" y="3273552"/>
-            <a:ext cx="400000" cy="205740"/>
+          <p:cNvPr id="770" name="T"/>
+          <p:cNvSpPr txBox="1"/>
+          <p:nvPr/>
+        </p:nvSpPr>
+        <p:spPr>
+          <a:xfrm>
+            <a:off x="9240000" y="3102102"/>
+            <a:ext cx="400000" cy="177165"/>
           </a:xfrm>
           <a:prstGeom prst="rect">
             <a:avLst/>
@@ -18980,14 +18980,14 @@
       </p:sp>
       <p:sp>
         <p:nvSpPr>
-          <p:cNvPr id="759" name="T"/>
-          <p:cNvSpPr txBox="1"/>
-          <p:nvPr/>
-        </p:nvSpPr>
-        <p:spPr>
-          <a:xfrm>
-            <a:off x="9664000" y="3273552"/>
-            <a:ext cx="260000" cy="205740"/>
+          <p:cNvPr id="771" name="T"/>
+          <p:cNvSpPr txBox="1"/>
+          <p:nvPr/>
+        </p:nvSpPr>
+        <p:spPr>
+          <a:xfrm>
+            <a:off x="9664000" y="3102102"/>
+            <a:ext cx="260000" cy="177165"/>
           </a:xfrm>
           <a:prstGeom prst="rect">
             <a:avLst/>
@@ -19018,13 +19018,13 @@
       </p:sp>
       <p:sp>
         <p:nvSpPr>
-          <p:cNvPr id="760" name="K"/>
+          <p:cNvPr id="772" name="K"/>
           <p:cNvSpPr/>
           <p:nvPr/>
         </p:nvSpPr>
         <p:spPr>
           <a:xfrm>
-            <a:off x="9930000" y="3294126"/>
+            <a:off x="9930000" y="3108388"/>
             <a:ext cx="880000" cy="164592"/>
           </a:xfrm>
           <a:prstGeom prst="roundRect">
@@ -19044,7 +19044,7 @@
       </p:sp>
       <p:pic>
         <p:nvPicPr>
-          <p:cNvPr id="761" name="G"/>
+          <p:cNvPr id="773" name="G"/>
           <p:cNvPicPr>
             <a:picLocks noChangeAspect="1"/>
           </p:cNvPicPr>
@@ -19058,7 +19058,7 @@
         </p:blipFill>
         <p:spPr>
           <a:xfrm>
-            <a:off x="9985000" y="3326126"/>
+            <a:off x="9985000" y="3140388"/>
             <a:ext cx="100584" cy="100584"/>
           </a:xfrm>
           <a:prstGeom prst="rect">
@@ -19068,13 +19068,13 @@
       </p:pic>
       <p:sp>
         <p:nvSpPr>
-          <p:cNvPr id="762" name="T"/>
-          <p:cNvSpPr txBox="1"/>
-          <p:nvPr/>
-        </p:nvSpPr>
-        <p:spPr>
-          <a:xfrm>
-            <a:off x="10120000" y="3294126"/>
+          <p:cNvPr id="774" name="T"/>
+          <p:cNvSpPr txBox="1"/>
+          <p:nvPr/>
+        </p:nvSpPr>
+        <p:spPr>
+          <a:xfrm>
+            <a:off x="10120000" y="3108388"/>
             <a:ext cx="430000" cy="164592"/>
           </a:xfrm>
           <a:prstGeom prst="rect">
@@ -19106,13 +19106,13 @@
       </p:sp>
       <p:sp>
         <p:nvSpPr>
-          <p:cNvPr id="763" name="T"/>
-          <p:cNvSpPr txBox="1"/>
-          <p:nvPr/>
-        </p:nvSpPr>
-        <p:spPr>
-          <a:xfrm>
-            <a:off x="10571600" y="3294126"/>
+          <p:cNvPr id="775" name="T"/>
+          <p:cNvSpPr txBox="1"/>
+          <p:nvPr/>
+        </p:nvSpPr>
+        <p:spPr>
+          <a:xfrm>
+            <a:off x="10571600" y="3108388"/>
             <a:ext cx="200000" cy="164592"/>
           </a:xfrm>
           <a:prstGeom prst="rect">
@@ -19144,13 +19144,13 @@
       </p:sp>
       <p:cxnSp>
         <p:nvCxnSpPr>
-          <p:cNvPr id="764" name="L"/>
+          <p:cNvPr id="776" name="L"/>
           <p:cNvCxnSpPr/>
           <p:nvPr/>
         </p:nvCxnSpPr>
         <p:spPr>
           <a:xfrm>
-            <a:off x="7571232" y="3479292"/>
+            <a:off x="7571232" y="3279267"/>
             <a:ext cx="3907231" cy="0"/>
           </a:xfrm>
           <a:prstGeom prst="line">
@@ -19165,13 +19165,13 @@
       </p:cxnSp>
       <p:sp>
         <p:nvSpPr>
-          <p:cNvPr id="765" name="K"/>
+          <p:cNvPr id="777" name="K"/>
           <p:cNvSpPr/>
           <p:nvPr/>
         </p:nvSpPr>
         <p:spPr>
           <a:xfrm>
-            <a:off x="7571232" y="3499866"/>
+            <a:off x="7571232" y="3285553"/>
             <a:ext cx="164592" cy="164592"/>
           </a:xfrm>
           <a:prstGeom prst="ellipse">
@@ -19187,7 +19187,7 @@
       </p:sp>
       <p:pic>
         <p:nvPicPr>
-          <p:cNvPr id="766" name="G"/>
+          <p:cNvPr id="778" name="G"/>
           <p:cNvPicPr>
             <a:picLocks noChangeAspect="1"/>
           </p:cNvPicPr>
@@ -19201,7 +19201,7 @@
         </p:blipFill>
         <p:spPr>
           <a:xfrm>
-            <a:off x="7600858" y="3529492"/>
+            <a:off x="7600858" y="3315180"/>
             <a:ext cx="105338" cy="105338"/>
           </a:xfrm>
           <a:prstGeom prst="rect">
@@ -19211,14 +19211,14 @@
       </p:pic>
       <p:sp>
         <p:nvSpPr>
-          <p:cNvPr id="767" name="T"/>
-          <p:cNvSpPr txBox="1"/>
-          <p:nvPr/>
-        </p:nvSpPr>
-        <p:spPr>
-          <a:xfrm>
-            <a:off x="7799832" y="3479292"/>
-            <a:ext cx="1100000" cy="205740"/>
+          <p:cNvPr id="779" name="T"/>
+          <p:cNvSpPr txBox="1"/>
+          <p:nvPr/>
+        </p:nvSpPr>
+        <p:spPr>
+          <a:xfrm>
+            <a:off x="7799832" y="3279267"/>
+            <a:ext cx="1100000" cy="177165"/>
           </a:xfrm>
           <a:prstGeom prst="rect">
             <a:avLst/>
@@ -19249,14 +19249,14 @@
       </p:sp>
       <p:sp>
         <p:nvSpPr>
-          <p:cNvPr id="768" name="T"/>
-          <p:cNvSpPr txBox="1"/>
-          <p:nvPr/>
-        </p:nvSpPr>
-        <p:spPr>
-          <a:xfrm>
-            <a:off x="8620000" y="3479292"/>
-            <a:ext cx="380000" cy="205740"/>
+          <p:cNvPr id="780" name="T"/>
+          <p:cNvSpPr txBox="1"/>
+          <p:nvPr/>
+        </p:nvSpPr>
+        <p:spPr>
+          <a:xfrm>
+            <a:off x="8620000" y="3279267"/>
+            <a:ext cx="380000" cy="177165"/>
           </a:xfrm>
           <a:prstGeom prst="rect">
             <a:avLst/>
@@ -19287,14 +19287,14 @@
       </p:sp>
       <p:sp>
         <p:nvSpPr>
-          <p:cNvPr id="769" name="T"/>
-          <p:cNvSpPr txBox="1"/>
-          <p:nvPr/>
-        </p:nvSpPr>
-        <p:spPr>
-          <a:xfrm>
-            <a:off x="9024000" y="3479292"/>
-            <a:ext cx="200000" cy="205740"/>
+          <p:cNvPr id="781" name="T"/>
+          <p:cNvSpPr txBox="1"/>
+          <p:nvPr/>
+        </p:nvSpPr>
+        <p:spPr>
+          <a:xfrm>
+            <a:off x="9024000" y="3279267"/>
+            <a:ext cx="200000" cy="177165"/>
           </a:xfrm>
           <a:prstGeom prst="rect">
             <a:avLst/>
@@ -19325,14 +19325,14 @@
       </p:sp>
       <p:sp>
         <p:nvSpPr>
-          <p:cNvPr id="770" name="T"/>
-          <p:cNvSpPr txBox="1"/>
-          <p:nvPr/>
-        </p:nvSpPr>
-        <p:spPr>
-          <a:xfrm>
-            <a:off x="9240000" y="3479292"/>
-            <a:ext cx="400000" cy="205740"/>
+          <p:cNvPr id="782" name="T"/>
+          <p:cNvSpPr txBox="1"/>
+          <p:nvPr/>
+        </p:nvSpPr>
+        <p:spPr>
+          <a:xfrm>
+            <a:off x="9240000" y="3279267"/>
+            <a:ext cx="400000" cy="177165"/>
           </a:xfrm>
           <a:prstGeom prst="rect">
             <a:avLst/>
@@ -19363,14 +19363,14 @@
       </p:sp>
       <p:sp>
         <p:nvSpPr>
-          <p:cNvPr id="771" name="T"/>
-          <p:cNvSpPr txBox="1"/>
-          <p:nvPr/>
-        </p:nvSpPr>
-        <p:spPr>
-          <a:xfrm>
-            <a:off x="9664000" y="3479292"/>
-            <a:ext cx="260000" cy="205740"/>
+          <p:cNvPr id="783" name="T"/>
+          <p:cNvSpPr txBox="1"/>
+          <p:nvPr/>
+        </p:nvSpPr>
+        <p:spPr>
+          <a:xfrm>
+            <a:off x="9664000" y="3279267"/>
+            <a:ext cx="260000" cy="177165"/>
           </a:xfrm>
           <a:prstGeom prst="rect">
             <a:avLst/>
@@ -19401,13 +19401,13 @@
       </p:sp>
       <p:sp>
         <p:nvSpPr>
-          <p:cNvPr id="772" name="K"/>
+          <p:cNvPr id="784" name="K"/>
           <p:cNvSpPr/>
           <p:nvPr/>
         </p:nvSpPr>
         <p:spPr>
           <a:xfrm>
-            <a:off x="9930000" y="3499866"/>
+            <a:off x="9930000" y="3285553"/>
             <a:ext cx="1548463" cy="164592"/>
           </a:xfrm>
           <a:prstGeom prst="roundRect">
@@ -19427,7 +19427,7 @@
       </p:sp>
       <p:pic>
         <p:nvPicPr>
-          <p:cNvPr id="773" name="G"/>
+          <p:cNvPr id="785" name="G"/>
           <p:cNvPicPr>
             <a:picLocks noChangeAspect="1"/>
           </p:cNvPicPr>
@@ -19441,7 +19441,7 @@
         </p:blipFill>
         <p:spPr>
           <a:xfrm>
-            <a:off x="9985000" y="3531866"/>
+            <a:off x="9985000" y="3317553"/>
             <a:ext cx="100584" cy="100584"/>
           </a:xfrm>
           <a:prstGeom prst="rect">
@@ -19451,13 +19451,13 @@
       </p:pic>
       <p:sp>
         <p:nvSpPr>
-          <p:cNvPr id="774" name="T"/>
-          <p:cNvSpPr txBox="1"/>
-          <p:nvPr/>
-        </p:nvSpPr>
-        <p:spPr>
-          <a:xfrm>
-            <a:off x="10120000" y="3499866"/>
+          <p:cNvPr id="786" name="T"/>
+          <p:cNvSpPr txBox="1"/>
+          <p:nvPr/>
+        </p:nvSpPr>
+        <p:spPr>
+          <a:xfrm>
+            <a:off x="10120000" y="3285553"/>
             <a:ext cx="1318463" cy="164592"/>
           </a:xfrm>
           <a:prstGeom prst="rect">
@@ -19489,14 +19489,14 @@
       </p:sp>
       <p:sp>
         <p:nvSpPr>
-          <p:cNvPr id="775" name="K"/>
+          <p:cNvPr id="787" name="K"/>
           <p:cNvSpPr/>
           <p:nvPr/>
         </p:nvSpPr>
         <p:spPr>
           <a:xfrm>
-            <a:off x="7406640" y="3867912"/>
-            <a:ext cx="4236415" cy="2139696"/>
+            <a:off x="7406640" y="3639312"/>
+            <a:ext cx="4236415" cy="2368296"/>
           </a:xfrm>
           <a:prstGeom prst="roundRect">
             <a:avLst>
@@ -19515,13 +19515,13 @@
       </p:sp>
       <p:sp>
         <p:nvSpPr>
-          <p:cNvPr id="776" name="K"/>
+          <p:cNvPr id="788" name="K"/>
           <p:cNvSpPr/>
           <p:nvPr/>
         </p:nvSpPr>
         <p:spPr>
           <a:xfrm>
-            <a:off x="7406640" y="3867912"/>
+            <a:off x="7406640" y="3639312"/>
             <a:ext cx="4236415" cy="365760"/>
           </a:xfrm>
           <a:prstGeom prst="roundRect">
@@ -19539,13 +19539,13 @@
       </p:sp>
       <p:sp>
         <p:nvSpPr>
-          <p:cNvPr id="777" name="K"/>
+          <p:cNvPr id="789" name="K"/>
           <p:cNvSpPr/>
           <p:nvPr/>
         </p:nvSpPr>
         <p:spPr>
           <a:xfrm>
-            <a:off x="7406640" y="4087368"/>
+            <a:off x="7406640" y="3858768"/>
             <a:ext cx="4236415" cy="146304"/>
           </a:xfrm>
           <a:prstGeom prst="rect">
@@ -19561,13 +19561,13 @@
       </p:sp>
       <p:sp>
         <p:nvSpPr>
-          <p:cNvPr id="778" name="K"/>
+          <p:cNvPr id="790" name="K"/>
           <p:cNvSpPr/>
           <p:nvPr/>
         </p:nvSpPr>
         <p:spPr>
           <a:xfrm>
-            <a:off x="7534656" y="3904488"/>
+            <a:off x="7534656" y="3675888"/>
             <a:ext cx="292608" cy="292608"/>
           </a:xfrm>
           <a:prstGeom prst="ellipse">
@@ -19583,7 +19583,7 @@
       </p:sp>
       <p:pic>
         <p:nvPicPr>
-          <p:cNvPr id="779" name="G"/>
+          <p:cNvPr id="791" name="G"/>
           <p:cNvPicPr>
             <a:picLocks noChangeAspect="1"/>
           </p:cNvPicPr>
@@ -19597,7 +19597,7 @@
         </p:blipFill>
         <p:spPr>
           <a:xfrm>
-            <a:off x="7589520" y="3959352"/>
+            <a:off x="7589520" y="3730752"/>
             <a:ext cx="182880" cy="182880"/>
           </a:xfrm>
           <a:prstGeom prst="rect">
@@ -19607,13 +19607,13 @@
       </p:pic>
       <p:sp>
         <p:nvSpPr>
-          <p:cNvPr id="780" name="T"/>
-          <p:cNvSpPr txBox="1"/>
-          <p:nvPr/>
-        </p:nvSpPr>
-        <p:spPr>
-          <a:xfrm>
-            <a:off x="7909560" y="3867912"/>
+          <p:cNvPr id="792" name="T"/>
+          <p:cNvSpPr txBox="1"/>
+          <p:nvPr/>
+        </p:nvSpPr>
+        <p:spPr>
+          <a:xfrm>
+            <a:off x="7909560" y="3639312"/>
             <a:ext cx="3136415" cy="365760"/>
           </a:xfrm>
           <a:prstGeom prst="rect">
@@ -19645,13 +19645,13 @@
       </p:sp>
       <p:sp>
         <p:nvSpPr>
-          <p:cNvPr id="781" name="T"/>
-          <p:cNvSpPr txBox="1"/>
-          <p:nvPr/>
-        </p:nvSpPr>
-        <p:spPr>
-          <a:xfrm>
-            <a:off x="11002975" y="3867912"/>
+          <p:cNvPr id="793" name="T"/>
+          <p:cNvSpPr txBox="1"/>
+          <p:nvPr/>
+        </p:nvSpPr>
+        <p:spPr>
+          <a:xfrm>
+            <a:off x="11002975" y="3639312"/>
             <a:ext cx="512064" cy="365760"/>
           </a:xfrm>
           <a:prstGeom prst="rect">
@@ -19684,6 +19684,342 @@
       <p:sp>
         <p:nvSpPr>
           <p:cNvPr id="564" name="K"/>
+          <p:cNvSpPr/>
+          <p:nvPr/>
+        </p:nvSpPr>
+        <p:spPr>
+          <a:xfrm>
+            <a:off x="7589520" y="4078224"/>
+            <a:ext cx="128016" cy="128016"/>
+          </a:xfrm>
+          <a:prstGeom prst="ellipse">
+            <a:avLst/>
+          </a:prstGeom>
+          <a:solidFill>
+            <a:srgbClr val="5B7A99"/>
+          </a:solidFill>
+          <a:ln>
+            <a:noFill/>
+          </a:ln>
+        </p:spPr>
+      </p:sp>
+      <p:pic>
+        <p:nvPicPr>
+          <p:cNvPr id="565" name="G"/>
+          <p:cNvPicPr>
+            <a:picLocks noChangeAspect="1"/>
+          </p:cNvPicPr>
+          <p:nvPr/>
+        </p:nvPicPr>
+        <p:blipFill>
+          <a:blip r:embed="rIdM6"/>
+          <a:stretch>
+            <a:fillRect/>
+          </a:stretch>
+        </p:blipFill>
+        <p:spPr>
+          <a:xfrm>
+            <a:off x="7616952" y="4105656"/>
+            <a:ext cx="73152" cy="73152"/>
+          </a:xfrm>
+          <a:prstGeom prst="rect">
+            <a:avLst/>
+          </a:prstGeom>
+        </p:spPr>
+      </p:pic>
+      <p:sp>
+        <p:nvSpPr>
+          <p:cNvPr id="566" name="T"/>
+          <p:cNvSpPr txBox="1"/>
+          <p:nvPr/>
+        </p:nvSpPr>
+        <p:spPr>
+          <a:xfrm>
+            <a:off x="7754112" y="4050792"/>
+            <a:ext cx="480000" cy="182880"/>
+          </a:xfrm>
+          <a:prstGeom prst="rect">
+            <a:avLst/>
+          </a:prstGeom>
+          <a:noFill/>
+        </p:spPr>
+        <p:txBody>
+          <a:bodyPr wrap="none" lIns="0" tIns="0" rIns="0" bIns="0" anchor="ctr"/>
+          <a:lstStyle/>
+          <a:p>
+            <a:pPr algn="l">
+              <a:buNone/>
+            </a:pPr>
+            <a:r>
+              <a:rPr lang="id-ID" sz="700" dirty="0">
+                <a:solidFill>
+                  <a:srgbClr val="2E3440"/>
+                </a:solidFill>
+                <a:latin typeface="Roboto"/>
+                <a:ea typeface="Roboto"/>
+                <a:cs typeface="Roboto"/>
+              </a:rPr>
+              <a:t>Gempa bumi</a:t>
+            </a:r>
+            <a:endParaRPr lang="id-ID" sz="700"/>
+          </a:p>
+        </p:txBody>
+      </p:sp>
+      <p:sp>
+        <p:nvSpPr>
+          <p:cNvPr id="567" name="K"/>
+          <p:cNvSpPr/>
+          <p:nvPr/>
+        </p:nvSpPr>
+        <p:spPr>
+          <a:xfrm>
+            <a:off x="8371272" y="4078224"/>
+            <a:ext cx="128016" cy="128016"/>
+          </a:xfrm>
+          <a:prstGeom prst="ellipse">
+            <a:avLst/>
+          </a:prstGeom>
+          <a:solidFill>
+            <a:srgbClr val="A23B2A"/>
+          </a:solidFill>
+          <a:ln>
+            <a:noFill/>
+          </a:ln>
+        </p:spPr>
+      </p:sp>
+      <p:pic>
+        <p:nvPicPr>
+          <p:cNvPr id="568" name="G"/>
+          <p:cNvPicPr>
+            <a:picLocks noChangeAspect="1"/>
+          </p:cNvPicPr>
+          <p:nvPr/>
+        </p:nvPicPr>
+        <p:blipFill>
+          <a:blip r:embed="rIdM12"/>
+          <a:stretch>
+            <a:fillRect/>
+          </a:stretch>
+        </p:blipFill>
+        <p:spPr>
+          <a:xfrm>
+            <a:off x="8398704" y="4105656"/>
+            <a:ext cx="73152" cy="73152"/>
+          </a:xfrm>
+          <a:prstGeom prst="rect">
+            <a:avLst/>
+          </a:prstGeom>
+        </p:spPr>
+      </p:pic>
+      <p:sp>
+        <p:nvSpPr>
+          <p:cNvPr id="569" name="T"/>
+          <p:cNvSpPr txBox="1"/>
+          <p:nvPr/>
+        </p:nvSpPr>
+        <p:spPr>
+          <a:xfrm>
+            <a:off x="8535864" y="4050792"/>
+            <a:ext cx="624000" cy="182880"/>
+          </a:xfrm>
+          <a:prstGeom prst="rect">
+            <a:avLst/>
+          </a:prstGeom>
+          <a:noFill/>
+        </p:spPr>
+        <p:txBody>
+          <a:bodyPr wrap="none" lIns="0" tIns="0" rIns="0" bIns="0" anchor="ctr"/>
+          <a:lstStyle/>
+          <a:p>
+            <a:pPr algn="l">
+              <a:buNone/>
+            </a:pPr>
+            <a:r>
+              <a:rPr lang="id-ID" sz="700" dirty="0">
+                <a:solidFill>
+                  <a:srgbClr val="2E3440"/>
+                </a:solidFill>
+                <a:latin typeface="Roboto"/>
+                <a:ea typeface="Roboto"/>
+                <a:cs typeface="Roboto"/>
+              </a:rPr>
+              <a:t>Kebakaran TPA</a:t>
+            </a:r>
+            <a:endParaRPr lang="id-ID" sz="700"/>
+          </a:p>
+        </p:txBody>
+      </p:sp>
+      <p:sp>
+        <p:nvSpPr>
+          <p:cNvPr id="570" name="K"/>
+          <p:cNvSpPr/>
+          <p:nvPr/>
+        </p:nvSpPr>
+        <p:spPr>
+          <a:xfrm>
+            <a:off x="9297024" y="4078224"/>
+            <a:ext cx="128016" cy="128016"/>
+          </a:xfrm>
+          <a:prstGeom prst="ellipse">
+            <a:avLst/>
+          </a:prstGeom>
+          <a:solidFill>
+            <a:srgbClr val="2F6FB5"/>
+          </a:solidFill>
+          <a:ln>
+            <a:noFill/>
+          </a:ln>
+        </p:spPr>
+      </p:sp>
+      <p:pic>
+        <p:nvPicPr>
+          <p:cNvPr id="571" name="G"/>
+          <p:cNvPicPr>
+            <a:picLocks noChangeAspect="1"/>
+          </p:cNvPicPr>
+          <p:nvPr/>
+        </p:nvPicPr>
+        <p:blipFill>
+          <a:blip r:embed="rIdM16"/>
+          <a:stretch>
+            <a:fillRect/>
+          </a:stretch>
+        </p:blipFill>
+        <p:spPr>
+          <a:xfrm>
+            <a:off x="9324456" y="4105656"/>
+            <a:ext cx="73152" cy="73152"/>
+          </a:xfrm>
+          <a:prstGeom prst="rect">
+            <a:avLst/>
+          </a:prstGeom>
+        </p:spPr>
+      </p:pic>
+      <p:sp>
+        <p:nvSpPr>
+          <p:cNvPr id="572" name="T"/>
+          <p:cNvSpPr txBox="1"/>
+          <p:nvPr/>
+        </p:nvSpPr>
+        <p:spPr>
+          <a:xfrm>
+            <a:off x="9461616" y="4050792"/>
+            <a:ext cx="288000" cy="182880"/>
+          </a:xfrm>
+          <a:prstGeom prst="rect">
+            <a:avLst/>
+          </a:prstGeom>
+          <a:noFill/>
+        </p:spPr>
+        <p:txBody>
+          <a:bodyPr wrap="none" lIns="0" tIns="0" rIns="0" bIns="0" anchor="ctr"/>
+          <a:lstStyle/>
+          <a:p>
+            <a:pPr algn="l">
+              <a:buNone/>
+            </a:pPr>
+            <a:r>
+              <a:rPr lang="id-ID" sz="700" dirty="0">
+                <a:solidFill>
+                  <a:srgbClr val="2E3440"/>
+                </a:solidFill>
+                <a:latin typeface="Roboto"/>
+                <a:ea typeface="Roboto"/>
+                <a:cs typeface="Roboto"/>
+              </a:rPr>
+              <a:t>Banjir</a:t>
+            </a:r>
+            <a:endParaRPr lang="id-ID" sz="700"/>
+          </a:p>
+        </p:txBody>
+      </p:sp>
+      <p:sp>
+        <p:nvSpPr>
+          <p:cNvPr id="573" name="K"/>
+          <p:cNvSpPr/>
+          <p:nvPr/>
+        </p:nvSpPr>
+        <p:spPr>
+          <a:xfrm>
+            <a:off x="9886776" y="4078224"/>
+            <a:ext cx="128016" cy="128016"/>
+          </a:xfrm>
+          <a:prstGeom prst="ellipse">
+            <a:avLst/>
+          </a:prstGeom>
+          <a:solidFill>
+            <a:srgbClr val="0E7490"/>
+          </a:solidFill>
+          <a:ln>
+            <a:noFill/>
+          </a:ln>
+        </p:spPr>
+      </p:sp>
+      <p:pic>
+        <p:nvPicPr>
+          <p:cNvPr id="574" name="G"/>
+          <p:cNvPicPr>
+            <a:picLocks noChangeAspect="1"/>
+          </p:cNvPicPr>
+          <p:nvPr/>
+        </p:nvPicPr>
+        <p:blipFill>
+          <a:blip r:embed="rIdM19"/>
+          <a:stretch>
+            <a:fillRect/>
+          </a:stretch>
+        </p:blipFill>
+        <p:spPr>
+          <a:xfrm>
+            <a:off x="9914208" y="4105656"/>
+            <a:ext cx="73152" cy="73152"/>
+          </a:xfrm>
+          <a:prstGeom prst="rect">
+            <a:avLst/>
+          </a:prstGeom>
+        </p:spPr>
+      </p:pic>
+      <p:sp>
+        <p:nvSpPr>
+          <p:cNvPr id="575" name="T"/>
+          <p:cNvSpPr txBox="1"/>
+          <p:nvPr/>
+        </p:nvSpPr>
+        <p:spPr>
+          <a:xfrm>
+            <a:off x="10051368" y="4050792"/>
+            <a:ext cx="624000" cy="182880"/>
+          </a:xfrm>
+          <a:prstGeom prst="rect">
+            <a:avLst/>
+          </a:prstGeom>
+          <a:noFill/>
+        </p:spPr>
+        <p:txBody>
+          <a:bodyPr wrap="none" lIns="0" tIns="0" rIns="0" bIns="0" anchor="ctr"/>
+          <a:lstStyle/>
+          <a:p>
+            <a:pPr algn="l">
+              <a:buNone/>
+            </a:pPr>
+            <a:r>
+              <a:rPr lang="id-ID" sz="700" dirty="0">
+                <a:solidFill>
+                  <a:srgbClr val="2E3440"/>
+                </a:solidFill>
+                <a:latin typeface="Roboto"/>
+                <a:ea typeface="Roboto"/>
+                <a:cs typeface="Roboto"/>
+              </a:rPr>
+              <a:t>Angin kencang</a:t>
+            </a:r>
+            <a:endParaRPr lang="id-ID" sz="700"/>
+          </a:p>
+        </p:txBody>
+      </p:sp>
+      <p:sp>
+        <p:nvSpPr>
+          <p:cNvPr id="576" name="K"/>
           <p:cNvSpPr/>
           <p:nvPr/>
         </p:nvSpPr>
@@ -19705,7 +20041,7 @@
       </p:sp>
       <p:pic>
         <p:nvPicPr>
-          <p:cNvPr id="565" name="G"/>
+          <p:cNvPr id="577" name="G"/>
           <p:cNvPicPr>
             <a:picLocks noChangeAspect="1"/>
           </p:cNvPicPr>
@@ -19729,7 +20065,7 @@
       </p:pic>
       <p:sp>
         <p:nvSpPr>
-          <p:cNvPr id="566" name="K"/>
+          <p:cNvPr id="578" name="K"/>
           <p:cNvSpPr/>
           <p:nvPr/>
         </p:nvSpPr>
@@ -19751,7 +20087,7 @@
       </p:sp>
       <p:pic>
         <p:nvPicPr>
-          <p:cNvPr id="567" name="G"/>
+          <p:cNvPr id="579" name="G"/>
           <p:cNvPicPr>
             <a:picLocks noChangeAspect="1"/>
           </p:cNvPicPr>
@@ -19775,7 +20111,7 @@
       </p:pic>
       <p:sp>
         <p:nvSpPr>
-          <p:cNvPr id="568" name="T"/>
+          <p:cNvPr id="580" name="T"/>
           <p:cNvSpPr txBox="1"/>
           <p:nvPr/>
         </p:nvSpPr>
@@ -19813,7 +20149,7 @@
       </p:sp>
       <p:sp>
         <p:nvSpPr>
-          <p:cNvPr id="581" name="K"/>
+          <p:cNvPr id="593" name="K"/>
           <p:cNvSpPr/>
           <p:nvPr/>
         </p:nvSpPr>
@@ -19837,7 +20173,7 @@
       </p:sp>
       <p:pic>
         <p:nvPicPr>
-          <p:cNvPr id="582" name="G"/>
+          <p:cNvPr id="594" name="G"/>
           <p:cNvPicPr>
             <a:picLocks noChangeAspect="1"/>
           </p:cNvPicPr>
@@ -19861,7 +20197,7 @@
       </p:pic>
       <p:sp>
         <p:nvSpPr>
-          <p:cNvPr id="583" name="T"/>
+          <p:cNvPr id="595" name="T"/>
           <p:cNvSpPr txBox="1"/>
           <p:nvPr/>
         </p:nvSpPr>
@@ -19899,7 +20235,7 @@
       </p:sp>
       <p:sp>
         <p:nvSpPr>
-          <p:cNvPr id="584" name="K"/>
+          <p:cNvPr id="596" name="K"/>
           <p:cNvSpPr/>
           <p:nvPr/>
         </p:nvSpPr>
@@ -19923,7 +20259,7 @@
       </p:sp>
       <p:pic>
         <p:nvPicPr>
-          <p:cNvPr id="585" name="G"/>
+          <p:cNvPr id="597" name="G"/>
           <p:cNvPicPr>
             <a:picLocks noChangeAspect="1"/>
           </p:cNvPicPr>
@@ -19947,7 +20283,7 @@
       </p:pic>
       <p:sp>
         <p:nvSpPr>
-          <p:cNvPr id="586" name="T"/>
+          <p:cNvPr id="598" name="T"/>
           <p:cNvSpPr txBox="1"/>
           <p:nvPr/>
         </p:nvSpPr>
@@ -19985,7 +20321,7 @@
       </p:sp>
       <p:sp>
         <p:nvSpPr>
-          <p:cNvPr id="587" name="K"/>
+          <p:cNvPr id="599" name="K"/>
           <p:cNvSpPr/>
           <p:nvPr/>
         </p:nvSpPr>
@@ -20009,7 +20345,7 @@
       </p:sp>
       <p:pic>
         <p:nvPicPr>
-          <p:cNvPr id="588" name="G"/>
+          <p:cNvPr id="600" name="G"/>
           <p:cNvPicPr>
             <a:picLocks noChangeAspect="1"/>
           </p:cNvPicPr>
@@ -20033,7 +20369,7 @@
       </p:pic>
       <p:sp>
         <p:nvSpPr>
-          <p:cNvPr id="589" name="T"/>
+          <p:cNvPr id="601" name="T"/>
           <p:cNvSpPr txBox="1"/>
           <p:nvPr/>
         </p:nvSpPr>
@@ -20071,7 +20407,7 @@
       </p:sp>
       <p:sp>
         <p:nvSpPr>
-          <p:cNvPr id="590" name="K"/>
+          <p:cNvPr id="602" name="K"/>
           <p:cNvSpPr/>
           <p:nvPr/>
         </p:nvSpPr>
@@ -20095,7 +20431,7 @@
       </p:sp>
       <p:pic>
         <p:nvPicPr>
-          <p:cNvPr id="591" name="G"/>
+          <p:cNvPr id="603" name="G"/>
           <p:cNvPicPr>
             <a:picLocks noChangeAspect="1"/>
           </p:cNvPicPr>
@@ -20119,7 +20455,7 @@
       </p:pic>
       <p:sp>
         <p:nvSpPr>
-          <p:cNvPr id="592" name="T"/>
+          <p:cNvPr id="604" name="T"/>
           <p:cNvSpPr txBox="1"/>
           <p:nvPr/>
         </p:nvSpPr>
@@ -20157,7 +20493,7 @@
       </p:sp>
       <p:sp>
         <p:nvSpPr>
-          <p:cNvPr id="593" name="K"/>
+          <p:cNvPr id="605" name="K"/>
           <p:cNvSpPr/>
           <p:nvPr/>
         </p:nvSpPr>
@@ -20179,7 +20515,7 @@
       </p:sp>
       <p:pic>
         <p:nvPicPr>
-          <p:cNvPr id="594" name="G"/>
+          <p:cNvPr id="606" name="G"/>
           <p:cNvPicPr>
             <a:picLocks noChangeAspect="1"/>
           </p:cNvPicPr>
@@ -20203,7 +20539,7 @@
       </p:pic>
       <p:sp>
         <p:nvSpPr>
-          <p:cNvPr id="595" name="K"/>
+          <p:cNvPr id="607" name="K"/>
           <p:cNvSpPr/>
           <p:nvPr/>
         </p:nvSpPr>
@@ -20225,7 +20561,7 @@
       </p:sp>
       <p:pic>
         <p:nvPicPr>
-          <p:cNvPr id="596" name="G"/>
+          <p:cNvPr id="608" name="G"/>
           <p:cNvPicPr>
             <a:picLocks noChangeAspect="1"/>
           </p:cNvPicPr>
@@ -20249,7 +20585,7 @@
       </p:pic>
       <p:sp>
         <p:nvSpPr>
-          <p:cNvPr id="597" name="T"/>
+          <p:cNvPr id="609" name="T"/>
           <p:cNvSpPr txBox="1"/>
           <p:nvPr/>
         </p:nvSpPr>
@@ -20298,7 +20634,7 @@
       </p:sp>
       <p:sp>
         <p:nvSpPr>
-          <p:cNvPr id="598" name="K"/>
+          <p:cNvPr id="610" name="K"/>
           <p:cNvSpPr/>
           <p:nvPr/>
         </p:nvSpPr>
@@ -20322,7 +20658,7 @@
       </p:sp>
       <p:pic>
         <p:nvPicPr>
-          <p:cNvPr id="599" name="G"/>
+          <p:cNvPr id="611" name="G"/>
           <p:cNvPicPr>
             <a:picLocks noChangeAspect="1"/>
           </p:cNvPicPr>
@@ -20346,7 +20682,7 @@
       </p:pic>
       <p:sp>
         <p:nvSpPr>
-          <p:cNvPr id="600" name="T"/>
+          <p:cNvPr id="612" name="T"/>
           <p:cNvSpPr txBox="1"/>
           <p:nvPr/>
         </p:nvSpPr>
@@ -20384,7 +20720,7 @@
       </p:sp>
       <p:sp>
         <p:nvSpPr>
-          <p:cNvPr id="601" name="K"/>
+          <p:cNvPr id="613" name="K"/>
           <p:cNvSpPr/>
           <p:nvPr/>
         </p:nvSpPr>
@@ -20408,7 +20744,7 @@
       </p:sp>
       <p:pic>
         <p:nvPicPr>
-          <p:cNvPr id="602" name="G"/>
+          <p:cNvPr id="614" name="G"/>
           <p:cNvPicPr>
             <a:picLocks noChangeAspect="1"/>
           </p:cNvPicPr>
@@ -20432,7 +20768,7 @@
       </p:pic>
       <p:sp>
         <p:nvSpPr>
-          <p:cNvPr id="603" name="T"/>
+          <p:cNvPr id="615" name="T"/>
           <p:cNvSpPr txBox="1"/>
           <p:nvPr/>
         </p:nvSpPr>
@@ -20470,7 +20806,7 @@
       </p:sp>
       <p:sp>
         <p:nvSpPr>
-          <p:cNvPr id="604" name="K"/>
+          <p:cNvPr id="616" name="K"/>
           <p:cNvSpPr/>
           <p:nvPr/>
         </p:nvSpPr>
@@ -20492,7 +20828,7 @@
       </p:sp>
       <p:pic>
         <p:nvPicPr>
-          <p:cNvPr id="605" name="G"/>
+          <p:cNvPr id="617" name="G"/>
           <p:cNvPicPr>
             <a:picLocks noChangeAspect="1"/>
           </p:cNvPicPr>
@@ -20516,7 +20852,7 @@
       </p:pic>
       <p:sp>
         <p:nvSpPr>
-          <p:cNvPr id="606" name="K"/>
+          <p:cNvPr id="618" name="K"/>
           <p:cNvSpPr/>
           <p:nvPr/>
         </p:nvSpPr>
@@ -20538,7 +20874,7 @@
       </p:sp>
       <p:pic>
         <p:nvPicPr>
-          <p:cNvPr id="607" name="G"/>
+          <p:cNvPr id="619" name="G"/>
           <p:cNvPicPr>
             <a:picLocks noChangeAspect="1"/>
           </p:cNvPicPr>
@@ -20562,7 +20898,7 @@
       </p:pic>
       <p:sp>
         <p:nvSpPr>
-          <p:cNvPr id="608" name="T"/>
+          <p:cNvPr id="620" name="T"/>
           <p:cNvSpPr txBox="1"/>
           <p:nvPr/>
         </p:nvSpPr>
@@ -20611,7 +20947,7 @@
       </p:sp>
       <p:sp>
         <p:nvSpPr>
-          <p:cNvPr id="609" name="K"/>
+          <p:cNvPr id="621" name="K"/>
           <p:cNvSpPr/>
           <p:nvPr/>
         </p:nvSpPr>
@@ -20635,7 +20971,7 @@
       </p:sp>
       <p:pic>
         <p:nvPicPr>
-          <p:cNvPr id="610" name="G"/>
+          <p:cNvPr id="622" name="G"/>
           <p:cNvPicPr>
             <a:picLocks noChangeAspect="1"/>
           </p:cNvPicPr>
@@ -20659,7 +20995,7 @@
       </p:pic>
       <p:sp>
         <p:nvSpPr>
-          <p:cNvPr id="611" name="T"/>
+          <p:cNvPr id="623" name="T"/>
           <p:cNvSpPr txBox="1"/>
           <p:nvPr/>
         </p:nvSpPr>
@@ -20697,7 +21033,7 @@
       </p:sp>
       <p:sp>
         <p:nvSpPr>
-          <p:cNvPr id="612" name="K"/>
+          <p:cNvPr id="624" name="K"/>
           <p:cNvSpPr/>
           <p:nvPr/>
         </p:nvSpPr>
@@ -20721,7 +21057,7 @@
       </p:sp>
       <p:pic>
         <p:nvPicPr>
-          <p:cNvPr id="613" name="G"/>
+          <p:cNvPr id="625" name="G"/>
           <p:cNvPicPr>
             <a:picLocks noChangeAspect="1"/>
           </p:cNvPicPr>
@@ -20745,7 +21081,7 @@
       </p:pic>
       <p:sp>
         <p:nvSpPr>
-          <p:cNvPr id="614" name="T"/>
+          <p:cNvPr id="626" name="T"/>
           <p:cNvSpPr txBox="1"/>
           <p:nvPr/>
         </p:nvSpPr>
@@ -20783,7 +21119,7 @@
       </p:sp>
       <p:sp>
         <p:nvSpPr>
-          <p:cNvPr id="615" name="K"/>
+          <p:cNvPr id="627" name="K"/>
           <p:cNvSpPr/>
           <p:nvPr/>
         </p:nvSpPr>
@@ -20805,7 +21141,7 @@
       </p:sp>
       <p:pic>
         <p:nvPicPr>
-          <p:cNvPr id="616" name="G"/>
+          <p:cNvPr id="628" name="G"/>
           <p:cNvPicPr>
             <a:picLocks noChangeAspect="1"/>
           </p:cNvPicPr>
@@ -20829,7 +21165,7 @@
       </p:pic>
       <p:sp>
         <p:nvSpPr>
-          <p:cNvPr id="617" name="K"/>
+          <p:cNvPr id="629" name="K"/>
           <p:cNvSpPr/>
           <p:nvPr/>
         </p:nvSpPr>
@@ -20851,7 +21187,7 @@
       </p:sp>
       <p:pic>
         <p:nvPicPr>
-          <p:cNvPr id="618" name="G"/>
+          <p:cNvPr id="630" name="G"/>
           <p:cNvPicPr>
             <a:picLocks noChangeAspect="1"/>
           </p:cNvPicPr>
@@ -20875,7 +21211,7 @@
       </p:pic>
       <p:sp>
         <p:nvSpPr>
-          <p:cNvPr id="619" name="T"/>
+          <p:cNvPr id="631" name="T"/>
           <p:cNvSpPr txBox="1"/>
           <p:nvPr/>
         </p:nvSpPr>
@@ -20924,7 +21260,7 @@
       </p:sp>
       <p:sp>
         <p:nvSpPr>
-          <p:cNvPr id="620" name="K"/>
+          <p:cNvPr id="632" name="K"/>
           <p:cNvSpPr/>
           <p:nvPr/>
         </p:nvSpPr>
@@ -20948,7 +21284,7 @@
       </p:sp>
       <p:pic>
         <p:nvPicPr>
-          <p:cNvPr id="621" name="G"/>
+          <p:cNvPr id="633" name="G"/>
           <p:cNvPicPr>
             <a:picLocks noChangeAspect="1"/>
           </p:cNvPicPr>
@@ -20972,7 +21308,7 @@
       </p:pic>
       <p:sp>
         <p:nvSpPr>
-          <p:cNvPr id="622" name="T"/>
+          <p:cNvPr id="634" name="T"/>
           <p:cNvSpPr txBox="1"/>
           <p:nvPr/>
         </p:nvSpPr>
@@ -21010,7 +21346,7 @@
       </p:sp>
       <p:sp>
         <p:nvSpPr>
-          <p:cNvPr id="623" name="K"/>
+          <p:cNvPr id="635" name="K"/>
           <p:cNvSpPr/>
           <p:nvPr/>
         </p:nvSpPr>
@@ -21034,7 +21370,7 @@
       </p:sp>
       <p:pic>
         <p:nvPicPr>
-          <p:cNvPr id="624" name="G"/>
+          <p:cNvPr id="636" name="G"/>
           <p:cNvPicPr>
             <a:picLocks noChangeAspect="1"/>
           </p:cNvPicPr>
@@ -21058,7 +21394,7 @@
       </p:pic>
       <p:sp>
         <p:nvSpPr>
-          <p:cNvPr id="625" name="T"/>
+          <p:cNvPr id="637" name="T"/>
           <p:cNvSpPr txBox="1"/>
           <p:nvPr/>
         </p:nvSpPr>
@@ -21096,7 +21432,7 @@
       </p:sp>
       <p:sp>
         <p:nvSpPr>
-          <p:cNvPr id="626" name="K"/>
+          <p:cNvPr id="638" name="K"/>
           <p:cNvSpPr/>
           <p:nvPr/>
         </p:nvSpPr>
@@ -21118,7 +21454,7 @@
       </p:sp>
       <p:pic>
         <p:nvPicPr>
-          <p:cNvPr id="627" name="G"/>
+          <p:cNvPr id="639" name="G"/>
           <p:cNvPicPr>
             <a:picLocks noChangeAspect="1"/>
           </p:cNvPicPr>
@@ -21142,7 +21478,7 @@
       </p:pic>
       <p:sp>
         <p:nvSpPr>
-          <p:cNvPr id="628" name="K"/>
+          <p:cNvPr id="640" name="K"/>
           <p:cNvSpPr/>
           <p:nvPr/>
         </p:nvSpPr>
@@ -21164,7 +21500,7 @@
       </p:sp>
       <p:pic>
         <p:nvPicPr>
-          <p:cNvPr id="629" name="G"/>
+          <p:cNvPr id="641" name="G"/>
           <p:cNvPicPr>
             <a:picLocks noChangeAspect="1"/>
           </p:cNvPicPr>
@@ -21188,7 +21524,7 @@
       </p:pic>
       <p:sp>
         <p:nvSpPr>
-          <p:cNvPr id="630" name="T"/>
+          <p:cNvPr id="642" name="T"/>
           <p:cNvSpPr txBox="1"/>
           <p:nvPr/>
         </p:nvSpPr>
@@ -21237,7 +21573,7 @@
       </p:sp>
       <p:sp>
         <p:nvSpPr>
-          <p:cNvPr id="631" name="K"/>
+          <p:cNvPr id="643" name="K"/>
           <p:cNvSpPr/>
           <p:nvPr/>
         </p:nvSpPr>
@@ -21261,7 +21597,7 @@
       </p:sp>
       <p:pic>
         <p:nvPicPr>
-          <p:cNvPr id="632" name="G"/>
+          <p:cNvPr id="644" name="G"/>
           <p:cNvPicPr>
             <a:picLocks noChangeAspect="1"/>
           </p:cNvPicPr>
@@ -21285,7 +21621,7 @@
       </p:pic>
       <p:sp>
         <p:nvSpPr>
-          <p:cNvPr id="633" name="T"/>
+          <p:cNvPr id="645" name="T"/>
           <p:cNvSpPr txBox="1"/>
           <p:nvPr/>
         </p:nvSpPr>
@@ -21323,7 +21659,7 @@
       </p:sp>
       <p:sp>
         <p:nvSpPr>
-          <p:cNvPr id="634" name="K"/>
+          <p:cNvPr id="646" name="K"/>
           <p:cNvSpPr/>
           <p:nvPr/>
         </p:nvSpPr>
@@ -21347,7 +21683,7 @@
       </p:sp>
       <p:pic>
         <p:nvPicPr>
-          <p:cNvPr id="635" name="G"/>
+          <p:cNvPr id="647" name="G"/>
           <p:cNvPicPr>
             <a:picLocks noChangeAspect="1"/>
           </p:cNvPicPr>
@@ -21371,7 +21707,7 @@
       </p:pic>
       <p:sp>
         <p:nvSpPr>
-          <p:cNvPr id="636" name="T"/>
+          <p:cNvPr id="648" name="T"/>
           <p:cNvSpPr txBox="1"/>
           <p:nvPr/>
         </p:nvSpPr>
@@ -21409,7 +21745,7 @@
       </p:sp>
       <p:sp>
         <p:nvSpPr>
-          <p:cNvPr id="637" name="K"/>
+          <p:cNvPr id="649" name="K"/>
           <p:cNvSpPr/>
           <p:nvPr/>
         </p:nvSpPr>
@@ -21431,7 +21767,7 @@
       </p:sp>
       <p:pic>
         <p:nvPicPr>
-          <p:cNvPr id="638" name="G"/>
+          <p:cNvPr id="650" name="G"/>
           <p:cNvPicPr>
             <a:picLocks noChangeAspect="1"/>
           </p:cNvPicPr>
@@ -21455,7 +21791,7 @@
       </p:pic>
       <p:sp>
         <p:nvSpPr>
-          <p:cNvPr id="639" name="K"/>
+          <p:cNvPr id="651" name="K"/>
           <p:cNvSpPr/>
           <p:nvPr/>
         </p:nvSpPr>
@@ -21477,7 +21813,7 @@
       </p:sp>
       <p:pic>
         <p:nvPicPr>
-          <p:cNvPr id="640" name="G"/>
+          <p:cNvPr id="652" name="G"/>
           <p:cNvPicPr>
             <a:picLocks noChangeAspect="1"/>
           </p:cNvPicPr>
@@ -21501,7 +21837,7 @@
       </p:pic>
       <p:sp>
         <p:nvSpPr>
-          <p:cNvPr id="641" name="T"/>
+          <p:cNvPr id="653" name="T"/>
           <p:cNvSpPr txBox="1"/>
           <p:nvPr/>
         </p:nvSpPr>
@@ -21550,7 +21886,7 @@
       </p:sp>
       <p:sp>
         <p:nvSpPr>
-          <p:cNvPr id="642" name="K"/>
+          <p:cNvPr id="654" name="K"/>
           <p:cNvSpPr/>
           <p:nvPr/>
         </p:nvSpPr>
@@ -21574,7 +21910,7 @@
       </p:sp>
       <p:pic>
         <p:nvPicPr>
-          <p:cNvPr id="643" name="G"/>
+          <p:cNvPr id="655" name="G"/>
           <p:cNvPicPr>
             <a:picLocks noChangeAspect="1"/>
           </p:cNvPicPr>
@@ -21598,7 +21934,7 @@
       </p:pic>
       <p:sp>
         <p:nvSpPr>
-          <p:cNvPr id="644" name="T"/>
+          <p:cNvPr id="656" name="T"/>
           <p:cNvSpPr txBox="1"/>
           <p:nvPr/>
         </p:nvSpPr>
@@ -21636,7 +21972,7 @@
       </p:sp>
       <p:sp>
         <p:nvSpPr>
-          <p:cNvPr id="645" name="K"/>
+          <p:cNvPr id="657" name="K"/>
           <p:cNvSpPr/>
           <p:nvPr/>
         </p:nvSpPr>
@@ -21658,7 +21994,7 @@
       </p:sp>
       <p:pic>
         <p:nvPicPr>
-          <p:cNvPr id="646" name="G"/>
+          <p:cNvPr id="658" name="G"/>
           <p:cNvPicPr>
             <a:picLocks noChangeAspect="1"/>
           </p:cNvPicPr>
@@ -21682,7 +22018,7 @@
       </p:pic>
       <p:sp>
         <p:nvSpPr>
-          <p:cNvPr id="647" name="K"/>
+          <p:cNvPr id="659" name="K"/>
           <p:cNvSpPr/>
           <p:nvPr/>
         </p:nvSpPr>
@@ -21704,7 +22040,7 @@
       </p:sp>
       <p:pic>
         <p:nvPicPr>
-          <p:cNvPr id="648" name="G"/>
+          <p:cNvPr id="660" name="G"/>
           <p:cNvPicPr>
             <a:picLocks noChangeAspect="1"/>
           </p:cNvPicPr>
@@ -21728,7 +22064,7 @@
       </p:pic>
       <p:sp>
         <p:nvSpPr>
-          <p:cNvPr id="649" name="T"/>
+          <p:cNvPr id="661" name="T"/>
           <p:cNvSpPr txBox="1"/>
           <p:nvPr/>
         </p:nvSpPr>
@@ -21777,7 +22113,7 @@
       </p:sp>
       <p:sp>
         <p:nvSpPr>
-          <p:cNvPr id="650" name="K"/>
+          <p:cNvPr id="662" name="K"/>
           <p:cNvSpPr/>
           <p:nvPr/>
         </p:nvSpPr>
@@ -21801,7 +22137,7 @@
       </p:sp>
       <p:pic>
         <p:nvPicPr>
-          <p:cNvPr id="651" name="G"/>
+          <p:cNvPr id="663" name="G"/>
           <p:cNvPicPr>
             <a:picLocks noChangeAspect="1"/>
           </p:cNvPicPr>
@@ -21825,7 +22161,7 @@
       </p:pic>
       <p:sp>
         <p:nvSpPr>
-          <p:cNvPr id="652" name="T"/>
+          <p:cNvPr id="664" name="T"/>
           <p:cNvSpPr txBox="1"/>
           <p:nvPr/>
         </p:nvSpPr>
@@ -21863,7 +22199,7 @@
       </p:sp>
       <p:sp>
         <p:nvSpPr>
-          <p:cNvPr id="653" name="K"/>
+          <p:cNvPr id="665" name="K"/>
           <p:cNvSpPr/>
           <p:nvPr/>
         </p:nvSpPr>
@@ -21887,7 +22223,7 @@
       </p:sp>
       <p:pic>
         <p:nvPicPr>
-          <p:cNvPr id="654" name="G"/>
+          <p:cNvPr id="666" name="G"/>
           <p:cNvPicPr>
             <a:picLocks noChangeAspect="1"/>
           </p:cNvPicPr>
@@ -21911,7 +22247,7 @@
       </p:pic>
       <p:sp>
         <p:nvSpPr>
-          <p:cNvPr id="655" name="T"/>
+          <p:cNvPr id="667" name="T"/>
           <p:cNvSpPr txBox="1"/>
           <p:nvPr/>
         </p:nvSpPr>
@@ -21949,7 +22285,7 @@
       </p:sp>
       <p:sp>
         <p:nvSpPr>
-          <p:cNvPr id="782" name="K"/>
+          <p:cNvPr id="794" name="K"/>
           <p:cNvSpPr/>
           <p:nvPr/>
         </p:nvSpPr>
@@ -21973,7 +22309,7 @@
       </p:sp>
       <p:sp>
         <p:nvSpPr>
-          <p:cNvPr id="783" name="T"/>
+          <p:cNvPr id="795" name="T"/>
           <p:cNvSpPr txBox="1"/>
           <p:nvPr/>
         </p:nvSpPr>
@@ -22011,7 +22347,7 @@
       </p:sp>
       <p:sp>
         <p:nvSpPr>
-          <p:cNvPr id="784" name="K"/>
+          <p:cNvPr id="796" name="K"/>
           <p:cNvSpPr/>
           <p:nvPr/>
         </p:nvSpPr>
@@ -22033,7 +22369,7 @@
       </p:sp>
       <p:pic>
         <p:nvPicPr>
-          <p:cNvPr id="785" name="G"/>
+          <p:cNvPr id="797" name="G"/>
           <p:cNvPicPr>
             <a:picLocks noChangeAspect="1"/>
           </p:cNvPicPr>
@@ -22057,7 +22393,7 @@
       </p:pic>
       <p:sp>
         <p:nvSpPr>
-          <p:cNvPr id="786" name="T"/>
+          <p:cNvPr id="798" name="T"/>
           <p:cNvSpPr txBox="1"/>
           <p:nvPr/>
         </p:nvSpPr>
@@ -22095,7 +22431,7 @@
       </p:sp>
       <p:sp>
         <p:nvSpPr>
-          <p:cNvPr id="787" name="K"/>
+          <p:cNvPr id="799" name="K"/>
           <p:cNvSpPr/>
           <p:nvPr/>
         </p:nvSpPr>
@@ -22117,7 +22453,7 @@
       </p:sp>
       <p:pic>
         <p:nvPicPr>
-          <p:cNvPr id="788" name="G"/>
+          <p:cNvPr id="800" name="G"/>
           <p:cNvPicPr>
             <a:picLocks noChangeAspect="1"/>
           </p:cNvPicPr>
@@ -22141,7 +22477,7 @@
       </p:pic>
       <p:sp>
         <p:nvSpPr>
-          <p:cNvPr id="789" name="T"/>
+          <p:cNvPr id="801" name="T"/>
           <p:cNvSpPr txBox="1"/>
           <p:nvPr/>
         </p:nvSpPr>

</xml_diff>